<commit_message>
feat: update deck with RAG/multi-model arch + add demo & technical scripts
</commit_message>
<xml_diff>
--- a/presentation/GF_sh_AI_scientist_Deck.pptx
+++ b/presentation/GF_sh_AI_scientist_Deck.pptx
@@ -3557,7 +3557,7 @@
                   <a:srgbClr val="6699BB"/>
                 </a:solidFill>
               </a:rPr>
-              <a:t>Powered by  OpenAI GPT-4o  ·  Tavily  ·  OpenAlex  ·  Semantic Scholar  ·  Next.js 14</a:t>
+              <a:t>Powered by  OpenAI GPT-4o  ·  Google Gemini  ·  Claude  ·  Supabase pgvector  ·  Tavily  ·  Next.js 14</a:t>
             </a:r>
           </a:p>
         </p:txBody>
@@ -4783,7 +4783,7 @@
                   <a:srgbClr val="FF6B6B"/>
                 </a:solidFill>
               </a:rPr>
-              <a:t>🔍  PLAN CRITIQUE — WE CHECK OUR OWN WORK</a:t>
+              <a:t>🔍  PLAN CRITIQUE — AI EVALUATES ITS OWN WEAKNESSES</a:t>
             </a:r>
           </a:p>
         </p:txBody>
@@ -4817,9 +4817,10 @@
                   <a:srgbClr val="CCD6E0"/>
                 </a:solidFill>
               </a:rPr>
-              <a:t>After every plan is generated, an AI critic scans it for 6 weakness categories:
-controls · statistics · sample size · validation · safety · feasibility
-Heuristic fallback if AI is unavailable. Rated: weak / needs_work / solid</a:t>
+              <a:t>After every plan, AI scans for 6 critical weakness categories:
+missing controls · weak statistics · insufficient sample size
+validation gaps · safety oversights · feasibility issues
+Rated: weak (critical) · needs_work (warning) · solid (pass)</a:t>
             </a:r>
           </a:p>
         </p:txBody>
@@ -4939,7 +4940,7 @@
                   <a:srgbClr val="FFD600"/>
                 </a:solidFill>
               </a:rPr>
-              <a:t>🔁  LEARNING FEEDBACK LOOP (Stretch Goal ✔)</a:t>
+              <a:t>🔁  RAG FEEDBACK LOOP — IT LEARNS  (Stretch Goal ✔)</a:t>
             </a:r>
           </a:p>
         </p:txBody>
@@ -4973,9 +4974,10 @@
                   <a:srgbClr val="CCD6E0"/>
                 </a:solidFill>
               </a:rPr>
-              <a:t>Scientist corrects a plan section → system derives a reusable rule + embedding.
-Next plan for a similar experiment automatically incorporates those corrections.
-Semantic + lexical retrieval: domain, type, tags, cosine similarity.</a:t>
+              <a:t>Scientist corrects a plan → Gemini embeds the correction (768-dim vector)
+stored in Supabase pgvector with HNSW index.
+Next similar question → match_experiments() retrieves corrections
+via cosine similarity → injected as few-shot context into the next plan.</a:t>
             </a:r>
           </a:p>
         </p:txBody>
@@ -7352,8 +7354,8 @@
                   <a:srgbClr val="00E596"/>
                 </a:solidFill>
               </a:rPr>
-              <a:t>Protocol + AI CRITIC that scans our own output for 6 weakness categories
-(controls · statistics · sample size · validation · safety · feasibility)</a:t>
+              <a:t>Protocol + AI CRITIC evaluates its own output for 6 weakness categories:
+controls · statistics · sample size · validation · safety · feasibility</a:t>
             </a:r>
           </a:p>
         </p:txBody>
@@ -7687,8 +7689,8 @@
                   <a:srgbClr val="00C2FF"/>
                 </a:solidFill>
               </a:rPr>
-              <a:t>✔  Fully implemented: derive rule → compute embedding → semantic+lexical retrieval
-   'Applied Feedback' panel shows exactly which rules were injected</a:t>
+              <a:t>✔  Full RAG pipeline: correction → Gemini 768-dim embedding → Supabase pgvector
+   match_experiments() cosine search → few-shot context in next plan</a:t>
             </a:r>
           </a:p>
         </p:txBody>
@@ -7799,7 +7801,7 @@
                   <a:srgbClr val="00C2FF"/>
                 </a:solidFill>
               </a:rPr>
-              <a:t>User-specific risk profile: hard-blocks · soft-flags · expert-review gates per plan</a:t>
+              <a:t>Multi-model: OpenAI GPT-4o · Google Gemini · Claude for redundancy &amp; best-fit tasks</a:t>
             </a:r>
           </a:p>
         </p:txBody>
@@ -7910,8 +7912,7 @@
                   <a:srgbClr val="00C2FF"/>
                 </a:solidFill>
               </a:rPr>
-              <a:t>Composite confidence score: evidence quality · supplier completeness
-   validation completeness · feedback relevance  →  trust before ordering</a:t>
+              <a:t>User-specific risk profile: hard-blocks · soft-flags · expert-review gates per plan</a:t>
             </a:r>
           </a:p>
         </p:txBody>
@@ -8022,7 +8023,119 @@
                   <a:srgbClr val="00C2FF"/>
                 </a:solidFill>
               </a:rPr>
-              <a:t>Upload own data [coming soon]  —  architecture (feedback store + embeddings) is ready</a:t>
+              <a:t>Composite confidence score: evidence quality · supplier completeness
+   validation completeness · feedback relevance  →  trust before ordering</a:t>
+            </a:r>
+          </a:p>
+        </p:txBody>
+      </p:sp>
+      <p:sp>
+        <p:nvSpPr>
+          <p:cNvPr id="34" name="Rectangle 33"/>
+          <p:cNvSpPr/>
+          <p:nvPr/>
+        </p:nvSpPr>
+        <p:spPr>
+          <a:xfrm>
+            <a:off x="365760" y="6684264"/>
+            <a:ext cx="11430000" cy="640080"/>
+          </a:xfrm>
+          <a:prstGeom prst="rect">
+            <a:avLst/>
+          </a:prstGeom>
+          <a:solidFill>
+            <a:srgbClr val="102233"/>
+          </a:solidFill>
+          <a:ln>
+            <a:noFill/>
+          </a:ln>
+        </p:spPr>
+        <p:style>
+          <a:lnRef idx="1">
+            <a:schemeClr val="accent1"/>
+          </a:lnRef>
+          <a:fillRef idx="3">
+            <a:schemeClr val="accent1"/>
+          </a:fillRef>
+          <a:effectRef idx="2">
+            <a:schemeClr val="accent1"/>
+          </a:effectRef>
+          <a:fontRef idx="minor">
+            <a:schemeClr val="lt1"/>
+          </a:fontRef>
+        </p:style>
+        <p:txBody>
+          <a:bodyPr rtlCol="0" anchor="ctr"/>
+          <a:lstStyle/>
+          <a:p>
+            <a:pPr algn="ctr"/>
+          </a:p>
+        </p:txBody>
+      </p:sp>
+      <p:sp>
+        <p:nvSpPr>
+          <p:cNvPr id="35" name="TextBox 34"/>
+          <p:cNvSpPr txBox="1"/>
+          <p:nvPr/>
+        </p:nvSpPr>
+        <p:spPr>
+          <a:xfrm>
+            <a:off x="502920" y="6775703"/>
+            <a:ext cx="5120640" cy="475488"/>
+          </a:xfrm>
+          <a:prstGeom prst="rect">
+            <a:avLst/>
+          </a:prstGeom>
+          <a:noFill/>
+        </p:spPr>
+        <p:txBody>
+          <a:bodyPr wrap="square">
+            <a:spAutoFit/>
+          </a:bodyPr>
+          <a:lstStyle/>
+          <a:p>
+            <a:pPr algn="l"/>
+            <a:r>
+              <a:rPr sz="1100" b="0" i="1">
+                <a:solidFill>
+                  <a:srgbClr val="8899AA"/>
+                </a:solidFill>
+              </a:rPr>
+              <a:t>(Not in brief)  —</a:t>
+            </a:r>
+          </a:p>
+        </p:txBody>
+      </p:sp>
+      <p:sp>
+        <p:nvSpPr>
+          <p:cNvPr id="36" name="TextBox 35"/>
+          <p:cNvSpPr txBox="1"/>
+          <p:nvPr/>
+        </p:nvSpPr>
+        <p:spPr>
+          <a:xfrm>
+            <a:off x="5760720" y="6775703"/>
+            <a:ext cx="6126480" cy="475488"/>
+          </a:xfrm>
+          <a:prstGeom prst="rect">
+            <a:avLst/>
+          </a:prstGeom>
+          <a:noFill/>
+        </p:spPr>
+        <p:txBody>
+          <a:bodyPr wrap="square">
+            <a:spAutoFit/>
+          </a:bodyPr>
+          <a:lstStyle/>
+          <a:p>
+            <a:pPr algn="l"/>
+            <a:r>
+              <a:rPr sz="1100" b="0" i="0">
+                <a:solidFill>
+                  <a:srgbClr val="00C2FF"/>
+                </a:solidFill>
+              </a:rPr>
+              <a:t>Upload own data [coming soon]  —  Supabase schema + embedding store already in place</a:t>
             </a:r>
           </a:p>
         </p:txBody>

</xml_diff>

<commit_message>
feat: rebuild deck + scripts for platform release (3-bucket feedback, doc upload, library)
</commit_message>
<xml_diff>
--- a/presentation/GF_sh_AI_scientist_Deck.pptx
+++ b/presentation/GF_sh_AI_scientist_Deck.pptx
@@ -9,7 +9,6 @@
     <p:sldId id="257" r:id="rId8"/>
     <p:sldId id="258" r:id="rId9"/>
     <p:sldId id="259" r:id="rId10"/>
-    <p:sldId id="260" r:id="rId11"/>
   </p:sldIdLst>
   <p:sldSz cx="12188952" cy="6858000" type="screen4x3"/>
   <p:notesSz cx="6858000" cy="9144000"/>
@@ -3364,12 +3363,12 @@
           <a:p>
             <a:pPr algn="ctr"/>
             <a:r>
-              <a:rPr sz="1400" b="0" i="1">
+              <a:rPr sz="1300" b="0" i="1">
                 <a:solidFill>
                   <a:srgbClr val="00C2FF"/>
                 </a:solidFill>
               </a:rPr>
-              <a:t>The AI Scientist  —  hypothesis to runnable experiment in minutes</a:t>
+              <a:t>The AI Scientist  —  from one-shot tool to experiment platform that learns</a:t>
             </a:r>
           </a:p>
         </p:txBody>
@@ -3557,7 +3556,7 @@
                   <a:srgbClr val="6699BB"/>
                 </a:solidFill>
               </a:rPr>
-              <a:t>Powered by  OpenAI GPT-4o  ·  Google Gemini  ·  Claude  ·  Supabase pgvector  ·  Tavily  ·  Next.js 14</a:t>
+              <a:t>OpenAI GPT-4o  ·  Google Gemini  ·  Claude  ·  Supabase pgvector  ·  Tavily  ·  Next.js 14</a:t>
             </a:r>
           </a:p>
         </p:txBody>
@@ -3670,8 +3669,8 @@
                 </a:solidFill>
               </a:rPr>
               <a:t>Science moves at the speed of operations, not ideas.
-We compress weeks of lab-planning into a plan a scientist
-can pick up on Monday and start running by Friday.</a:t>
+Every plan saved, every correction made, every document uploaded —
+the next plan is better.</a:t>
             </a:r>
           </a:p>
         </p:txBody>
@@ -3851,7 +3850,7 @@
                   <a:srgbClr val="00C2FF"/>
                 </a:solidFill>
               </a:rPr>
-              <a:t>From hypothesis to runnable experiment — in minutes, not weeks</a:t>
+              <a:t>Hypothesis to runnable experiment plan — in minutes, not weeks</a:t>
             </a:r>
           </a:p>
         </p:txBody>
@@ -4043,11 +4042,11 @@
           <a:p>
             <a:pPr algn="l">
               <a:lnSpc>
-                <a:spcPts val="2000"/>
+                <a:spcPts val="1900"/>
               </a:lnSpc>
             </a:pPr>
             <a:r>
-              <a:rPr sz="1400" b="0" i="0">
+              <a:rPr sz="1300" b="0" i="0">
                 <a:solidFill>
                   <a:srgbClr val="CCD6E0"/>
                 </a:solidFill>
@@ -4059,11 +4058,11 @@
           <a:p>
             <a:pPr algn="l">
               <a:lnSpc>
-                <a:spcPts val="2000"/>
+                <a:spcPts val="1900"/>
               </a:lnSpc>
             </a:pPr>
             <a:r>
-              <a:rPr sz="1400" b="0" i="0">
+              <a:rPr sz="1300" b="0" i="0">
                 <a:solidFill>
                   <a:srgbClr val="CCD6E0"/>
                 </a:solidFill>
@@ -4074,11 +4073,11 @@
           <a:p>
             <a:pPr algn="l">
               <a:lnSpc>
-                <a:spcPts val="2000"/>
+                <a:spcPts val="1900"/>
               </a:lnSpc>
             </a:pPr>
             <a:r>
-              <a:rPr sz="1400" b="0" i="0">
+              <a:rPr sz="1300" b="0" i="0">
                 <a:solidFill>
                   <a:srgbClr val="CCD6E0"/>
                 </a:solidFill>
@@ -4089,11 +4088,11 @@
           <a:p>
             <a:pPr algn="l">
               <a:lnSpc>
-                <a:spcPts val="2000"/>
+                <a:spcPts val="1900"/>
               </a:lnSpc>
             </a:pPr>
             <a:r>
-              <a:rPr sz="1400" b="0" i="0">
+              <a:rPr sz="1300" b="0" i="0">
                 <a:solidFill>
                   <a:srgbClr val="CCD6E0"/>
                 </a:solidFill>
@@ -4104,11 +4103,11 @@
           <a:p>
             <a:pPr algn="l">
               <a:lnSpc>
-                <a:spcPts val="2000"/>
+                <a:spcPts val="1900"/>
               </a:lnSpc>
             </a:pPr>
             <a:r>
-              <a:rPr sz="1400" b="0" i="0">
+              <a:rPr sz="1300" b="0" i="0">
                 <a:solidFill>
                   <a:srgbClr val="CCD6E0"/>
                 </a:solidFill>
@@ -4119,11 +4118,11 @@
           <a:p>
             <a:pPr algn="l">
               <a:lnSpc>
-                <a:spcPts val="2000"/>
+                <a:spcPts val="1900"/>
               </a:lnSpc>
             </a:pPr>
             <a:r>
-              <a:rPr sz="1400" b="0" i="0">
+              <a:rPr sz="1300" b="0" i="0">
                 <a:solidFill>
                   <a:srgbClr val="CCD6E0"/>
                 </a:solidFill>
@@ -4134,11 +4133,26 @@
           <a:p>
             <a:pPr algn="l">
               <a:lnSpc>
-                <a:spcPts val="2000"/>
+                <a:spcPts val="1900"/>
               </a:lnSpc>
             </a:pPr>
             <a:r>
-              <a:rPr sz="1400" b="0" i="0">
+              <a:rPr sz="1300" b="0" i="0">
+                <a:solidFill>
+                  <a:srgbClr val="CCD6E0"/>
+                </a:solidFill>
+              </a:rPr>
+              <a:t>• Applying your lab's own SOPs and prior corrections</a:t>
+            </a:r>
+          </a:p>
+          <a:p>
+            <a:pPr algn="l">
+              <a:lnSpc>
+                <a:spcPts val="1900"/>
+              </a:lnSpc>
+            </a:pPr>
+            <a:r>
+              <a:rPr sz="1300" b="0" i="0">
                 <a:solidFill>
                   <a:srgbClr val="CCD6E0"/>
                 </a:solidFill>
@@ -4149,11 +4163,11 @@
           <a:p>
             <a:pPr algn="l">
               <a:lnSpc>
-                <a:spcPts val="2000"/>
+                <a:spcPts val="1900"/>
               </a:lnSpc>
             </a:pPr>
             <a:r>
-              <a:rPr sz="1400" b="0" i="1">
+              <a:rPr sz="1300" b="0" i="1">
                 <a:solidFill>
                   <a:srgbClr val="FFD600"/>
                 </a:solidFill>
@@ -4326,7 +4340,7 @@
         <p:spPr>
           <a:xfrm>
             <a:off x="6583680" y="2423160"/>
-            <a:ext cx="5120640" cy="3474720"/>
+            <a:ext cx="5120640" cy="3566160"/>
           </a:xfrm>
           <a:prstGeom prst="rect">
             <a:avLst/>
@@ -4341,26 +4355,26 @@
           <a:p>
             <a:pPr algn="l">
               <a:lnSpc>
-                <a:spcPts val="1800"/>
+                <a:spcPts val="1700"/>
               </a:lnSpc>
             </a:pPr>
             <a:r>
-              <a:rPr sz="1300" b="1" i="0">
+              <a:rPr sz="1200" b="1" i="0">
                 <a:solidFill>
                   <a:srgbClr val="FFFFFF"/>
                 </a:solidFill>
               </a:rPr>
-              <a:t>3-stage AI pipeline:</a:t>
+              <a:t>An iterative experiment platform:</a:t>
             </a:r>
           </a:p>
           <a:p>
             <a:pPr algn="l">
               <a:lnSpc>
-                <a:spcPts val="1800"/>
+                <a:spcPts val="1700"/>
               </a:lnSpc>
             </a:pPr>
             <a:r>
-              <a:rPr sz="1300" b="0" i="0">
+              <a:rPr sz="1200" b="0" i="0">
                 <a:solidFill>
                   <a:srgbClr val="CCD6E0"/>
                 </a:solidFill>
@@ -4371,26 +4385,27 @@
           <a:p>
             <a:pPr algn="l">
               <a:lnSpc>
-                <a:spcPts val="1800"/>
+                <a:spcPts val="1700"/>
               </a:lnSpc>
             </a:pPr>
             <a:r>
-              <a:rPr sz="1300" b="0" i="0">
+              <a:rPr sz="1200" b="0" i="0">
                 <a:solidFill>
                   <a:srgbClr val="00C2FF"/>
                 </a:solidFill>
               </a:rPr>
-              <a:t>① Input  — any natural-language hypothesis</a:t>
+              <a:t>① Input  — hypothesis + category + optional
+   reference documents (PDF / TXT)</a:t>
             </a:r>
           </a:p>
           <a:p>
             <a:pPr algn="l">
               <a:lnSpc>
-                <a:spcPts val="1800"/>
+                <a:spcPts val="1700"/>
               </a:lnSpc>
             </a:pPr>
             <a:r>
-              <a:rPr sz="1300" b="0" i="0">
+              <a:rPr sz="1200" b="0" i="0">
                 <a:solidFill>
                   <a:srgbClr val="CCD6E0"/>
                 </a:solidFill>
@@ -4401,28 +4416,27 @@
           <a:p>
             <a:pPr algn="l">
               <a:lnSpc>
-                <a:spcPts val="1800"/>
+                <a:spcPts val="1700"/>
               </a:lnSpc>
             </a:pPr>
             <a:r>
-              <a:rPr sz="1300" b="0" i="0">
+              <a:rPr sz="1200" b="0" i="0">
                 <a:solidFill>
                   <a:srgbClr val="00C2FF"/>
                 </a:solidFill>
               </a:rPr>
-              <a:t>② Literature QC  — 6-source search (Semantic Scholar,
-   arXiv, PubMed, OpenAlex, protocols.io + Tavily)
+              <a:t>② Literature QC  — 6-source parallel search
    → novelty signal in seconds</a:t>
             </a:r>
           </a:p>
           <a:p>
             <a:pPr algn="l">
               <a:lnSpc>
-                <a:spcPts val="1800"/>
+                <a:spcPts val="1700"/>
               </a:lnSpc>
             </a:pPr>
             <a:r>
-              <a:rPr sz="1300" b="0" i="0">
+              <a:rPr sz="1200" b="0" i="0">
                 <a:solidFill>
                   <a:srgbClr val="CCD6E0"/>
                 </a:solidFill>
@@ -4433,28 +4447,27 @@
           <a:p>
             <a:pPr algn="l">
               <a:lnSpc>
-                <a:spcPts val="1800"/>
+                <a:spcPts val="1700"/>
               </a:lnSpc>
             </a:pPr>
             <a:r>
-              <a:rPr sz="1300" b="0" i="0">
+              <a:rPr sz="1200" b="0" i="0">
                 <a:solidFill>
                   <a:srgbClr val="00C2FF"/>
                 </a:solidFill>
               </a:rPr>
-              <a:t>③ Full Experiment Plan  — protocol · materials
-   catalog #s · budget · timeline · validation
-   safety · risks · assumptions</a:t>
+              <a:t>③ Plan + Critique  — full operational plan,
+   then AI audits its own weaknesses</a:t>
             </a:r>
           </a:p>
           <a:p>
             <a:pPr algn="l">
               <a:lnSpc>
-                <a:spcPts val="1800"/>
+                <a:spcPts val="1700"/>
               </a:lnSpc>
             </a:pPr>
             <a:r>
-              <a:rPr sz="1300" b="0" i="0">
+              <a:rPr sz="1200" b="0" i="0">
                 <a:solidFill>
                   <a:srgbClr val="CCD6E0"/>
                 </a:solidFill>
@@ -4465,16 +4478,47 @@
           <a:p>
             <a:pPr algn="l">
               <a:lnSpc>
-                <a:spcPts val="1800"/>
+                <a:spcPts val="1700"/>
               </a:lnSpc>
             </a:pPr>
             <a:r>
-              <a:rPr sz="1300" b="1" i="1">
+              <a:rPr sz="1200" b="0" i="0">
+                <a:solidFill>
+                  <a:srgbClr val="00C2FF"/>
+                </a:solidFill>
+              </a:rPr>
+              <a:t>④ Save → Feedback → Regenerate  — corrections
+   stored by scope, applied to every future plan</a:t>
+            </a:r>
+          </a:p>
+          <a:p>
+            <a:pPr algn="l">
+              <a:lnSpc>
+                <a:spcPts val="1700"/>
+              </a:lnSpc>
+            </a:pPr>
+            <a:r>
+              <a:rPr sz="1200" b="0" i="0">
+                <a:solidFill>
+                  <a:srgbClr val="CCD6E0"/>
+                </a:solidFill>
+              </a:rPr>
+              <a:t/>
+            </a:r>
+          </a:p>
+          <a:p>
+            <a:pPr algn="l">
+              <a:lnSpc>
+                <a:spcPts val="1700"/>
+              </a:lnSpc>
+            </a:pPr>
+            <a:r>
+              <a:rPr sz="1200" b="1" i="1">
                 <a:solidFill>
                   <a:srgbClr val="00E596"/>
                 </a:solidFill>
               </a:rPr>
-              <a:t>Pick it up Monday. Start running Friday.</a:t>
+              <a:t>The platform gets smarter with every use.</a:t>
             </a:r>
           </a:p>
         </p:txBody>
@@ -4677,7 +4721,7 @@
         <p:spPr>
           <a:xfrm>
             <a:off x="365760" y="1051560"/>
-            <a:ext cx="5577840" cy="2423160"/>
+            <a:ext cx="5577840" cy="2487168"/>
           </a:xfrm>
           <a:prstGeom prst="rect">
             <a:avLst/>
@@ -4763,7 +4807,7 @@
         <p:spPr>
           <a:xfrm>
             <a:off x="502920" y="1179576"/>
-            <a:ext cx="5303520" cy="457200"/>
+            <a:ext cx="5303520" cy="438912"/>
           </a:xfrm>
           <a:prstGeom prst="rect">
             <a:avLst/>
@@ -4778,7 +4822,7 @@
           <a:p>
             <a:pPr algn="l"/>
             <a:r>
-              <a:rPr sz="1400" b="1" i="0">
+              <a:rPr sz="1300" b="1" i="0">
                 <a:solidFill>
                   <a:srgbClr val="FF6B6B"/>
                 </a:solidFill>
@@ -4796,8 +4840,8 @@
         </p:nvSpPr>
         <p:spPr>
           <a:xfrm>
-            <a:off x="502920" y="1691639"/>
-            <a:ext cx="5303520" cy="1645920"/>
+            <a:off x="502920" y="1655064"/>
+            <a:ext cx="5303520" cy="1755648"/>
           </a:xfrm>
           <a:prstGeom prst="rect">
             <a:avLst/>
@@ -4812,15 +4856,15 @@
           <a:p>
             <a:pPr algn="l"/>
             <a:r>
-              <a:rPr sz="1200" b="0" i="0">
+              <a:rPr sz="1100" b="0" i="0">
                 <a:solidFill>
                   <a:srgbClr val="CCD6E0"/>
                 </a:solidFill>
               </a:rPr>
-              <a:t>After every plan, AI scans for 6 critical weakness categories:
+              <a:t>After every plan, a second AI pass scans for 6 weakness categories:
 missing controls · weak statistics · insufficient sample size
 validation gaps · safety oversights · feasibility issues
-Rated: weak (critical) · needs_work (warning) · solid (pass)</a:t>
+Rated: weak (critical) · needs_work · solid</a:t>
             </a:r>
           </a:p>
         </p:txBody>
@@ -4834,7 +4878,7 @@
         <p:spPr>
           <a:xfrm>
             <a:off x="6263640" y="1051560"/>
-            <a:ext cx="5577840" cy="2423160"/>
+            <a:ext cx="5577840" cy="2487168"/>
           </a:xfrm>
           <a:prstGeom prst="rect">
             <a:avLst/>
@@ -4883,7 +4927,7 @@
             <a:avLst/>
           </a:prstGeom>
           <a:solidFill>
-            <a:srgbClr val="FFD600"/>
+            <a:srgbClr val="05C48A"/>
           </a:solidFill>
           <a:ln>
             <a:noFill/>
@@ -4920,7 +4964,7 @@
         <p:spPr>
           <a:xfrm>
             <a:off x="6400800" y="1179576"/>
-            <a:ext cx="5303520" cy="457200"/>
+            <a:ext cx="5303520" cy="438912"/>
           </a:xfrm>
           <a:prstGeom prst="rect">
             <a:avLst/>
@@ -4935,12 +4979,12 @@
           <a:p>
             <a:pPr algn="l"/>
             <a:r>
-              <a:rPr sz="1400" b="1" i="0">
-                <a:solidFill>
-                  <a:srgbClr val="FFD600"/>
+              <a:rPr sz="1300" b="1" i="0">
+                <a:solidFill>
+                  <a:srgbClr val="05C48A"/>
                 </a:solidFill>
               </a:rPr>
-              <a:t>🔁  RAG FEEDBACK LOOP — IT LEARNS  (Stretch Goal ✔)</a:t>
+              <a:t>🔁  3-BUCKET FEEDBACK PLATFORM  (Stretch Goal ✔)</a:t>
             </a:r>
           </a:p>
         </p:txBody>
@@ -4953,8 +4997,8 @@
         </p:nvSpPr>
         <p:spPr>
           <a:xfrm>
-            <a:off x="6400800" y="1691639"/>
-            <a:ext cx="5303520" cy="1645920"/>
+            <a:off x="6400800" y="1655064"/>
+            <a:ext cx="5303520" cy="1755648"/>
           </a:xfrm>
           <a:prstGeom prst="rect">
             <a:avLst/>
@@ -4969,15 +5013,15 @@
           <a:p>
             <a:pPr algn="l"/>
             <a:r>
-              <a:rPr sz="1200" b="0" i="0">
+              <a:rPr sz="1100" b="0" i="0">
                 <a:solidFill>
                   <a:srgbClr val="CCD6E0"/>
                 </a:solidFill>
               </a:rPr>
-              <a:t>Scientist corrects a plan → Gemini embeds the correction (768-dim vector)
-stored in Supabase pgvector with HNSW index.
-Next similar question → match_experiments() retrieves corrections
-via cosine similarity → injected as few-shot context into the next plan.</a:t>
+              <a:t>Corrections scoped to: Organisation · Category · Experiment
+AI auto-classifies each correction into the right bucket.
+Stored as Gemini 768-dim vectors in Supabase pgvector (HNSW).
+Injected as labelled blocks into every new plan. ~1,600 rules pre-seeded.</a:t>
             </a:r>
           </a:p>
         </p:txBody>
@@ -4990,8 +5034,8 @@
         </p:nvSpPr>
         <p:spPr>
           <a:xfrm>
-            <a:off x="365760" y="3657600"/>
-            <a:ext cx="5577840" cy="2423160"/>
+            <a:off x="365760" y="3703320"/>
+            <a:ext cx="5577840" cy="2487168"/>
           </a:xfrm>
           <a:prstGeom prst="rect">
             <a:avLst/>
@@ -5033,14 +5077,14 @@
         </p:nvSpPr>
         <p:spPr>
           <a:xfrm>
-            <a:off x="365760" y="3657600"/>
+            <a:off x="365760" y="3703320"/>
             <a:ext cx="5577840" cy="73152"/>
           </a:xfrm>
           <a:prstGeom prst="rect">
             <a:avLst/>
           </a:prstGeom>
           <a:solidFill>
-            <a:srgbClr val="FF6B6B"/>
+            <a:srgbClr val="FFD600"/>
           </a:solidFill>
           <a:ln>
             <a:noFill/>
@@ -5076,8 +5120,8 @@
         </p:nvSpPr>
         <p:spPr>
           <a:xfrm>
-            <a:off x="502920" y="3785615"/>
-            <a:ext cx="5303520" cy="457200"/>
+            <a:off x="502920" y="3831335"/>
+            <a:ext cx="5303520" cy="438912"/>
           </a:xfrm>
           <a:prstGeom prst="rect">
             <a:avLst/>
@@ -5092,12 +5136,12 @@
           <a:p>
             <a:pPr algn="l"/>
             <a:r>
-              <a:rPr sz="1400" b="1" i="0">
-                <a:solidFill>
-                  <a:srgbClr val="FF6B6B"/>
+              <a:rPr sz="1300" b="1" i="0">
+                <a:solidFill>
+                  <a:srgbClr val="FFD600"/>
                 </a:solidFill>
               </a:rPr>
-              <a:t>🛡️  USER-SPECIFIC RISK PROFILE</a:t>
+              <a:t>📂  DOCUMENT UPLOAD — YOUR SOPs BECOME PART OF EVERY PLAN</a:t>
             </a:r>
           </a:p>
         </p:txBody>
@@ -5110,8 +5154,8 @@
         </p:nvSpPr>
         <p:spPr>
           <a:xfrm>
-            <a:off x="502920" y="4297680"/>
-            <a:ext cx="5303520" cy="1645920"/>
+            <a:off x="502920" y="4306824"/>
+            <a:ext cx="5303520" cy="1755648"/>
           </a:xfrm>
           <a:prstGeom prst="rect">
             <a:avLst/>
@@ -5126,14 +5170,15 @@
           <a:p>
             <a:pPr algn="l"/>
             <a:r>
-              <a:rPr sz="1200" b="0" i="0">
+              <a:rPr sz="1100" b="0" i="0">
                 <a:solidFill>
                   <a:srgbClr val="CCD6E0"/>
                 </a:solidFill>
               </a:rPr>
-              <a:t>Hard-blocks: gain-of-function · pathogen synthesis · unapproved human trials.
-Soft-flags: animal work · GMOs · controlled substances · biohazards.
-Every plan includes PPE requirements, waste handling &amp; expert-review gates.</a:t>
+              <a:t>Upload PDF, TXT, or MD at organisation-scope or experiment-scope.
+Text extracted via pdf-parse (60 KB cap), threaded into plan prompt.
+Org documents inject into all plans. Experiment docs inject on branch.
+Your lab's protocols, not just the literature.</a:t>
             </a:r>
           </a:p>
         </p:txBody>
@@ -5146,8 +5191,8 @@
         </p:nvSpPr>
         <p:spPr>
           <a:xfrm>
-            <a:off x="6263640" y="3657600"/>
-            <a:ext cx="5577840" cy="2423160"/>
+            <a:off x="6263640" y="3703320"/>
+            <a:ext cx="5577840" cy="2487168"/>
           </a:xfrm>
           <a:prstGeom prst="rect">
             <a:avLst/>
@@ -5189,14 +5234,14 @@
         </p:nvSpPr>
         <p:spPr>
           <a:xfrm>
-            <a:off x="6263640" y="3657600"/>
+            <a:off x="6263640" y="3703320"/>
             <a:ext cx="5577840" cy="73152"/>
           </a:xfrm>
           <a:prstGeom prst="rect">
             <a:avLst/>
           </a:prstGeom>
           <a:solidFill>
-            <a:srgbClr val="00E596"/>
+            <a:srgbClr val="A86EFF"/>
           </a:solidFill>
           <a:ln>
             <a:noFill/>
@@ -5232,8 +5277,8 @@
         </p:nvSpPr>
         <p:spPr>
           <a:xfrm>
-            <a:off x="6400800" y="3785615"/>
-            <a:ext cx="5303520" cy="457200"/>
+            <a:off x="6400800" y="3831335"/>
+            <a:ext cx="5303520" cy="438912"/>
           </a:xfrm>
           <a:prstGeom prst="rect">
             <a:avLst/>
@@ -5248,12 +5293,12 @@
           <a:p>
             <a:pPr algn="l"/>
             <a:r>
-              <a:rPr sz="1400" b="1" i="0">
-                <a:solidFill>
-                  <a:srgbClr val="00E596"/>
+              <a:rPr sz="1300" b="1" i="0">
+                <a:solidFill>
+                  <a:srgbClr val="A86EFF"/>
                 </a:solidFill>
               </a:rPr>
-              <a:t>📊  COMPOSITE CONFIDENCE SCORE</a:t>
+              <a:t>🏛️  EXPERIMENT LIBRARY + ORGANISATION LAYER</a:t>
             </a:r>
           </a:p>
         </p:txBody>
@@ -5266,8 +5311,8 @@
         </p:nvSpPr>
         <p:spPr>
           <a:xfrm>
-            <a:off x="6400800" y="4297680"/>
-            <a:ext cx="5303520" cy="1645920"/>
+            <a:off x="6400800" y="4306824"/>
+            <a:ext cx="5303520" cy="1755648"/>
           </a:xfrm>
           <a:prstGeom prst="rect">
             <a:avLst/>
@@ -5282,14 +5327,15 @@
           <a:p>
             <a:pPr algn="l"/>
             <a:r>
-              <a:rPr sz="1200" b="0" i="0">
+              <a:rPr sz="1100" b="0" i="0">
                 <a:solidFill>
                   <a:srgbClr val="CCD6E0"/>
                 </a:solidFill>
               </a:rPr>
-              <a:t>Every plan is scored across 4 dimensions:
-evidence quality · supplier completeness · validation completeness · feedback relevance.
-Scientists know exactly how much to trust the output before ordering materials.</a:t>
+              <a:t>Named experiments saved and re-opened from a persistent library.
+Save without re-running · Regenerate with latest feedback applied.
+Category system (cell-biology, diagnostics, …) scopes feedback rules.
+Multi-tenant org layer: settings drawer, per-org categories &amp; documents.</a:t>
             </a:r>
           </a:p>
         </p:txBody>
@@ -5435,7 +5481,7 @@
                   <a:srgbClr val="FFFFFF"/>
                 </a:solidFill>
               </a:rPr>
-              <a:t>DID WE FULFIL THE BRIEF?</a:t>
+              <a:t>WHAT WE DID BETTER THAN THE REQUIREMENTS</a:t>
             </a:r>
           </a:p>
         </p:txBody>
@@ -5492,1505 +5538,6 @@
         <p:spPr>
           <a:xfrm>
             <a:off x="365760" y="960120"/>
-            <a:ext cx="5760720" cy="347472"/>
-          </a:xfrm>
-          <a:prstGeom prst="rect">
-            <a:avLst/>
-          </a:prstGeom>
-          <a:solidFill>
-            <a:srgbClr val="004A7A"/>
-          </a:solidFill>
-          <a:ln>
-            <a:noFill/>
-          </a:ln>
-        </p:spPr>
-        <p:style>
-          <a:lnRef idx="1">
-            <a:schemeClr val="accent1"/>
-          </a:lnRef>
-          <a:fillRef idx="3">
-            <a:schemeClr val="accent1"/>
-          </a:fillRef>
-          <a:effectRef idx="2">
-            <a:schemeClr val="accent1"/>
-          </a:effectRef>
-          <a:fontRef idx="minor">
-            <a:schemeClr val="lt1"/>
-          </a:fontRef>
-        </p:style>
-        <p:txBody>
-          <a:bodyPr rtlCol="0" anchor="ctr"/>
-          <a:lstStyle/>
-          <a:p>
-            <a:pPr algn="ctr"/>
-          </a:p>
-        </p:txBody>
-      </p:sp>
-      <p:sp>
-        <p:nvSpPr>
-          <p:cNvPr id="7" name="Rectangle 6"/>
-          <p:cNvSpPr/>
-          <p:nvPr/>
-        </p:nvSpPr>
-        <p:spPr>
-          <a:xfrm>
-            <a:off x="6263640" y="960120"/>
-            <a:ext cx="5577840" cy="347472"/>
-          </a:xfrm>
-          <a:prstGeom prst="rect">
-            <a:avLst/>
-          </a:prstGeom>
-          <a:solidFill>
-            <a:srgbClr val="003A1A"/>
-          </a:solidFill>
-          <a:ln>
-            <a:noFill/>
-          </a:ln>
-        </p:spPr>
-        <p:style>
-          <a:lnRef idx="1">
-            <a:schemeClr val="accent1"/>
-          </a:lnRef>
-          <a:fillRef idx="3">
-            <a:schemeClr val="accent1"/>
-          </a:fillRef>
-          <a:effectRef idx="2">
-            <a:schemeClr val="accent1"/>
-          </a:effectRef>
-          <a:fontRef idx="minor">
-            <a:schemeClr val="lt1"/>
-          </a:fontRef>
-        </p:style>
-        <p:txBody>
-          <a:bodyPr rtlCol="0" anchor="ctr"/>
-          <a:lstStyle/>
-          <a:p>
-            <a:pPr algn="ctr"/>
-          </a:p>
-        </p:txBody>
-      </p:sp>
-      <p:sp>
-        <p:nvSpPr>
-          <p:cNvPr id="8" name="TextBox 7"/>
-          <p:cNvSpPr txBox="1"/>
-          <p:nvPr/>
-        </p:nvSpPr>
-        <p:spPr>
-          <a:xfrm>
-            <a:off x="502920" y="1005840"/>
-            <a:ext cx="5577840" cy="274320"/>
-          </a:xfrm>
-          <a:prstGeom prst="rect">
-            <a:avLst/>
-          </a:prstGeom>
-          <a:noFill/>
-        </p:spPr>
-        <p:txBody>
-          <a:bodyPr wrap="square">
-            <a:spAutoFit/>
-          </a:bodyPr>
-          <a:lstStyle/>
-          <a:p>
-            <a:pPr algn="l"/>
-            <a:r>
-              <a:rPr sz="1300" b="1" i="0">
-                <a:solidFill>
-                  <a:srgbClr val="FFFFFF"/>
-                </a:solidFill>
-              </a:rPr>
-              <a:t>CORE REQUIREMENTS</a:t>
-            </a:r>
-          </a:p>
-        </p:txBody>
-      </p:sp>
-      <p:sp>
-        <p:nvSpPr>
-          <p:cNvPr id="9" name="TextBox 8"/>
-          <p:cNvSpPr txBox="1"/>
-          <p:nvPr/>
-        </p:nvSpPr>
-        <p:spPr>
-          <a:xfrm>
-            <a:off x="6400800" y="1005840"/>
-            <a:ext cx="5394960" cy="274320"/>
-          </a:xfrm>
-          <a:prstGeom prst="rect">
-            <a:avLst/>
-          </a:prstGeom>
-          <a:noFill/>
-        </p:spPr>
-        <p:txBody>
-          <a:bodyPr wrap="square">
-            <a:spAutoFit/>
-          </a:bodyPr>
-          <a:lstStyle/>
-          <a:p>
-            <a:pPr algn="l"/>
-            <a:r>
-              <a:rPr sz="1300" b="1" i="0">
-                <a:solidFill>
-                  <a:srgbClr val="00E596"/>
-                </a:solidFill>
-              </a:rPr>
-              <a:t>STRETCH GOAL + BEYOND</a:t>
-            </a:r>
-          </a:p>
-        </p:txBody>
-      </p:sp>
-      <p:sp>
-        <p:nvSpPr>
-          <p:cNvPr id="10" name="TextBox 9"/>
-          <p:cNvSpPr txBox="1"/>
-          <p:nvPr/>
-        </p:nvSpPr>
-        <p:spPr>
-          <a:xfrm>
-            <a:off x="365760" y="1417320"/>
-            <a:ext cx="411480" cy="347472"/>
-          </a:xfrm>
-          <a:prstGeom prst="rect">
-            <a:avLst/>
-          </a:prstGeom>
-          <a:noFill/>
-        </p:spPr>
-        <p:txBody>
-          <a:bodyPr wrap="square">
-            <a:spAutoFit/>
-          </a:bodyPr>
-          <a:lstStyle/>
-          <a:p>
-            <a:pPr algn="l"/>
-            <a:r>
-              <a:rPr sz="1600" b="1" i="0">
-                <a:solidFill>
-                  <a:srgbClr val="00E596"/>
-                </a:solidFill>
-              </a:rPr>
-              <a:t>✔</a:t>
-            </a:r>
-          </a:p>
-        </p:txBody>
-      </p:sp>
-      <p:sp>
-        <p:nvSpPr>
-          <p:cNvPr id="11" name="TextBox 10"/>
-          <p:cNvSpPr txBox="1"/>
-          <p:nvPr/>
-        </p:nvSpPr>
-        <p:spPr>
-          <a:xfrm>
-            <a:off x="749808" y="1417320"/>
-            <a:ext cx="4937760" cy="347472"/>
-          </a:xfrm>
-          <a:prstGeom prst="rect">
-            <a:avLst/>
-          </a:prstGeom>
-          <a:noFill/>
-        </p:spPr>
-        <p:txBody>
-          <a:bodyPr wrap="square">
-            <a:spAutoFit/>
-          </a:bodyPr>
-          <a:lstStyle/>
-          <a:p>
-            <a:pPr algn="l"/>
-            <a:r>
-              <a:rPr sz="1300" b="0" i="0">
-                <a:solidFill>
-                  <a:srgbClr val="FFFFFF"/>
-                </a:solidFill>
-              </a:rPr>
-              <a:t>Natural language input</a:t>
-            </a:r>
-          </a:p>
-        </p:txBody>
-      </p:sp>
-      <p:sp>
-        <p:nvSpPr>
-          <p:cNvPr id="12" name="TextBox 11"/>
-          <p:cNvSpPr txBox="1"/>
-          <p:nvPr/>
-        </p:nvSpPr>
-        <p:spPr>
-          <a:xfrm>
-            <a:off x="365760" y="2039112"/>
-            <a:ext cx="411480" cy="347472"/>
-          </a:xfrm>
-          <a:prstGeom prst="rect">
-            <a:avLst/>
-          </a:prstGeom>
-          <a:noFill/>
-        </p:spPr>
-        <p:txBody>
-          <a:bodyPr wrap="square">
-            <a:spAutoFit/>
-          </a:bodyPr>
-          <a:lstStyle/>
-          <a:p>
-            <a:pPr algn="l"/>
-            <a:r>
-              <a:rPr sz="1600" b="1" i="0">
-                <a:solidFill>
-                  <a:srgbClr val="00E596"/>
-                </a:solidFill>
-              </a:rPr>
-              <a:t>✔</a:t>
-            </a:r>
-          </a:p>
-        </p:txBody>
-      </p:sp>
-      <p:sp>
-        <p:nvSpPr>
-          <p:cNvPr id="13" name="TextBox 12"/>
-          <p:cNvSpPr txBox="1"/>
-          <p:nvPr/>
-        </p:nvSpPr>
-        <p:spPr>
-          <a:xfrm>
-            <a:off x="749808" y="2039112"/>
-            <a:ext cx="4937760" cy="347472"/>
-          </a:xfrm>
-          <a:prstGeom prst="rect">
-            <a:avLst/>
-          </a:prstGeom>
-          <a:noFill/>
-        </p:spPr>
-        <p:txBody>
-          <a:bodyPr wrap="square">
-            <a:spAutoFit/>
-          </a:bodyPr>
-          <a:lstStyle/>
-          <a:p>
-            <a:pPr algn="l"/>
-            <a:r>
-              <a:rPr sz="1300" b="0" i="0">
-                <a:solidFill>
-                  <a:srgbClr val="FFFFFF"/>
-                </a:solidFill>
-              </a:rPr>
-              <a:t>Literature QC — novelty signal + references</a:t>
-            </a:r>
-          </a:p>
-        </p:txBody>
-      </p:sp>
-      <p:sp>
-        <p:nvSpPr>
-          <p:cNvPr id="14" name="TextBox 13"/>
-          <p:cNvSpPr txBox="1"/>
-          <p:nvPr/>
-        </p:nvSpPr>
-        <p:spPr>
-          <a:xfrm>
-            <a:off x="365760" y="2660904"/>
-            <a:ext cx="411480" cy="347472"/>
-          </a:xfrm>
-          <a:prstGeom prst="rect">
-            <a:avLst/>
-          </a:prstGeom>
-          <a:noFill/>
-        </p:spPr>
-        <p:txBody>
-          <a:bodyPr wrap="square">
-            <a:spAutoFit/>
-          </a:bodyPr>
-          <a:lstStyle/>
-          <a:p>
-            <a:pPr algn="l"/>
-            <a:r>
-              <a:rPr sz="1600" b="1" i="0">
-                <a:solidFill>
-                  <a:srgbClr val="00E596"/>
-                </a:solidFill>
-              </a:rPr>
-              <a:t>✔</a:t>
-            </a:r>
-          </a:p>
-        </p:txBody>
-      </p:sp>
-      <p:sp>
-        <p:nvSpPr>
-          <p:cNvPr id="15" name="TextBox 14"/>
-          <p:cNvSpPr txBox="1"/>
-          <p:nvPr/>
-        </p:nvSpPr>
-        <p:spPr>
-          <a:xfrm>
-            <a:off x="749808" y="2660904"/>
-            <a:ext cx="4937760" cy="347472"/>
-          </a:xfrm>
-          <a:prstGeom prst="rect">
-            <a:avLst/>
-          </a:prstGeom>
-          <a:noFill/>
-        </p:spPr>
-        <p:txBody>
-          <a:bodyPr wrap="square">
-            <a:spAutoFit/>
-          </a:bodyPr>
-          <a:lstStyle/>
-          <a:p>
-            <a:pPr algn="l"/>
-            <a:r>
-              <a:rPr sz="1300" b="0" i="0">
-                <a:solidFill>
-                  <a:srgbClr val="FFFFFF"/>
-                </a:solidFill>
-              </a:rPr>
-              <a:t>Step-by-step protocol (grounded in research)</a:t>
-            </a:r>
-          </a:p>
-        </p:txBody>
-      </p:sp>
-      <p:sp>
-        <p:nvSpPr>
-          <p:cNvPr id="16" name="TextBox 15"/>
-          <p:cNvSpPr txBox="1"/>
-          <p:nvPr/>
-        </p:nvSpPr>
-        <p:spPr>
-          <a:xfrm>
-            <a:off x="365760" y="3282696"/>
-            <a:ext cx="411480" cy="347472"/>
-          </a:xfrm>
-          <a:prstGeom prst="rect">
-            <a:avLst/>
-          </a:prstGeom>
-          <a:noFill/>
-        </p:spPr>
-        <p:txBody>
-          <a:bodyPr wrap="square">
-            <a:spAutoFit/>
-          </a:bodyPr>
-          <a:lstStyle/>
-          <a:p>
-            <a:pPr algn="l"/>
-            <a:r>
-              <a:rPr sz="1600" b="1" i="0">
-                <a:solidFill>
-                  <a:srgbClr val="00E596"/>
-                </a:solidFill>
-              </a:rPr>
-              <a:t>✔</a:t>
-            </a:r>
-          </a:p>
-        </p:txBody>
-      </p:sp>
-      <p:sp>
-        <p:nvSpPr>
-          <p:cNvPr id="17" name="TextBox 16"/>
-          <p:cNvSpPr txBox="1"/>
-          <p:nvPr/>
-        </p:nvSpPr>
-        <p:spPr>
-          <a:xfrm>
-            <a:off x="749808" y="3282696"/>
-            <a:ext cx="4937760" cy="347472"/>
-          </a:xfrm>
-          <a:prstGeom prst="rect">
-            <a:avLst/>
-          </a:prstGeom>
-          <a:noFill/>
-        </p:spPr>
-        <p:txBody>
-          <a:bodyPr wrap="square">
-            <a:spAutoFit/>
-          </a:bodyPr>
-          <a:lstStyle/>
-          <a:p>
-            <a:pPr algn="l"/>
-            <a:r>
-              <a:rPr sz="1300" b="0" i="0">
-                <a:solidFill>
-                  <a:srgbClr val="FFFFFF"/>
-                </a:solidFill>
-              </a:rPr>
-              <a:t>Reagents with catalog numbers &amp; suppliers</a:t>
-            </a:r>
-          </a:p>
-        </p:txBody>
-      </p:sp>
-      <p:sp>
-        <p:nvSpPr>
-          <p:cNvPr id="18" name="TextBox 17"/>
-          <p:cNvSpPr txBox="1"/>
-          <p:nvPr/>
-        </p:nvSpPr>
-        <p:spPr>
-          <a:xfrm>
-            <a:off x="365760" y="3904488"/>
-            <a:ext cx="411480" cy="347472"/>
-          </a:xfrm>
-          <a:prstGeom prst="rect">
-            <a:avLst/>
-          </a:prstGeom>
-          <a:noFill/>
-        </p:spPr>
-        <p:txBody>
-          <a:bodyPr wrap="square">
-            <a:spAutoFit/>
-          </a:bodyPr>
-          <a:lstStyle/>
-          <a:p>
-            <a:pPr algn="l"/>
-            <a:r>
-              <a:rPr sz="1600" b="1" i="0">
-                <a:solidFill>
-                  <a:srgbClr val="00E596"/>
-                </a:solidFill>
-              </a:rPr>
-              <a:t>✔</a:t>
-            </a:r>
-          </a:p>
-        </p:txBody>
-      </p:sp>
-      <p:sp>
-        <p:nvSpPr>
-          <p:cNvPr id="19" name="TextBox 18"/>
-          <p:cNvSpPr txBox="1"/>
-          <p:nvPr/>
-        </p:nvSpPr>
-        <p:spPr>
-          <a:xfrm>
-            <a:off x="749808" y="3904488"/>
-            <a:ext cx="4937760" cy="347472"/>
-          </a:xfrm>
-          <a:prstGeom prst="rect">
-            <a:avLst/>
-          </a:prstGeom>
-          <a:noFill/>
-        </p:spPr>
-        <p:txBody>
-          <a:bodyPr wrap="square">
-            <a:spAutoFit/>
-          </a:bodyPr>
-          <a:lstStyle/>
-          <a:p>
-            <a:pPr algn="l"/>
-            <a:r>
-              <a:rPr sz="1300" b="0" i="0">
-                <a:solidFill>
-                  <a:srgbClr val="FFFFFF"/>
-                </a:solidFill>
-              </a:rPr>
-              <a:t>Realistic cost breakdown (line items)</a:t>
-            </a:r>
-          </a:p>
-        </p:txBody>
-      </p:sp>
-      <p:sp>
-        <p:nvSpPr>
-          <p:cNvPr id="20" name="TextBox 19"/>
-          <p:cNvSpPr txBox="1"/>
-          <p:nvPr/>
-        </p:nvSpPr>
-        <p:spPr>
-          <a:xfrm>
-            <a:off x="365760" y="4526280"/>
-            <a:ext cx="411480" cy="347472"/>
-          </a:xfrm>
-          <a:prstGeom prst="rect">
-            <a:avLst/>
-          </a:prstGeom>
-          <a:noFill/>
-        </p:spPr>
-        <p:txBody>
-          <a:bodyPr wrap="square">
-            <a:spAutoFit/>
-          </a:bodyPr>
-          <a:lstStyle/>
-          <a:p>
-            <a:pPr algn="l"/>
-            <a:r>
-              <a:rPr sz="1600" b="1" i="0">
-                <a:solidFill>
-                  <a:srgbClr val="00E596"/>
-                </a:solidFill>
-              </a:rPr>
-              <a:t>✔</a:t>
-            </a:r>
-          </a:p>
-        </p:txBody>
-      </p:sp>
-      <p:sp>
-        <p:nvSpPr>
-          <p:cNvPr id="21" name="TextBox 20"/>
-          <p:cNvSpPr txBox="1"/>
-          <p:nvPr/>
-        </p:nvSpPr>
-        <p:spPr>
-          <a:xfrm>
-            <a:off x="749808" y="4526280"/>
-            <a:ext cx="4937760" cy="347472"/>
-          </a:xfrm>
-          <a:prstGeom prst="rect">
-            <a:avLst/>
-          </a:prstGeom>
-          <a:noFill/>
-        </p:spPr>
-        <p:txBody>
-          <a:bodyPr wrap="square">
-            <a:spAutoFit/>
-          </a:bodyPr>
-          <a:lstStyle/>
-          <a:p>
-            <a:pPr algn="l"/>
-            <a:r>
-              <a:rPr sz="1300" b="0" i="0">
-                <a:solidFill>
-                  <a:srgbClr val="FFFFFF"/>
-                </a:solidFill>
-              </a:rPr>
-              <a:t>Phased timeline with dependencies</a:t>
-            </a:r>
-          </a:p>
-        </p:txBody>
-      </p:sp>
-      <p:sp>
-        <p:nvSpPr>
-          <p:cNvPr id="22" name="TextBox 21"/>
-          <p:cNvSpPr txBox="1"/>
-          <p:nvPr/>
-        </p:nvSpPr>
-        <p:spPr>
-          <a:xfrm>
-            <a:off x="365760" y="5148072"/>
-            <a:ext cx="411480" cy="347472"/>
-          </a:xfrm>
-          <a:prstGeom prst="rect">
-            <a:avLst/>
-          </a:prstGeom>
-          <a:noFill/>
-        </p:spPr>
-        <p:txBody>
-          <a:bodyPr wrap="square">
-            <a:spAutoFit/>
-          </a:bodyPr>
-          <a:lstStyle/>
-          <a:p>
-            <a:pPr algn="l"/>
-            <a:r>
-              <a:rPr sz="1600" b="1" i="0">
-                <a:solidFill>
-                  <a:srgbClr val="00E596"/>
-                </a:solidFill>
-              </a:rPr>
-              <a:t>✔</a:t>
-            </a:r>
-          </a:p>
-        </p:txBody>
-      </p:sp>
-      <p:sp>
-        <p:nvSpPr>
-          <p:cNvPr id="23" name="TextBox 22"/>
-          <p:cNvSpPr txBox="1"/>
-          <p:nvPr/>
-        </p:nvSpPr>
-        <p:spPr>
-          <a:xfrm>
-            <a:off x="749808" y="5148072"/>
-            <a:ext cx="4937760" cy="347472"/>
-          </a:xfrm>
-          <a:prstGeom prst="rect">
-            <a:avLst/>
-          </a:prstGeom>
-          <a:noFill/>
-        </p:spPr>
-        <p:txBody>
-          <a:bodyPr wrap="square">
-            <a:spAutoFit/>
-          </a:bodyPr>
-          <a:lstStyle/>
-          <a:p>
-            <a:pPr algn="l"/>
-            <a:r>
-              <a:rPr sz="1300" b="0" i="0">
-                <a:solidFill>
-                  <a:srgbClr val="FFFFFF"/>
-                </a:solidFill>
-              </a:rPr>
-              <a:t>Validation design — success/failure criteria</a:t>
-            </a:r>
-          </a:p>
-        </p:txBody>
-      </p:sp>
-      <p:sp>
-        <p:nvSpPr>
-          <p:cNvPr id="24" name="TextBox 23"/>
-          <p:cNvSpPr txBox="1"/>
-          <p:nvPr/>
-        </p:nvSpPr>
-        <p:spPr>
-          <a:xfrm>
-            <a:off x="365760" y="5769864"/>
-            <a:ext cx="411480" cy="347472"/>
-          </a:xfrm>
-          <a:prstGeom prst="rect">
-            <a:avLst/>
-          </a:prstGeom>
-          <a:noFill/>
-        </p:spPr>
-        <p:txBody>
-          <a:bodyPr wrap="square">
-            <a:spAutoFit/>
-          </a:bodyPr>
-          <a:lstStyle/>
-          <a:p>
-            <a:pPr algn="l"/>
-            <a:r>
-              <a:rPr sz="1600" b="1" i="0">
-                <a:solidFill>
-                  <a:srgbClr val="00E596"/>
-                </a:solidFill>
-              </a:rPr>
-              <a:t>✔</a:t>
-            </a:r>
-          </a:p>
-        </p:txBody>
-      </p:sp>
-      <p:sp>
-        <p:nvSpPr>
-          <p:cNvPr id="25" name="TextBox 24"/>
-          <p:cNvSpPr txBox="1"/>
-          <p:nvPr/>
-        </p:nvSpPr>
-        <p:spPr>
-          <a:xfrm>
-            <a:off x="749808" y="5769864"/>
-            <a:ext cx="4937760" cy="347472"/>
-          </a:xfrm>
-          <a:prstGeom prst="rect">
-            <a:avLst/>
-          </a:prstGeom>
-          <a:noFill/>
-        </p:spPr>
-        <p:txBody>
-          <a:bodyPr wrap="square">
-            <a:spAutoFit/>
-          </a:bodyPr>
-          <a:lstStyle/>
-          <a:p>
-            <a:pPr algn="l"/>
-            <a:r>
-              <a:rPr sz="1300" b="0" i="0">
-                <a:solidFill>
-                  <a:srgbClr val="FFFFFF"/>
-                </a:solidFill>
-              </a:rPr>
-              <a:t>Polished end-to-end UI</a:t>
-            </a:r>
-          </a:p>
-        </p:txBody>
-      </p:sp>
-      <p:sp>
-        <p:nvSpPr>
-          <p:cNvPr id="26" name="TextBox 25"/>
-          <p:cNvSpPr txBox="1"/>
-          <p:nvPr/>
-        </p:nvSpPr>
-        <p:spPr>
-          <a:xfrm>
-            <a:off x="6263640" y="1417320"/>
-            <a:ext cx="411480" cy="347472"/>
-          </a:xfrm>
-          <a:prstGeom prst="rect">
-            <a:avLst/>
-          </a:prstGeom>
-          <a:noFill/>
-        </p:spPr>
-        <p:txBody>
-          <a:bodyPr wrap="square">
-            <a:spAutoFit/>
-          </a:bodyPr>
-          <a:lstStyle/>
-          <a:p>
-            <a:pPr algn="l"/>
-            <a:r>
-              <a:rPr sz="1600" b="1" i="0">
-                <a:solidFill>
-                  <a:srgbClr val="00E596"/>
-                </a:solidFill>
-              </a:rPr>
-              <a:t>✔</a:t>
-            </a:r>
-          </a:p>
-        </p:txBody>
-      </p:sp>
-      <p:sp>
-        <p:nvSpPr>
-          <p:cNvPr id="27" name="TextBox 26"/>
-          <p:cNvSpPr txBox="1"/>
-          <p:nvPr/>
-        </p:nvSpPr>
-        <p:spPr>
-          <a:xfrm>
-            <a:off x="6647688" y="1417320"/>
-            <a:ext cx="4937760" cy="347472"/>
-          </a:xfrm>
-          <a:prstGeom prst="rect">
-            <a:avLst/>
-          </a:prstGeom>
-          <a:noFill/>
-        </p:spPr>
-        <p:txBody>
-          <a:bodyPr wrap="square">
-            <a:spAutoFit/>
-          </a:bodyPr>
-          <a:lstStyle/>
-          <a:p>
-            <a:pPr algn="l"/>
-            <a:r>
-              <a:rPr sz="1300" b="0" i="0">
-                <a:solidFill>
-                  <a:srgbClr val="FFFFFF"/>
-                </a:solidFill>
-              </a:rPr>
-              <a:t>Feedback loop — corrects future plans</a:t>
-            </a:r>
-          </a:p>
-        </p:txBody>
-      </p:sp>
-      <p:sp>
-        <p:nvSpPr>
-          <p:cNvPr id="28" name="TextBox 27"/>
-          <p:cNvSpPr txBox="1"/>
-          <p:nvPr/>
-        </p:nvSpPr>
-        <p:spPr>
-          <a:xfrm>
-            <a:off x="6647688" y="1664208"/>
-            <a:ext cx="4937760" cy="274320"/>
-          </a:xfrm>
-          <a:prstGeom prst="rect">
-            <a:avLst/>
-          </a:prstGeom>
-          <a:noFill/>
-        </p:spPr>
-        <p:txBody>
-          <a:bodyPr wrap="square">
-            <a:spAutoFit/>
-          </a:bodyPr>
-          <a:lstStyle/>
-          <a:p>
-            <a:pPr algn="l"/>
-            <a:r>
-              <a:rPr sz="1000" b="0" i="1">
-                <a:solidFill>
-                  <a:srgbClr val="00C2FF"/>
-                </a:solidFill>
-              </a:rPr>
-              <a:t>✔ Stretch goal fully implemented</a:t>
-            </a:r>
-          </a:p>
-        </p:txBody>
-      </p:sp>
-      <p:sp>
-        <p:nvSpPr>
-          <p:cNvPr id="29" name="TextBox 28"/>
-          <p:cNvSpPr txBox="1"/>
-          <p:nvPr/>
-        </p:nvSpPr>
-        <p:spPr>
-          <a:xfrm>
-            <a:off x="6263640" y="2304288"/>
-            <a:ext cx="411480" cy="347472"/>
-          </a:xfrm>
-          <a:prstGeom prst="rect">
-            <a:avLst/>
-          </a:prstGeom>
-          <a:noFill/>
-        </p:spPr>
-        <p:txBody>
-          <a:bodyPr wrap="square">
-            <a:spAutoFit/>
-          </a:bodyPr>
-          <a:lstStyle/>
-          <a:p>
-            <a:pPr algn="l"/>
-            <a:r>
-              <a:rPr sz="1600" b="1" i="0">
-                <a:solidFill>
-                  <a:srgbClr val="00E596"/>
-                </a:solidFill>
-              </a:rPr>
-              <a:t>✔</a:t>
-            </a:r>
-          </a:p>
-        </p:txBody>
-      </p:sp>
-      <p:sp>
-        <p:nvSpPr>
-          <p:cNvPr id="30" name="TextBox 29"/>
-          <p:cNvSpPr txBox="1"/>
-          <p:nvPr/>
-        </p:nvSpPr>
-        <p:spPr>
-          <a:xfrm>
-            <a:off x="6647688" y="2304288"/>
-            <a:ext cx="4937760" cy="347472"/>
-          </a:xfrm>
-          <a:prstGeom prst="rect">
-            <a:avLst/>
-          </a:prstGeom>
-          <a:noFill/>
-        </p:spPr>
-        <p:txBody>
-          <a:bodyPr wrap="square">
-            <a:spAutoFit/>
-          </a:bodyPr>
-          <a:lstStyle/>
-          <a:p>
-            <a:pPr algn="l"/>
-            <a:r>
-              <a:rPr sz="1300" b="0" i="0">
-                <a:solidFill>
-                  <a:srgbClr val="FFFFFF"/>
-                </a:solidFill>
-              </a:rPr>
-              <a:t>Plan critique — finds own weaknesses</a:t>
-            </a:r>
-          </a:p>
-        </p:txBody>
-      </p:sp>
-      <p:sp>
-        <p:nvSpPr>
-          <p:cNvPr id="31" name="TextBox 30"/>
-          <p:cNvSpPr txBox="1"/>
-          <p:nvPr/>
-        </p:nvSpPr>
-        <p:spPr>
-          <a:xfrm>
-            <a:off x="6647688" y="2551176"/>
-            <a:ext cx="4937760" cy="274320"/>
-          </a:xfrm>
-          <a:prstGeom prst="rect">
-            <a:avLst/>
-          </a:prstGeom>
-          <a:noFill/>
-        </p:spPr>
-        <p:txBody>
-          <a:bodyPr wrap="square">
-            <a:spAutoFit/>
-          </a:bodyPr>
-          <a:lstStyle/>
-          <a:p>
-            <a:pPr algn="l"/>
-            <a:r>
-              <a:rPr sz="1000" b="0" i="1">
-                <a:solidFill>
-                  <a:srgbClr val="00C2FF"/>
-                </a:solidFill>
-              </a:rPr>
-              <a:t>✔ Beyond the brief</a:t>
-            </a:r>
-          </a:p>
-        </p:txBody>
-      </p:sp>
-      <p:sp>
-        <p:nvSpPr>
-          <p:cNvPr id="32" name="TextBox 31"/>
-          <p:cNvSpPr txBox="1"/>
-          <p:nvPr/>
-        </p:nvSpPr>
-        <p:spPr>
-          <a:xfrm>
-            <a:off x="6263640" y="3191256"/>
-            <a:ext cx="411480" cy="347472"/>
-          </a:xfrm>
-          <a:prstGeom prst="rect">
-            <a:avLst/>
-          </a:prstGeom>
-          <a:noFill/>
-        </p:spPr>
-        <p:txBody>
-          <a:bodyPr wrap="square">
-            <a:spAutoFit/>
-          </a:bodyPr>
-          <a:lstStyle/>
-          <a:p>
-            <a:pPr algn="l"/>
-            <a:r>
-              <a:rPr sz="1600" b="1" i="0">
-                <a:solidFill>
-                  <a:srgbClr val="00E596"/>
-                </a:solidFill>
-              </a:rPr>
-              <a:t>✔</a:t>
-            </a:r>
-          </a:p>
-        </p:txBody>
-      </p:sp>
-      <p:sp>
-        <p:nvSpPr>
-          <p:cNvPr id="33" name="TextBox 32"/>
-          <p:cNvSpPr txBox="1"/>
-          <p:nvPr/>
-        </p:nvSpPr>
-        <p:spPr>
-          <a:xfrm>
-            <a:off x="6647688" y="3191256"/>
-            <a:ext cx="4937760" cy="347472"/>
-          </a:xfrm>
-          <a:prstGeom prst="rect">
-            <a:avLst/>
-          </a:prstGeom>
-          <a:noFill/>
-        </p:spPr>
-        <p:txBody>
-          <a:bodyPr wrap="square">
-            <a:spAutoFit/>
-          </a:bodyPr>
-          <a:lstStyle/>
-          <a:p>
-            <a:pPr algn="l"/>
-            <a:r>
-              <a:rPr sz="1300" b="0" i="0">
-                <a:solidFill>
-                  <a:srgbClr val="FFFFFF"/>
-                </a:solidFill>
-              </a:rPr>
-              <a:t>Risk profile per plan + safety hard-blocks</a:t>
-            </a:r>
-          </a:p>
-        </p:txBody>
-      </p:sp>
-      <p:sp>
-        <p:nvSpPr>
-          <p:cNvPr id="34" name="TextBox 33"/>
-          <p:cNvSpPr txBox="1"/>
-          <p:nvPr/>
-        </p:nvSpPr>
-        <p:spPr>
-          <a:xfrm>
-            <a:off x="6647688" y="3438144"/>
-            <a:ext cx="4937760" cy="274320"/>
-          </a:xfrm>
-          <a:prstGeom prst="rect">
-            <a:avLst/>
-          </a:prstGeom>
-          <a:noFill/>
-        </p:spPr>
-        <p:txBody>
-          <a:bodyPr wrap="square">
-            <a:spAutoFit/>
-          </a:bodyPr>
-          <a:lstStyle/>
-          <a:p>
-            <a:pPr algn="l"/>
-            <a:r>
-              <a:rPr sz="1000" b="0" i="1">
-                <a:solidFill>
-                  <a:srgbClr val="00C2FF"/>
-                </a:solidFill>
-              </a:rPr>
-              <a:t>✔ Beyond the brief</a:t>
-            </a:r>
-          </a:p>
-        </p:txBody>
-      </p:sp>
-      <p:sp>
-        <p:nvSpPr>
-          <p:cNvPr id="35" name="TextBox 34"/>
-          <p:cNvSpPr txBox="1"/>
-          <p:nvPr/>
-        </p:nvSpPr>
-        <p:spPr>
-          <a:xfrm>
-            <a:off x="6263640" y="4078224"/>
-            <a:ext cx="411480" cy="347472"/>
-          </a:xfrm>
-          <a:prstGeom prst="rect">
-            <a:avLst/>
-          </a:prstGeom>
-          <a:noFill/>
-        </p:spPr>
-        <p:txBody>
-          <a:bodyPr wrap="square">
-            <a:spAutoFit/>
-          </a:bodyPr>
-          <a:lstStyle/>
-          <a:p>
-            <a:pPr algn="l"/>
-            <a:r>
-              <a:rPr sz="1600" b="1" i="0">
-                <a:solidFill>
-                  <a:srgbClr val="00E596"/>
-                </a:solidFill>
-              </a:rPr>
-              <a:t>✔</a:t>
-            </a:r>
-          </a:p>
-        </p:txBody>
-      </p:sp>
-      <p:sp>
-        <p:nvSpPr>
-          <p:cNvPr id="36" name="TextBox 35"/>
-          <p:cNvSpPr txBox="1"/>
-          <p:nvPr/>
-        </p:nvSpPr>
-        <p:spPr>
-          <a:xfrm>
-            <a:off x="6647688" y="4078224"/>
-            <a:ext cx="4937760" cy="347472"/>
-          </a:xfrm>
-          <a:prstGeom prst="rect">
-            <a:avLst/>
-          </a:prstGeom>
-          <a:noFill/>
-        </p:spPr>
-        <p:txBody>
-          <a:bodyPr wrap="square">
-            <a:spAutoFit/>
-          </a:bodyPr>
-          <a:lstStyle/>
-          <a:p>
-            <a:pPr algn="l"/>
-            <a:r>
-              <a:rPr sz="1300" b="0" i="0">
-                <a:solidFill>
-                  <a:srgbClr val="FFFFFF"/>
-                </a:solidFill>
-              </a:rPr>
-              <a:t>Composite confidence score</a:t>
-            </a:r>
-          </a:p>
-        </p:txBody>
-      </p:sp>
-      <p:sp>
-        <p:nvSpPr>
-          <p:cNvPr id="37" name="TextBox 36"/>
-          <p:cNvSpPr txBox="1"/>
-          <p:nvPr/>
-        </p:nvSpPr>
-        <p:spPr>
-          <a:xfrm>
-            <a:off x="6647688" y="4325112"/>
-            <a:ext cx="4937760" cy="274320"/>
-          </a:xfrm>
-          <a:prstGeom prst="rect">
-            <a:avLst/>
-          </a:prstGeom>
-          <a:noFill/>
-        </p:spPr>
-        <p:txBody>
-          <a:bodyPr wrap="square">
-            <a:spAutoFit/>
-          </a:bodyPr>
-          <a:lstStyle/>
-          <a:p>
-            <a:pPr algn="l"/>
-            <a:r>
-              <a:rPr sz="1000" b="0" i="1">
-                <a:solidFill>
-                  <a:srgbClr val="00C2FF"/>
-                </a:solidFill>
-              </a:rPr>
-              <a:t>✔ Beyond the brief</a:t>
-            </a:r>
-          </a:p>
-        </p:txBody>
-      </p:sp>
-      <p:sp>
-        <p:nvSpPr>
-          <p:cNvPr id="38" name="TextBox 37"/>
-          <p:cNvSpPr txBox="1"/>
-          <p:nvPr/>
-        </p:nvSpPr>
-        <p:spPr>
-          <a:xfrm>
-            <a:off x="6263640" y="4965192"/>
-            <a:ext cx="411480" cy="347472"/>
-          </a:xfrm>
-          <a:prstGeom prst="rect">
-            <a:avLst/>
-          </a:prstGeom>
-          <a:noFill/>
-        </p:spPr>
-        <p:txBody>
-          <a:bodyPr wrap="square">
-            <a:spAutoFit/>
-          </a:bodyPr>
-          <a:lstStyle/>
-          <a:p>
-            <a:pPr algn="l"/>
-            <a:r>
-              <a:rPr sz="1600" b="1" i="0">
-                <a:solidFill>
-                  <a:srgbClr val="00E596"/>
-                </a:solidFill>
-              </a:rPr>
-              <a:t>✔</a:t>
-            </a:r>
-          </a:p>
-        </p:txBody>
-      </p:sp>
-      <p:sp>
-        <p:nvSpPr>
-          <p:cNvPr id="39" name="TextBox 38"/>
-          <p:cNvSpPr txBox="1"/>
-          <p:nvPr/>
-        </p:nvSpPr>
-        <p:spPr>
-          <a:xfrm>
-            <a:off x="6647688" y="4965192"/>
-            <a:ext cx="4937760" cy="347472"/>
-          </a:xfrm>
-          <a:prstGeom prst="rect">
-            <a:avLst/>
-          </a:prstGeom>
-          <a:noFill/>
-        </p:spPr>
-        <p:txBody>
-          <a:bodyPr wrap="square">
-            <a:spAutoFit/>
-          </a:bodyPr>
-          <a:lstStyle/>
-          <a:p>
-            <a:pPr algn="l"/>
-            <a:r>
-              <a:rPr sz="1300" b="0" i="0">
-                <a:solidFill>
-                  <a:srgbClr val="FFFFFF"/>
-                </a:solidFill>
-              </a:rPr>
-              <a:t>Evidence drilldown cards</a:t>
-            </a:r>
-          </a:p>
-        </p:txBody>
-      </p:sp>
-      <p:sp>
-        <p:nvSpPr>
-          <p:cNvPr id="40" name="TextBox 39"/>
-          <p:cNvSpPr txBox="1"/>
-          <p:nvPr/>
-        </p:nvSpPr>
-        <p:spPr>
-          <a:xfrm>
-            <a:off x="6647688" y="5212079"/>
-            <a:ext cx="4937760" cy="274320"/>
-          </a:xfrm>
-          <a:prstGeom prst="rect">
-            <a:avLst/>
-          </a:prstGeom>
-          <a:noFill/>
-        </p:spPr>
-        <p:txBody>
-          <a:bodyPr wrap="square">
-            <a:spAutoFit/>
-          </a:bodyPr>
-          <a:lstStyle/>
-          <a:p>
-            <a:pPr algn="l"/>
-            <a:r>
-              <a:rPr sz="1000" b="0" i="1">
-                <a:solidFill>
-                  <a:srgbClr val="00C2FF"/>
-                </a:solidFill>
-              </a:rPr>
-              <a:t>✔ Beyond the brief</a:t>
-            </a:r>
-          </a:p>
-        </p:txBody>
-      </p:sp>
-      <p:sp>
-        <p:nvSpPr>
-          <p:cNvPr id="41" name="TextBox 40"/>
-          <p:cNvSpPr txBox="1"/>
-          <p:nvPr/>
-        </p:nvSpPr>
-        <p:spPr>
-          <a:xfrm>
-            <a:off x="6263640" y="5852159"/>
-            <a:ext cx="411480" cy="347472"/>
-          </a:xfrm>
-          <a:prstGeom prst="rect">
-            <a:avLst/>
-          </a:prstGeom>
-          <a:noFill/>
-        </p:spPr>
-        <p:txBody>
-          <a:bodyPr wrap="square">
-            <a:spAutoFit/>
-          </a:bodyPr>
-          <a:lstStyle/>
-          <a:p>
-            <a:pPr algn="l"/>
-            <a:r>
-              <a:rPr sz="1600" b="1" i="0">
-                <a:solidFill>
-                  <a:srgbClr val="CCD6E0"/>
-                </a:solidFill>
-              </a:rPr>
-              <a:t>○</a:t>
-            </a:r>
-          </a:p>
-        </p:txBody>
-      </p:sp>
-      <p:sp>
-        <p:nvSpPr>
-          <p:cNvPr id="42" name="TextBox 41"/>
-          <p:cNvSpPr txBox="1"/>
-          <p:nvPr/>
-        </p:nvSpPr>
-        <p:spPr>
-          <a:xfrm>
-            <a:off x="6647688" y="5852159"/>
-            <a:ext cx="4937760" cy="347472"/>
-          </a:xfrm>
-          <a:prstGeom prst="rect">
-            <a:avLst/>
-          </a:prstGeom>
-          <a:noFill/>
-        </p:spPr>
-        <p:txBody>
-          <a:bodyPr wrap="square">
-            <a:spAutoFit/>
-          </a:bodyPr>
-          <a:lstStyle/>
-          <a:p>
-            <a:pPr algn="l"/>
-            <a:r>
-              <a:rPr sz="1300" b="0" i="0">
-                <a:solidFill>
-                  <a:srgbClr val="CCD6E0"/>
-                </a:solidFill>
-              </a:rPr>
-              <a:t>Upload own experimental data</a:t>
-            </a:r>
-          </a:p>
-        </p:txBody>
-      </p:sp>
-      <p:sp>
-        <p:nvSpPr>
-          <p:cNvPr id="43" name="TextBox 42"/>
-          <p:cNvSpPr txBox="1"/>
-          <p:nvPr/>
-        </p:nvSpPr>
-        <p:spPr>
-          <a:xfrm>
-            <a:off x="6647688" y="6099048"/>
-            <a:ext cx="4937760" cy="274320"/>
-          </a:xfrm>
-          <a:prstGeom prst="rect">
-            <a:avLst/>
-          </a:prstGeom>
-          <a:noFill/>
-        </p:spPr>
-        <p:txBody>
-          <a:bodyPr wrap="square">
-            <a:spAutoFit/>
-          </a:bodyPr>
-          <a:lstStyle/>
-          <a:p>
-            <a:pPr algn="l"/>
-            <a:r>
-              <a:rPr sz="1000" b="0" i="1">
-                <a:solidFill>
-                  <a:srgbClr val="00C2FF"/>
-                </a:solidFill>
-              </a:rPr>
-              <a:t>○ Architecture ready — coming soon</a:t>
-            </a:r>
-          </a:p>
-        </p:txBody>
-      </p:sp>
-    </p:spTree>
-  </p:cSld>
-  <p:clrMapOvr>
-    <a:masterClrMapping/>
-  </p:clrMapOvr>
-</p:sld>
-</file>
-
-<file path=ppt/slides/slide5.xml><?xml version="1.0" encoding="utf-8"?>
-<p:sld xmlns:a="http://schemas.openxmlformats.org/drawingml/2006/main" xmlns:p="http://schemas.openxmlformats.org/presentationml/2006/main" xmlns:r="http://schemas.openxmlformats.org/officeDocument/2006/relationships">
-  <p:cSld>
-    <p:bg>
-      <p:bgPr>
-        <a:solidFill>
-          <a:srgbClr val="0D1B2A"/>
-        </a:solidFill>
-        <a:effectLst/>
-      </p:bgPr>
-    </p:bg>
-    <p:spTree>
-      <p:nvGrpSpPr>
-        <p:cNvPr id="1" name=""/>
-        <p:cNvGrpSpPr/>
-        <p:nvPr/>
-      </p:nvGrpSpPr>
-      <p:grpSpPr/>
-      <p:sp>
-        <p:nvSpPr>
-          <p:cNvPr id="2" name="Rectangle 1"/>
-          <p:cNvSpPr/>
-          <p:nvPr/>
-        </p:nvSpPr>
-        <p:spPr>
-          <a:xfrm>
-            <a:off x="0" y="0"/>
-            <a:ext cx="12188952" cy="91440"/>
-          </a:xfrm>
-          <a:prstGeom prst="rect">
-            <a:avLst/>
-          </a:prstGeom>
-          <a:solidFill>
-            <a:srgbClr val="00C2FF"/>
-          </a:solidFill>
-          <a:ln>
-            <a:noFill/>
-          </a:ln>
-        </p:spPr>
-        <p:style>
-          <a:lnRef idx="1">
-            <a:schemeClr val="accent1"/>
-          </a:lnRef>
-          <a:fillRef idx="3">
-            <a:schemeClr val="accent1"/>
-          </a:fillRef>
-          <a:effectRef idx="2">
-            <a:schemeClr val="accent1"/>
-          </a:effectRef>
-          <a:fontRef idx="minor">
-            <a:schemeClr val="lt1"/>
-          </a:fontRef>
-        </p:style>
-        <p:txBody>
-          <a:bodyPr rtlCol="0" anchor="ctr"/>
-          <a:lstStyle/>
-          <a:p>
-            <a:pPr algn="ctr"/>
-          </a:p>
-        </p:txBody>
-      </p:sp>
-      <p:sp>
-        <p:nvSpPr>
-          <p:cNvPr id="3" name="Rectangle 2"/>
-          <p:cNvSpPr/>
-          <p:nvPr/>
-        </p:nvSpPr>
-        <p:spPr>
-          <a:xfrm>
-            <a:off x="0" y="6766560"/>
-            <a:ext cx="12188952" cy="91440"/>
-          </a:xfrm>
-          <a:prstGeom prst="rect">
-            <a:avLst/>
-          </a:prstGeom>
-          <a:solidFill>
-            <a:srgbClr val="00C2FF"/>
-          </a:solidFill>
-          <a:ln>
-            <a:noFill/>
-          </a:ln>
-        </p:spPr>
-        <p:style>
-          <a:lnRef idx="1">
-            <a:schemeClr val="accent1"/>
-          </a:lnRef>
-          <a:fillRef idx="3">
-            <a:schemeClr val="accent1"/>
-          </a:fillRef>
-          <a:effectRef idx="2">
-            <a:schemeClr val="accent1"/>
-          </a:effectRef>
-          <a:fontRef idx="minor">
-            <a:schemeClr val="lt1"/>
-          </a:fontRef>
-        </p:style>
-        <p:txBody>
-          <a:bodyPr rtlCol="0" anchor="ctr"/>
-          <a:lstStyle/>
-          <a:p>
-            <a:pPr algn="ctr"/>
-          </a:p>
-        </p:txBody>
-      </p:sp>
-      <p:sp>
-        <p:nvSpPr>
-          <p:cNvPr id="4" name="TextBox 3"/>
-          <p:cNvSpPr txBox="1"/>
-          <p:nvPr/>
-        </p:nvSpPr>
-        <p:spPr>
-          <a:xfrm>
-            <a:off x="457200" y="164592"/>
-            <a:ext cx="10972800" cy="548640"/>
-          </a:xfrm>
-          <a:prstGeom prst="rect">
-            <a:avLst/>
-          </a:prstGeom>
-          <a:noFill/>
-        </p:spPr>
-        <p:txBody>
-          <a:bodyPr wrap="square">
-            <a:spAutoFit/>
-          </a:bodyPr>
-          <a:lstStyle/>
-          <a:p>
-            <a:pPr algn="l"/>
-            <a:r>
-              <a:rPr sz="3200" b="1" i="0">
-                <a:solidFill>
-                  <a:srgbClr val="FFFFFF"/>
-                </a:solidFill>
-              </a:rPr>
-              <a:t>WHAT WE DID BETTER THAN THE REQUIREMENTS</a:t>
-            </a:r>
-          </a:p>
-        </p:txBody>
-      </p:sp>
-      <p:sp>
-        <p:nvSpPr>
-          <p:cNvPr id="5" name="Rectangle 4"/>
-          <p:cNvSpPr/>
-          <p:nvPr/>
-        </p:nvSpPr>
-        <p:spPr>
-          <a:xfrm>
-            <a:off x="457200" y="749808"/>
-            <a:ext cx="1097280" cy="64008"/>
-          </a:xfrm>
-          <a:prstGeom prst="rect">
-            <a:avLst/>
-          </a:prstGeom>
-          <a:solidFill>
-            <a:srgbClr val="00C2FF"/>
-          </a:solidFill>
-          <a:ln>
-            <a:noFill/>
-          </a:ln>
-        </p:spPr>
-        <p:style>
-          <a:lnRef idx="1">
-            <a:schemeClr val="accent1"/>
-          </a:lnRef>
-          <a:fillRef idx="3">
-            <a:schemeClr val="accent1"/>
-          </a:fillRef>
-          <a:effectRef idx="2">
-            <a:schemeClr val="accent1"/>
-          </a:effectRef>
-          <a:fontRef idx="minor">
-            <a:schemeClr val="lt1"/>
-          </a:fontRef>
-        </p:style>
-        <p:txBody>
-          <a:bodyPr rtlCol="0" anchor="ctr"/>
-          <a:lstStyle/>
-          <a:p>
-            <a:pPr algn="ctr"/>
-          </a:p>
-        </p:txBody>
-      </p:sp>
-      <p:sp>
-        <p:nvSpPr>
-          <p:cNvPr id="6" name="Rectangle 5"/>
-          <p:cNvSpPr/>
-          <p:nvPr/>
-        </p:nvSpPr>
-        <p:spPr>
-          <a:xfrm>
-            <a:off x="365760" y="960120"/>
             <a:ext cx="5212080" cy="365760"/>
           </a:xfrm>
           <a:prstGeom prst="rect">
@@ -7145,7 +5692,7 @@
         <p:spPr>
           <a:xfrm>
             <a:off x="365760" y="1417320"/>
-            <a:ext cx="11430000" cy="640080"/>
+            <a:ext cx="11430000" cy="576072"/>
           </a:xfrm>
           <a:prstGeom prst="rect">
             <a:avLst/>
@@ -7187,8 +5734,8 @@
         </p:nvSpPr>
         <p:spPr>
           <a:xfrm>
-            <a:off x="502920" y="1508760"/>
-            <a:ext cx="5120640" cy="475488"/>
+            <a:off x="502920" y="1517904"/>
+            <a:ext cx="5120640" cy="402336"/>
           </a:xfrm>
           <a:prstGeom prst="rect">
             <a:avLst/>
@@ -7221,8 +5768,8 @@
         </p:nvSpPr>
         <p:spPr>
           <a:xfrm>
-            <a:off x="5760720" y="1508760"/>
-            <a:ext cx="6126480" cy="475488"/>
+            <a:off x="5760720" y="1517904"/>
+            <a:ext cx="6126480" cy="402336"/>
           </a:xfrm>
           <a:prstGeom prst="rect">
             <a:avLst/>
@@ -7242,8 +5789,7 @@
                   <a:srgbClr val="00E596"/>
                 </a:solidFill>
               </a:rPr>
-              <a:t>6-source search (Scholar · arXiv · PubMed · OpenAlex · protocols.io · Tavily)
-Smart domain filtering · re-ranking · de-duplication · coverage diagnostics</a:t>
+              <a:t>6-source parallel search · domain filtering · Jaccard re-ranking · de-duplication</a:t>
             </a:r>
           </a:p>
         </p:txBody>
@@ -7256,8 +5802,8 @@
         </p:nvSpPr>
         <p:spPr>
           <a:xfrm>
-            <a:off x="365760" y="2075688"/>
-            <a:ext cx="11430000" cy="640080"/>
+            <a:off x="365760" y="2016252"/>
+            <a:ext cx="11430000" cy="576072"/>
           </a:xfrm>
           <a:prstGeom prst="rect">
             <a:avLst/>
@@ -7299,8 +5845,8 @@
         </p:nvSpPr>
         <p:spPr>
           <a:xfrm>
-            <a:off x="502920" y="2167128"/>
-            <a:ext cx="5120640" cy="475488"/>
+            <a:off x="502920" y="2116836"/>
+            <a:ext cx="5120640" cy="402336"/>
           </a:xfrm>
           <a:prstGeom prst="rect">
             <a:avLst/>
@@ -7333,8 +5879,8 @@
         </p:nvSpPr>
         <p:spPr>
           <a:xfrm>
-            <a:off x="5760720" y="2167128"/>
-            <a:ext cx="6126480" cy="475488"/>
+            <a:off x="5760720" y="2116836"/>
+            <a:ext cx="6126480" cy="402336"/>
           </a:xfrm>
           <a:prstGeom prst="rect">
             <a:avLst/>
@@ -7354,8 +5900,7 @@
                   <a:srgbClr val="00E596"/>
                 </a:solidFill>
               </a:rPr>
-              <a:t>Protocol + AI CRITIC evaluates its own output for 6 weakness categories:
-controls · statistics · sample size · validation · safety · feasibility</a:t>
+              <a:t>Protocol + AI CRITIC: 6 weakness categories audited after every generation</a:t>
             </a:r>
           </a:p>
         </p:txBody>
@@ -7368,8 +5913,8 @@
         </p:nvSpPr>
         <p:spPr>
           <a:xfrm>
-            <a:off x="365760" y="2734056"/>
-            <a:ext cx="11430000" cy="640080"/>
+            <a:off x="365760" y="2615184"/>
+            <a:ext cx="11430000" cy="576072"/>
           </a:xfrm>
           <a:prstGeom prst="rect">
             <a:avLst/>
@@ -7411,8 +5956,8 @@
         </p:nvSpPr>
         <p:spPr>
           <a:xfrm>
-            <a:off x="502920" y="2825496"/>
-            <a:ext cx="5120640" cy="475488"/>
+            <a:off x="502920" y="2715768"/>
+            <a:ext cx="5120640" cy="402336"/>
           </a:xfrm>
           <a:prstGeom prst="rect">
             <a:avLst/>
@@ -7445,8 +5990,8 @@
         </p:nvSpPr>
         <p:spPr>
           <a:xfrm>
-            <a:off x="5760720" y="2825496"/>
-            <a:ext cx="6126480" cy="475488"/>
+            <a:off x="5760720" y="2715768"/>
+            <a:ext cx="6126480" cy="402336"/>
           </a:xfrm>
           <a:prstGeom prst="rect">
             <a:avLst/>
@@ -7466,8 +6011,7 @@
                   <a:srgbClr val="00E596"/>
                 </a:solidFill>
               </a:rPr>
-              <a:t>Per-material Tavily search · regex fact extraction from supplier pages
-AI price estimation tagged [approx_estimate] — never fabricates</a:t>
+              <a:t>Tavily supplier search + regex extraction of prices, pack sizes, catalog numbers</a:t>
             </a:r>
           </a:p>
         </p:txBody>
@@ -7480,8 +6024,8 @@
         </p:nvSpPr>
         <p:spPr>
           <a:xfrm>
-            <a:off x="365760" y="3392424"/>
-            <a:ext cx="11430000" cy="640080"/>
+            <a:off x="365760" y="3214116"/>
+            <a:ext cx="11430000" cy="576072"/>
           </a:xfrm>
           <a:prstGeom prst="rect">
             <a:avLst/>
@@ -7523,8 +6067,8 @@
         </p:nvSpPr>
         <p:spPr>
           <a:xfrm>
-            <a:off x="502920" y="3483864"/>
-            <a:ext cx="5120640" cy="475488"/>
+            <a:off x="502920" y="3314700"/>
+            <a:ext cx="5120640" cy="402336"/>
           </a:xfrm>
           <a:prstGeom prst="rect">
             <a:avLst/>
@@ -7557,8 +6101,8 @@
         </p:nvSpPr>
         <p:spPr>
           <a:xfrm>
-            <a:off x="5760720" y="3483864"/>
-            <a:ext cx="6126480" cy="475488"/>
+            <a:off x="5760720" y="3314700"/>
+            <a:ext cx="6126480" cy="402336"/>
           </a:xfrm>
           <a:prstGeom prst="rect">
             <a:avLst/>
@@ -7578,7 +6122,7 @@
                   <a:srgbClr val="00E596"/>
                 </a:solidFill>
               </a:rPr>
-              <a:t>Timeline with decision gates · schedule risks per phase · dependencies</a:t>
+              <a:t>Timeline with decision gates · schedule risks · dependencies per phase</a:t>
             </a:r>
           </a:p>
         </p:txBody>
@@ -7591,8 +6135,8 @@
         </p:nvSpPr>
         <p:spPr>
           <a:xfrm>
-            <a:off x="365760" y="4050791"/>
-            <a:ext cx="11430000" cy="640080"/>
+            <a:off x="365760" y="3813048"/>
+            <a:ext cx="11430000" cy="576072"/>
           </a:xfrm>
           <a:prstGeom prst="rect">
             <a:avLst/>
@@ -7634,8 +6178,8 @@
         </p:nvSpPr>
         <p:spPr>
           <a:xfrm>
-            <a:off x="502920" y="4142231"/>
-            <a:ext cx="5120640" cy="475488"/>
+            <a:off x="502920" y="3913632"/>
+            <a:ext cx="5120640" cy="402336"/>
           </a:xfrm>
           <a:prstGeom prst="rect">
             <a:avLst/>
@@ -7668,8 +6212,8 @@
         </p:nvSpPr>
         <p:spPr>
           <a:xfrm>
-            <a:off x="5760720" y="4142231"/>
-            <a:ext cx="6126480" cy="475488"/>
+            <a:off x="5760720" y="3913632"/>
+            <a:ext cx="6126480" cy="402336"/>
           </a:xfrm>
           <a:prstGeom prst="rect">
             <a:avLst/>
@@ -7686,11 +6230,10 @@
             <a:r>
               <a:rPr sz="1100" b="0" i="0">
                 <a:solidFill>
-                  <a:srgbClr val="00C2FF"/>
+                  <a:srgbClr val="05C48A"/>
                 </a:solidFill>
               </a:rPr>
-              <a:t>✔  Full RAG pipeline: correction → Gemini 768-dim embedding → Supabase pgvector
-   match_experiments() cosine search → few-shot context in next plan</a:t>
+              <a:t>✔  3-bucket RAG: org / category / experiment scope · Gemini embeddings · Supabase pgvector</a:t>
             </a:r>
           </a:p>
         </p:txBody>
@@ -7703,8 +6246,8 @@
         </p:nvSpPr>
         <p:spPr>
           <a:xfrm>
-            <a:off x="365760" y="4709159"/>
-            <a:ext cx="11430000" cy="640080"/>
+            <a:off x="365760" y="4411980"/>
+            <a:ext cx="11430000" cy="576072"/>
           </a:xfrm>
           <a:prstGeom prst="rect">
             <a:avLst/>
@@ -7746,8 +6289,8 @@
         </p:nvSpPr>
         <p:spPr>
           <a:xfrm>
-            <a:off x="502920" y="4800599"/>
-            <a:ext cx="5120640" cy="475488"/>
+            <a:off x="502920" y="4512564"/>
+            <a:ext cx="5120640" cy="402336"/>
           </a:xfrm>
           <a:prstGeom prst="rect">
             <a:avLst/>
@@ -7764,10 +6307,10 @@
             <a:r>
               <a:rPr sz="1100" b="0" i="1">
                 <a:solidFill>
-                  <a:srgbClr val="8899AA"/>
+                  <a:srgbClr val="778899"/>
                 </a:solidFill>
               </a:rPr>
-              <a:t>(Not in brief)  —</a:t>
+              <a:t>(Not in brief)</a:t>
             </a:r>
           </a:p>
         </p:txBody>
@@ -7780,8 +6323,8 @@
         </p:nvSpPr>
         <p:spPr>
           <a:xfrm>
-            <a:off x="5760720" y="4800599"/>
-            <a:ext cx="6126480" cy="475488"/>
+            <a:off x="5760720" y="4512564"/>
+            <a:ext cx="6126480" cy="402336"/>
           </a:xfrm>
           <a:prstGeom prst="rect">
             <a:avLst/>
@@ -7801,7 +6344,7 @@
                   <a:srgbClr val="00C2FF"/>
                 </a:solidFill>
               </a:rPr>
-              <a:t>Multi-model: OpenAI GPT-4o · Google Gemini · Claude for redundancy &amp; best-fit tasks</a:t>
+              <a:t>Document upload: PDF/TXT/MD · extracted &amp; injected · org-scope + experiment-scope</a:t>
             </a:r>
           </a:p>
         </p:txBody>
@@ -7814,8 +6357,8 @@
         </p:nvSpPr>
         <p:spPr>
           <a:xfrm>
-            <a:off x="365760" y="5367528"/>
-            <a:ext cx="11430000" cy="640080"/>
+            <a:off x="365760" y="5010912"/>
+            <a:ext cx="11430000" cy="576072"/>
           </a:xfrm>
           <a:prstGeom prst="rect">
             <a:avLst/>
@@ -7857,8 +6400,8 @@
         </p:nvSpPr>
         <p:spPr>
           <a:xfrm>
-            <a:off x="502920" y="5458968"/>
-            <a:ext cx="5120640" cy="475488"/>
+            <a:off x="502920" y="5111496"/>
+            <a:ext cx="5120640" cy="402336"/>
           </a:xfrm>
           <a:prstGeom prst="rect">
             <a:avLst/>
@@ -7875,10 +6418,10 @@
             <a:r>
               <a:rPr sz="1100" b="0" i="1">
                 <a:solidFill>
-                  <a:srgbClr val="8899AA"/>
+                  <a:srgbClr val="778899"/>
                 </a:solidFill>
               </a:rPr>
-              <a:t>(Not in brief)  —</a:t>
+              <a:t>(Not in brief)</a:t>
             </a:r>
           </a:p>
         </p:txBody>
@@ -7891,8 +6434,8 @@
         </p:nvSpPr>
         <p:spPr>
           <a:xfrm>
-            <a:off x="5760720" y="5458968"/>
-            <a:ext cx="6126480" cy="475488"/>
+            <a:off x="5760720" y="5111496"/>
+            <a:ext cx="6126480" cy="402336"/>
           </a:xfrm>
           <a:prstGeom prst="rect">
             <a:avLst/>
@@ -7912,7 +6455,7 @@
                   <a:srgbClr val="00C2FF"/>
                 </a:solidFill>
               </a:rPr>
-              <a:t>User-specific risk profile: hard-blocks · soft-flags · expert-review gates per plan</a:t>
+              <a:t>Persistent experiment library · named plans · Save + Regenerate workflow</a:t>
             </a:r>
           </a:p>
         </p:txBody>
@@ -7925,8 +6468,8 @@
         </p:nvSpPr>
         <p:spPr>
           <a:xfrm>
-            <a:off x="365760" y="6025896"/>
-            <a:ext cx="11430000" cy="640080"/>
+            <a:off x="365760" y="5609844"/>
+            <a:ext cx="11430000" cy="576072"/>
           </a:xfrm>
           <a:prstGeom prst="rect">
             <a:avLst/>
@@ -7968,8 +6511,8 @@
         </p:nvSpPr>
         <p:spPr>
           <a:xfrm>
-            <a:off x="502920" y="6117336"/>
-            <a:ext cx="5120640" cy="475488"/>
+            <a:off x="502920" y="5710428"/>
+            <a:ext cx="5120640" cy="402336"/>
           </a:xfrm>
           <a:prstGeom prst="rect">
             <a:avLst/>
@@ -7986,10 +6529,10 @@
             <a:r>
               <a:rPr sz="1100" b="0" i="1">
                 <a:solidFill>
-                  <a:srgbClr val="8899AA"/>
+                  <a:srgbClr val="778899"/>
                 </a:solidFill>
               </a:rPr>
-              <a:t>(Not in brief)  —</a:t>
+              <a:t>(Not in brief)</a:t>
             </a:r>
           </a:p>
         </p:txBody>
@@ -8002,8 +6545,8 @@
         </p:nvSpPr>
         <p:spPr>
           <a:xfrm>
-            <a:off x="5760720" y="6117336"/>
-            <a:ext cx="6126480" cy="475488"/>
+            <a:off x="5760720" y="5710428"/>
+            <a:ext cx="6126480" cy="402336"/>
           </a:xfrm>
           <a:prstGeom prst="rect">
             <a:avLst/>
@@ -8023,8 +6566,7 @@
                   <a:srgbClr val="00C2FF"/>
                 </a:solidFill>
               </a:rPr>
-              <a:t>Composite confidence score: evidence quality · supplier completeness
-   validation completeness · feedback relevance  →  trust before ordering</a:t>
+              <a:t>Category system + multi-tenant org layer · settings drawer · per-org rules</a:t>
             </a:r>
           </a:p>
         </p:txBody>
@@ -8037,8 +6579,8 @@
         </p:nvSpPr>
         <p:spPr>
           <a:xfrm>
-            <a:off x="365760" y="6684264"/>
-            <a:ext cx="11430000" cy="640080"/>
+            <a:off x="365760" y="6208776"/>
+            <a:ext cx="11430000" cy="576072"/>
           </a:xfrm>
           <a:prstGeom prst="rect">
             <a:avLst/>
@@ -8080,8 +6622,8 @@
         </p:nvSpPr>
         <p:spPr>
           <a:xfrm>
-            <a:off x="502920" y="6775703"/>
-            <a:ext cx="5120640" cy="475488"/>
+            <a:off x="502920" y="6309360"/>
+            <a:ext cx="5120640" cy="402336"/>
           </a:xfrm>
           <a:prstGeom prst="rect">
             <a:avLst/>
@@ -8098,10 +6640,10 @@
             <a:r>
               <a:rPr sz="1100" b="0" i="1">
                 <a:solidFill>
-                  <a:srgbClr val="8899AA"/>
+                  <a:srgbClr val="778899"/>
                 </a:solidFill>
               </a:rPr>
-              <a:t>(Not in brief)  —</a:t>
+              <a:t>(Not in brief)</a:t>
             </a:r>
           </a:p>
         </p:txBody>
@@ -8114,8 +6656,8 @@
         </p:nvSpPr>
         <p:spPr>
           <a:xfrm>
-            <a:off x="5760720" y="6775703"/>
-            <a:ext cx="6126480" cy="475488"/>
+            <a:off x="5760720" y="6309360"/>
+            <a:ext cx="6126480" cy="402336"/>
           </a:xfrm>
           <a:prstGeom prst="rect">
             <a:avLst/>
@@ -8135,7 +6677,7 @@
                   <a:srgbClr val="00C2FF"/>
                 </a:solidFill>
               </a:rPr>
-              <a:t>Upload own data [coming soon]  —  Supabase schema + embedding store already in place</a:t>
+              <a:t>Multi-model: OpenAI GPT-4o · Google Gemini · Claude — redundancy &amp; best-fit routing</a:t>
             </a:r>
           </a:p>
         </p:txBody>

</xml_diff>

<commit_message>
feat: add slide 6 — dedicated contact us slide
</commit_message>
<xml_diff>
--- a/presentation/GF_sh_AI_scientist_Deck.pptx
+++ b/presentation/GF_sh_AI_scientist_Deck.pptx
@@ -9,6 +9,8 @@
     <p:sldId id="257" r:id="rId8"/>
     <p:sldId id="258" r:id="rId9"/>
     <p:sldId id="259" r:id="rId10"/>
+    <p:sldId id="260" r:id="rId11"/>
+    <p:sldId id="261" r:id="rId12"/>
   </p:sldIdLst>
   <p:sldSz cx="12188952" cy="6858000" type="screen4x3"/>
   <p:notesSz cx="6858000" cy="9144000"/>
@@ -6678,6 +6680,3004 @@
                 </a:solidFill>
               </a:rPr>
               <a:t>Multi-model: OpenAI GPT-4o · Google Gemini · Claude — redundancy &amp; best-fit routing</a:t>
+            </a:r>
+          </a:p>
+        </p:txBody>
+      </p:sp>
+    </p:spTree>
+  </p:cSld>
+  <p:clrMapOvr>
+    <a:masterClrMapping/>
+  </p:clrMapOvr>
+</p:sld>
+</file>
+
+<file path=ppt/slides/slide5.xml><?xml version="1.0" encoding="utf-8"?>
+<p:sld xmlns:a="http://schemas.openxmlformats.org/drawingml/2006/main" xmlns:p="http://schemas.openxmlformats.org/presentationml/2006/main" xmlns:r="http://schemas.openxmlformats.org/officeDocument/2006/relationships">
+  <p:cSld>
+    <p:bg>
+      <p:bgPr>
+        <a:solidFill>
+          <a:srgbClr val="0D1B2A"/>
+        </a:solidFill>
+        <a:effectLst/>
+      </p:bgPr>
+    </p:bg>
+    <p:spTree>
+      <p:nvGrpSpPr>
+        <p:cNvPr id="1" name=""/>
+        <p:cNvGrpSpPr/>
+        <p:nvPr/>
+      </p:nvGrpSpPr>
+      <p:grpSpPr/>
+      <p:sp>
+        <p:nvSpPr>
+          <p:cNvPr id="2" name="Rectangle 1"/>
+          <p:cNvSpPr/>
+          <p:nvPr/>
+        </p:nvSpPr>
+        <p:spPr>
+          <a:xfrm>
+            <a:off x="0" y="0"/>
+            <a:ext cx="12188952" cy="91440"/>
+          </a:xfrm>
+          <a:prstGeom prst="rect">
+            <a:avLst/>
+          </a:prstGeom>
+          <a:solidFill>
+            <a:srgbClr val="00C2FF"/>
+          </a:solidFill>
+          <a:ln>
+            <a:noFill/>
+          </a:ln>
+        </p:spPr>
+        <p:style>
+          <a:lnRef idx="1">
+            <a:schemeClr val="accent1"/>
+          </a:lnRef>
+          <a:fillRef idx="3">
+            <a:schemeClr val="accent1"/>
+          </a:fillRef>
+          <a:effectRef idx="2">
+            <a:schemeClr val="accent1"/>
+          </a:effectRef>
+          <a:fontRef idx="minor">
+            <a:schemeClr val="lt1"/>
+          </a:fontRef>
+        </p:style>
+        <p:txBody>
+          <a:bodyPr rtlCol="0" anchor="ctr"/>
+          <a:lstStyle/>
+          <a:p>
+            <a:pPr algn="ctr"/>
+          </a:p>
+        </p:txBody>
+      </p:sp>
+      <p:sp>
+        <p:nvSpPr>
+          <p:cNvPr id="3" name="Rectangle 2"/>
+          <p:cNvSpPr/>
+          <p:nvPr/>
+        </p:nvSpPr>
+        <p:spPr>
+          <a:xfrm>
+            <a:off x="0" y="6766560"/>
+            <a:ext cx="12188952" cy="91440"/>
+          </a:xfrm>
+          <a:prstGeom prst="rect">
+            <a:avLst/>
+          </a:prstGeom>
+          <a:solidFill>
+            <a:srgbClr val="00C2FF"/>
+          </a:solidFill>
+          <a:ln>
+            <a:noFill/>
+          </a:ln>
+        </p:spPr>
+        <p:style>
+          <a:lnRef idx="1">
+            <a:schemeClr val="accent1"/>
+          </a:lnRef>
+          <a:fillRef idx="3">
+            <a:schemeClr val="accent1"/>
+          </a:fillRef>
+          <a:effectRef idx="2">
+            <a:schemeClr val="accent1"/>
+          </a:effectRef>
+          <a:fontRef idx="minor">
+            <a:schemeClr val="lt1"/>
+          </a:fontRef>
+        </p:style>
+        <p:txBody>
+          <a:bodyPr rtlCol="0" anchor="ctr"/>
+          <a:lstStyle/>
+          <a:p>
+            <a:pPr algn="ctr"/>
+          </a:p>
+        </p:txBody>
+      </p:sp>
+      <p:sp>
+        <p:nvSpPr>
+          <p:cNvPr id="4" name="TextBox 3"/>
+          <p:cNvSpPr txBox="1"/>
+          <p:nvPr/>
+        </p:nvSpPr>
+        <p:spPr>
+          <a:xfrm>
+            <a:off x="457200" y="164592"/>
+            <a:ext cx="10972800" cy="548640"/>
+          </a:xfrm>
+          <a:prstGeom prst="rect">
+            <a:avLst/>
+          </a:prstGeom>
+          <a:noFill/>
+        </p:spPr>
+        <p:txBody>
+          <a:bodyPr wrap="square">
+            <a:spAutoFit/>
+          </a:bodyPr>
+          <a:lstStyle/>
+          <a:p>
+            <a:pPr algn="l"/>
+            <a:r>
+              <a:rPr sz="3200" b="1" i="0">
+                <a:solidFill>
+                  <a:srgbClr val="FFFFFF"/>
+                </a:solidFill>
+              </a:rPr>
+              <a:t>FEEDBACK MODEL &amp; AI VALIDATION</a:t>
+            </a:r>
+          </a:p>
+        </p:txBody>
+      </p:sp>
+      <p:sp>
+        <p:nvSpPr>
+          <p:cNvPr id="5" name="Rectangle 4"/>
+          <p:cNvSpPr/>
+          <p:nvPr/>
+        </p:nvSpPr>
+        <p:spPr>
+          <a:xfrm>
+            <a:off x="457200" y="749808"/>
+            <a:ext cx="1097280" cy="64008"/>
+          </a:xfrm>
+          <a:prstGeom prst="rect">
+            <a:avLst/>
+          </a:prstGeom>
+          <a:solidFill>
+            <a:srgbClr val="00C2FF"/>
+          </a:solidFill>
+          <a:ln>
+            <a:noFill/>
+          </a:ln>
+        </p:spPr>
+        <p:style>
+          <a:lnRef idx="1">
+            <a:schemeClr val="accent1"/>
+          </a:lnRef>
+          <a:fillRef idx="3">
+            <a:schemeClr val="accent1"/>
+          </a:fillRef>
+          <a:effectRef idx="2">
+            <a:schemeClr val="accent1"/>
+          </a:effectRef>
+          <a:fontRef idx="minor">
+            <a:schemeClr val="lt1"/>
+          </a:fontRef>
+        </p:style>
+        <p:txBody>
+          <a:bodyPr rtlCol="0" anchor="ctr"/>
+          <a:lstStyle/>
+          <a:p>
+            <a:pPr algn="ctr"/>
+          </a:p>
+        </p:txBody>
+      </p:sp>
+      <p:sp>
+        <p:nvSpPr>
+          <p:cNvPr id="6" name="Rectangle 5"/>
+          <p:cNvSpPr/>
+          <p:nvPr/>
+        </p:nvSpPr>
+        <p:spPr>
+          <a:xfrm>
+            <a:off x="365760" y="960120"/>
+            <a:ext cx="6400800" cy="4480560"/>
+          </a:xfrm>
+          <a:prstGeom prst="rect">
+            <a:avLst/>
+          </a:prstGeom>
+          <a:solidFill>
+            <a:srgbClr val="12283E"/>
+          </a:solidFill>
+          <a:ln>
+            <a:noFill/>
+          </a:ln>
+        </p:spPr>
+        <p:style>
+          <a:lnRef idx="1">
+            <a:schemeClr val="accent1"/>
+          </a:lnRef>
+          <a:fillRef idx="3">
+            <a:schemeClr val="accent1"/>
+          </a:fillRef>
+          <a:effectRef idx="2">
+            <a:schemeClr val="accent1"/>
+          </a:effectRef>
+          <a:fontRef idx="minor">
+            <a:schemeClr val="lt1"/>
+          </a:fontRef>
+        </p:style>
+        <p:txBody>
+          <a:bodyPr rtlCol="0" anchor="ctr"/>
+          <a:lstStyle/>
+          <a:p>
+            <a:pPr algn="ctr"/>
+          </a:p>
+        </p:txBody>
+      </p:sp>
+      <p:sp>
+        <p:nvSpPr>
+          <p:cNvPr id="7" name="Rectangle 6"/>
+          <p:cNvSpPr/>
+          <p:nvPr/>
+        </p:nvSpPr>
+        <p:spPr>
+          <a:xfrm>
+            <a:off x="365760" y="960120"/>
+            <a:ext cx="6400800" cy="73152"/>
+          </a:xfrm>
+          <a:prstGeom prst="rect">
+            <a:avLst/>
+          </a:prstGeom>
+          <a:solidFill>
+            <a:srgbClr val="05C48A"/>
+          </a:solidFill>
+          <a:ln>
+            <a:noFill/>
+          </a:ln>
+        </p:spPr>
+        <p:style>
+          <a:lnRef idx="1">
+            <a:schemeClr val="accent1"/>
+          </a:lnRef>
+          <a:fillRef idx="3">
+            <a:schemeClr val="accent1"/>
+          </a:fillRef>
+          <a:effectRef idx="2">
+            <a:schemeClr val="accent1"/>
+          </a:effectRef>
+          <a:fontRef idx="minor">
+            <a:schemeClr val="lt1"/>
+          </a:fontRef>
+        </p:style>
+        <p:txBody>
+          <a:bodyPr rtlCol="0" anchor="ctr"/>
+          <a:lstStyle/>
+          <a:p>
+            <a:pPr algn="ctr"/>
+          </a:p>
+        </p:txBody>
+      </p:sp>
+      <p:sp>
+        <p:nvSpPr>
+          <p:cNvPr id="8" name="TextBox 7"/>
+          <p:cNvSpPr txBox="1"/>
+          <p:nvPr/>
+        </p:nvSpPr>
+        <p:spPr>
+          <a:xfrm>
+            <a:off x="502920" y="1078992"/>
+            <a:ext cx="6126480" cy="384048"/>
+          </a:xfrm>
+          <a:prstGeom prst="rect">
+            <a:avLst/>
+          </a:prstGeom>
+          <a:noFill/>
+        </p:spPr>
+        <p:txBody>
+          <a:bodyPr wrap="square">
+            <a:spAutoFit/>
+          </a:bodyPr>
+          <a:lstStyle/>
+          <a:p>
+            <a:pPr algn="l"/>
+            <a:r>
+              <a:rPr sz="1400" b="1" i="0">
+                <a:solidFill>
+                  <a:srgbClr val="05C48A"/>
+                </a:solidFill>
+              </a:rPr>
+              <a:t>HOW THE FEEDBACK MODEL WORKS</a:t>
+            </a:r>
+          </a:p>
+        </p:txBody>
+      </p:sp>
+      <p:sp>
+        <p:nvSpPr>
+          <p:cNvPr id="9" name="Rectangle 8"/>
+          <p:cNvSpPr/>
+          <p:nvPr/>
+        </p:nvSpPr>
+        <p:spPr>
+          <a:xfrm>
+            <a:off x="502920" y="1572768"/>
+            <a:ext cx="6126480" cy="868680"/>
+          </a:xfrm>
+          <a:prstGeom prst="rect">
+            <a:avLst/>
+          </a:prstGeom>
+          <a:solidFill>
+            <a:srgbClr val="0A1E30"/>
+          </a:solidFill>
+          <a:ln>
+            <a:noFill/>
+          </a:ln>
+        </p:spPr>
+        <p:style>
+          <a:lnRef idx="1">
+            <a:schemeClr val="accent1"/>
+          </a:lnRef>
+          <a:fillRef idx="3">
+            <a:schemeClr val="accent1"/>
+          </a:fillRef>
+          <a:effectRef idx="2">
+            <a:schemeClr val="accent1"/>
+          </a:effectRef>
+          <a:fontRef idx="minor">
+            <a:schemeClr val="lt1"/>
+          </a:fontRef>
+        </p:style>
+        <p:txBody>
+          <a:bodyPr rtlCol="0" anchor="ctr"/>
+          <a:lstStyle/>
+          <a:p>
+            <a:pPr algn="ctr"/>
+          </a:p>
+        </p:txBody>
+      </p:sp>
+      <p:sp>
+        <p:nvSpPr>
+          <p:cNvPr id="10" name="Rectangle 9"/>
+          <p:cNvSpPr/>
+          <p:nvPr/>
+        </p:nvSpPr>
+        <p:spPr>
+          <a:xfrm>
+            <a:off x="502920" y="1572768"/>
+            <a:ext cx="164592" cy="868680"/>
+          </a:xfrm>
+          <a:prstGeom prst="rect">
+            <a:avLst/>
+          </a:prstGeom>
+          <a:solidFill>
+            <a:srgbClr val="05C48A"/>
+          </a:solidFill>
+          <a:ln>
+            <a:noFill/>
+          </a:ln>
+        </p:spPr>
+        <p:style>
+          <a:lnRef idx="1">
+            <a:schemeClr val="accent1"/>
+          </a:lnRef>
+          <a:fillRef idx="3">
+            <a:schemeClr val="accent1"/>
+          </a:fillRef>
+          <a:effectRef idx="2">
+            <a:schemeClr val="accent1"/>
+          </a:effectRef>
+          <a:fontRef idx="minor">
+            <a:schemeClr val="lt1"/>
+          </a:fontRef>
+        </p:style>
+        <p:txBody>
+          <a:bodyPr rtlCol="0" anchor="ctr"/>
+          <a:lstStyle/>
+          <a:p>
+            <a:pPr algn="ctr"/>
+          </a:p>
+        </p:txBody>
+      </p:sp>
+      <p:sp>
+        <p:nvSpPr>
+          <p:cNvPr id="11" name="TextBox 10"/>
+          <p:cNvSpPr txBox="1"/>
+          <p:nvPr/>
+        </p:nvSpPr>
+        <p:spPr>
+          <a:xfrm>
+            <a:off x="777240" y="1645920"/>
+            <a:ext cx="1828800" cy="274320"/>
+          </a:xfrm>
+          <a:prstGeom prst="rect">
+            <a:avLst/>
+          </a:prstGeom>
+          <a:noFill/>
+        </p:spPr>
+        <p:txBody>
+          <a:bodyPr wrap="square">
+            <a:spAutoFit/>
+          </a:bodyPr>
+          <a:lstStyle/>
+          <a:p>
+            <a:pPr algn="l"/>
+            <a:r>
+              <a:rPr sz="1200" b="1" i="0">
+                <a:solidFill>
+                  <a:srgbClr val="05C48A"/>
+                </a:solidFill>
+              </a:rPr>
+              <a:t>ORGANISATION</a:t>
+            </a:r>
+          </a:p>
+        </p:txBody>
+      </p:sp>
+      <p:sp>
+        <p:nvSpPr>
+          <p:cNvPr id="12" name="TextBox 11"/>
+          <p:cNvSpPr txBox="1"/>
+          <p:nvPr/>
+        </p:nvSpPr>
+        <p:spPr>
+          <a:xfrm>
+            <a:off x="777240" y="1938528"/>
+            <a:ext cx="5577840" cy="411480"/>
+          </a:xfrm>
+          <a:prstGeom prst="rect">
+            <a:avLst/>
+          </a:prstGeom>
+          <a:noFill/>
+        </p:spPr>
+        <p:txBody>
+          <a:bodyPr wrap="square">
+            <a:spAutoFit/>
+          </a:bodyPr>
+          <a:lstStyle/>
+          <a:p>
+            <a:pPr algn="l"/>
+            <a:r>
+              <a:rPr sz="1100" b="0" i="0">
+                <a:solidFill>
+                  <a:srgbClr val="CCD6E0"/>
+                </a:solidFill>
+              </a:rPr>
+              <a:t>Applies to all plans in the org
+e.g. 'Always verify matrix effects for biosensors'</a:t>
+            </a:r>
+          </a:p>
+        </p:txBody>
+      </p:sp>
+      <p:sp>
+        <p:nvSpPr>
+          <p:cNvPr id="13" name="Rectangle 12"/>
+          <p:cNvSpPr/>
+          <p:nvPr/>
+        </p:nvSpPr>
+        <p:spPr>
+          <a:xfrm>
+            <a:off x="502920" y="2560320"/>
+            <a:ext cx="6126480" cy="868680"/>
+          </a:xfrm>
+          <a:prstGeom prst="rect">
+            <a:avLst/>
+          </a:prstGeom>
+          <a:solidFill>
+            <a:srgbClr val="0A1E30"/>
+          </a:solidFill>
+          <a:ln>
+            <a:noFill/>
+          </a:ln>
+        </p:spPr>
+        <p:style>
+          <a:lnRef idx="1">
+            <a:schemeClr val="accent1"/>
+          </a:lnRef>
+          <a:fillRef idx="3">
+            <a:schemeClr val="accent1"/>
+          </a:fillRef>
+          <a:effectRef idx="2">
+            <a:schemeClr val="accent1"/>
+          </a:effectRef>
+          <a:fontRef idx="minor">
+            <a:schemeClr val="lt1"/>
+          </a:fontRef>
+        </p:style>
+        <p:txBody>
+          <a:bodyPr rtlCol="0" anchor="ctr"/>
+          <a:lstStyle/>
+          <a:p>
+            <a:pPr algn="ctr"/>
+          </a:p>
+        </p:txBody>
+      </p:sp>
+      <p:sp>
+        <p:nvSpPr>
+          <p:cNvPr id="14" name="Rectangle 13"/>
+          <p:cNvSpPr/>
+          <p:nvPr/>
+        </p:nvSpPr>
+        <p:spPr>
+          <a:xfrm>
+            <a:off x="502920" y="2560320"/>
+            <a:ext cx="164592" cy="868680"/>
+          </a:xfrm>
+          <a:prstGeom prst="rect">
+            <a:avLst/>
+          </a:prstGeom>
+          <a:solidFill>
+            <a:srgbClr val="00C2FF"/>
+          </a:solidFill>
+          <a:ln>
+            <a:noFill/>
+          </a:ln>
+        </p:spPr>
+        <p:style>
+          <a:lnRef idx="1">
+            <a:schemeClr val="accent1"/>
+          </a:lnRef>
+          <a:fillRef idx="3">
+            <a:schemeClr val="accent1"/>
+          </a:fillRef>
+          <a:effectRef idx="2">
+            <a:schemeClr val="accent1"/>
+          </a:effectRef>
+          <a:fontRef idx="minor">
+            <a:schemeClr val="lt1"/>
+          </a:fontRef>
+        </p:style>
+        <p:txBody>
+          <a:bodyPr rtlCol="0" anchor="ctr"/>
+          <a:lstStyle/>
+          <a:p>
+            <a:pPr algn="ctr"/>
+          </a:p>
+        </p:txBody>
+      </p:sp>
+      <p:sp>
+        <p:nvSpPr>
+          <p:cNvPr id="15" name="TextBox 14"/>
+          <p:cNvSpPr txBox="1"/>
+          <p:nvPr/>
+        </p:nvSpPr>
+        <p:spPr>
+          <a:xfrm>
+            <a:off x="777240" y="2633472"/>
+            <a:ext cx="1828800" cy="274320"/>
+          </a:xfrm>
+          <a:prstGeom prst="rect">
+            <a:avLst/>
+          </a:prstGeom>
+          <a:noFill/>
+        </p:spPr>
+        <p:txBody>
+          <a:bodyPr wrap="square">
+            <a:spAutoFit/>
+          </a:bodyPr>
+          <a:lstStyle/>
+          <a:p>
+            <a:pPr algn="l"/>
+            <a:r>
+              <a:rPr sz="1200" b="1" i="0">
+                <a:solidFill>
+                  <a:srgbClr val="00C2FF"/>
+                </a:solidFill>
+              </a:rPr>
+              <a:t>CATEGORY</a:t>
+            </a:r>
+          </a:p>
+        </p:txBody>
+      </p:sp>
+      <p:sp>
+        <p:nvSpPr>
+          <p:cNvPr id="16" name="TextBox 15"/>
+          <p:cNvSpPr txBox="1"/>
+          <p:nvPr/>
+        </p:nvSpPr>
+        <p:spPr>
+          <a:xfrm>
+            <a:off x="777240" y="2926079"/>
+            <a:ext cx="5577840" cy="411480"/>
+          </a:xfrm>
+          <a:prstGeom prst="rect">
+            <a:avLst/>
+          </a:prstGeom>
+          <a:noFill/>
+        </p:spPr>
+        <p:txBody>
+          <a:bodyPr wrap="square">
+            <a:spAutoFit/>
+          </a:bodyPr>
+          <a:lstStyle/>
+          <a:p>
+            <a:pPr algn="l"/>
+            <a:r>
+              <a:rPr sz="1100" b="0" i="0">
+                <a:solidFill>
+                  <a:srgbClr val="CCD6E0"/>
+                </a:solidFill>
+              </a:rPr>
+              <a:t>Applies to one experiment type
+e.g. 'For Cell Biology: include mycoplasma testing'</a:t>
+            </a:r>
+          </a:p>
+        </p:txBody>
+      </p:sp>
+      <p:sp>
+        <p:nvSpPr>
+          <p:cNvPr id="17" name="Rectangle 16"/>
+          <p:cNvSpPr/>
+          <p:nvPr/>
+        </p:nvSpPr>
+        <p:spPr>
+          <a:xfrm>
+            <a:off x="502920" y="3547872"/>
+            <a:ext cx="6126480" cy="868680"/>
+          </a:xfrm>
+          <a:prstGeom prst="rect">
+            <a:avLst/>
+          </a:prstGeom>
+          <a:solidFill>
+            <a:srgbClr val="0A1E30"/>
+          </a:solidFill>
+          <a:ln>
+            <a:noFill/>
+          </a:ln>
+        </p:spPr>
+        <p:style>
+          <a:lnRef idx="1">
+            <a:schemeClr val="accent1"/>
+          </a:lnRef>
+          <a:fillRef idx="3">
+            <a:schemeClr val="accent1"/>
+          </a:fillRef>
+          <a:effectRef idx="2">
+            <a:schemeClr val="accent1"/>
+          </a:effectRef>
+          <a:fontRef idx="minor">
+            <a:schemeClr val="lt1"/>
+          </a:fontRef>
+        </p:style>
+        <p:txBody>
+          <a:bodyPr rtlCol="0" anchor="ctr"/>
+          <a:lstStyle/>
+          <a:p>
+            <a:pPr algn="ctr"/>
+          </a:p>
+        </p:txBody>
+      </p:sp>
+      <p:sp>
+        <p:nvSpPr>
+          <p:cNvPr id="18" name="Rectangle 17"/>
+          <p:cNvSpPr/>
+          <p:nvPr/>
+        </p:nvSpPr>
+        <p:spPr>
+          <a:xfrm>
+            <a:off x="502920" y="3547872"/>
+            <a:ext cx="164592" cy="868680"/>
+          </a:xfrm>
+          <a:prstGeom prst="rect">
+            <a:avLst/>
+          </a:prstGeom>
+          <a:solidFill>
+            <a:srgbClr val="FFD600"/>
+          </a:solidFill>
+          <a:ln>
+            <a:noFill/>
+          </a:ln>
+        </p:spPr>
+        <p:style>
+          <a:lnRef idx="1">
+            <a:schemeClr val="accent1"/>
+          </a:lnRef>
+          <a:fillRef idx="3">
+            <a:schemeClr val="accent1"/>
+          </a:fillRef>
+          <a:effectRef idx="2">
+            <a:schemeClr val="accent1"/>
+          </a:effectRef>
+          <a:fontRef idx="minor">
+            <a:schemeClr val="lt1"/>
+          </a:fontRef>
+        </p:style>
+        <p:txBody>
+          <a:bodyPr rtlCol="0" anchor="ctr"/>
+          <a:lstStyle/>
+          <a:p>
+            <a:pPr algn="ctr"/>
+          </a:p>
+        </p:txBody>
+      </p:sp>
+      <p:sp>
+        <p:nvSpPr>
+          <p:cNvPr id="19" name="TextBox 18"/>
+          <p:cNvSpPr txBox="1"/>
+          <p:nvPr/>
+        </p:nvSpPr>
+        <p:spPr>
+          <a:xfrm>
+            <a:off x="777240" y="3621024"/>
+            <a:ext cx="1828800" cy="274320"/>
+          </a:xfrm>
+          <a:prstGeom prst="rect">
+            <a:avLst/>
+          </a:prstGeom>
+          <a:noFill/>
+        </p:spPr>
+        <p:txBody>
+          <a:bodyPr wrap="square">
+            <a:spAutoFit/>
+          </a:bodyPr>
+          <a:lstStyle/>
+          <a:p>
+            <a:pPr algn="l"/>
+            <a:r>
+              <a:rPr sz="1200" b="1" i="0">
+                <a:solidFill>
+                  <a:srgbClr val="FFD600"/>
+                </a:solidFill>
+              </a:rPr>
+              <a:t>EXPERIMENT</a:t>
+            </a:r>
+          </a:p>
+        </p:txBody>
+      </p:sp>
+      <p:sp>
+        <p:nvSpPr>
+          <p:cNvPr id="20" name="TextBox 19"/>
+          <p:cNvSpPr txBox="1"/>
+          <p:nvPr/>
+        </p:nvSpPr>
+        <p:spPr>
+          <a:xfrm>
+            <a:off x="777240" y="3913632"/>
+            <a:ext cx="5577840" cy="411480"/>
+          </a:xfrm>
+          <a:prstGeom prst="rect">
+            <a:avLst/>
+          </a:prstGeom>
+          <a:noFill/>
+        </p:spPr>
+        <p:txBody>
+          <a:bodyPr wrap="square">
+            <a:spAutoFit/>
+          </a:bodyPr>
+          <a:lstStyle/>
+          <a:p>
+            <a:pPr algn="l"/>
+            <a:r>
+              <a:rPr sz="1100" b="0" i="0">
+                <a:solidFill>
+                  <a:srgbClr val="CCD6E0"/>
+                </a:solidFill>
+              </a:rPr>
+              <a:t>Applies when branching from a specific plan
+e.g. 'n=4 sufficient for this HeLa line'</a:t>
+            </a:r>
+          </a:p>
+        </p:txBody>
+      </p:sp>
+      <p:sp>
+        <p:nvSpPr>
+          <p:cNvPr id="21" name="Rectangle 20"/>
+          <p:cNvSpPr/>
+          <p:nvPr/>
+        </p:nvSpPr>
+        <p:spPr>
+          <a:xfrm>
+            <a:off x="365760" y="4553712"/>
+            <a:ext cx="6400800" cy="438912"/>
+          </a:xfrm>
+          <a:prstGeom prst="rect">
+            <a:avLst/>
+          </a:prstGeom>
+          <a:solidFill>
+            <a:srgbClr val="061420"/>
+          </a:solidFill>
+          <a:ln>
+            <a:noFill/>
+          </a:ln>
+        </p:spPr>
+        <p:style>
+          <a:lnRef idx="1">
+            <a:schemeClr val="accent1"/>
+          </a:lnRef>
+          <a:fillRef idx="3">
+            <a:schemeClr val="accent1"/>
+          </a:fillRef>
+          <a:effectRef idx="2">
+            <a:schemeClr val="accent1"/>
+          </a:effectRef>
+          <a:fontRef idx="minor">
+            <a:schemeClr val="lt1"/>
+          </a:fontRef>
+        </p:style>
+        <p:txBody>
+          <a:bodyPr rtlCol="0" anchor="ctr"/>
+          <a:lstStyle/>
+          <a:p>
+            <a:pPr algn="ctr"/>
+          </a:p>
+        </p:txBody>
+      </p:sp>
+      <p:sp>
+        <p:nvSpPr>
+          <p:cNvPr id="22" name="TextBox 21"/>
+          <p:cNvSpPr txBox="1"/>
+          <p:nvPr/>
+        </p:nvSpPr>
+        <p:spPr>
+          <a:xfrm>
+            <a:off x="502920" y="4599432"/>
+            <a:ext cx="6126480" cy="347472"/>
+          </a:xfrm>
+          <a:prstGeom prst="rect">
+            <a:avLst/>
+          </a:prstGeom>
+          <a:noFill/>
+        </p:spPr>
+        <p:txBody>
+          <a:bodyPr wrap="square">
+            <a:spAutoFit/>
+          </a:bodyPr>
+          <a:lstStyle/>
+          <a:p>
+            <a:pPr algn="l"/>
+            <a:r>
+              <a:rPr sz="1000" b="0" i="0">
+                <a:solidFill>
+                  <a:srgbClr val="88BBDD"/>
+                </a:solidFill>
+              </a:rPr>
+              <a:t>Gemini 768-dim embeddings · Supabase pgvector HNSW · cosine similarity · match_experiments() RPC · ~1,600 pre-seeded rules · AI auto-classifies bucket</a:t>
+            </a:r>
+          </a:p>
+        </p:txBody>
+      </p:sp>
+      <p:sp>
+        <p:nvSpPr>
+          <p:cNvPr id="23" name="Rectangle 22"/>
+          <p:cNvSpPr/>
+          <p:nvPr/>
+        </p:nvSpPr>
+        <p:spPr>
+          <a:xfrm>
+            <a:off x="6949440" y="960120"/>
+            <a:ext cx="4846320" cy="4480560"/>
+          </a:xfrm>
+          <a:prstGeom prst="rect">
+            <a:avLst/>
+          </a:prstGeom>
+          <a:solidFill>
+            <a:srgbClr val="0F2235"/>
+          </a:solidFill>
+          <a:ln>
+            <a:noFill/>
+          </a:ln>
+        </p:spPr>
+        <p:style>
+          <a:lnRef idx="1">
+            <a:schemeClr val="accent1"/>
+          </a:lnRef>
+          <a:fillRef idx="3">
+            <a:schemeClr val="accent1"/>
+          </a:fillRef>
+          <a:effectRef idx="2">
+            <a:schemeClr val="accent1"/>
+          </a:effectRef>
+          <a:fontRef idx="minor">
+            <a:schemeClr val="lt1"/>
+          </a:fontRef>
+        </p:style>
+        <p:txBody>
+          <a:bodyPr rtlCol="0" anchor="ctr"/>
+          <a:lstStyle/>
+          <a:p>
+            <a:pPr algn="ctr"/>
+          </a:p>
+        </p:txBody>
+      </p:sp>
+      <p:sp>
+        <p:nvSpPr>
+          <p:cNvPr id="24" name="Rectangle 23"/>
+          <p:cNvSpPr/>
+          <p:nvPr/>
+        </p:nvSpPr>
+        <p:spPr>
+          <a:xfrm>
+            <a:off x="6949440" y="960120"/>
+            <a:ext cx="4846320" cy="73152"/>
+          </a:xfrm>
+          <a:prstGeom prst="rect">
+            <a:avLst/>
+          </a:prstGeom>
+          <a:solidFill>
+            <a:srgbClr val="FF6B6B"/>
+          </a:solidFill>
+          <a:ln>
+            <a:noFill/>
+          </a:ln>
+        </p:spPr>
+        <p:style>
+          <a:lnRef idx="1">
+            <a:schemeClr val="accent1"/>
+          </a:lnRef>
+          <a:fillRef idx="3">
+            <a:schemeClr val="accent1"/>
+          </a:fillRef>
+          <a:effectRef idx="2">
+            <a:schemeClr val="accent1"/>
+          </a:effectRef>
+          <a:fontRef idx="minor">
+            <a:schemeClr val="lt1"/>
+          </a:fontRef>
+        </p:style>
+        <p:txBody>
+          <a:bodyPr rtlCol="0" anchor="ctr"/>
+          <a:lstStyle/>
+          <a:p>
+            <a:pPr algn="ctr"/>
+          </a:p>
+        </p:txBody>
+      </p:sp>
+      <p:sp>
+        <p:nvSpPr>
+          <p:cNvPr id="25" name="TextBox 24"/>
+          <p:cNvSpPr txBox="1"/>
+          <p:nvPr/>
+        </p:nvSpPr>
+        <p:spPr>
+          <a:xfrm>
+            <a:off x="7086600" y="1078992"/>
+            <a:ext cx="4572000" cy="384048"/>
+          </a:xfrm>
+          <a:prstGeom prst="rect">
+            <a:avLst/>
+          </a:prstGeom>
+          <a:noFill/>
+        </p:spPr>
+        <p:txBody>
+          <a:bodyPr wrap="square">
+            <a:spAutoFit/>
+          </a:bodyPr>
+          <a:lstStyle/>
+          <a:p>
+            <a:pPr algn="l"/>
+            <a:r>
+              <a:rPr sz="1400" b="1" i="0">
+                <a:solidFill>
+                  <a:srgbClr val="FF6B6B"/>
+                </a:solidFill>
+              </a:rPr>
+              <a:t>HOW WE VALIDATE THE AI</a:t>
+            </a:r>
+          </a:p>
+        </p:txBody>
+      </p:sp>
+      <p:sp>
+        <p:nvSpPr>
+          <p:cNvPr id="26" name="Rectangle 25"/>
+          <p:cNvSpPr/>
+          <p:nvPr/>
+        </p:nvSpPr>
+        <p:spPr>
+          <a:xfrm>
+            <a:off x="7086600" y="1517904"/>
+            <a:ext cx="4526280" cy="841248"/>
+          </a:xfrm>
+          <a:prstGeom prst="rect">
+            <a:avLst/>
+          </a:prstGeom>
+          <a:solidFill>
+            <a:srgbClr val="0A1A28"/>
+          </a:solidFill>
+          <a:ln>
+            <a:noFill/>
+          </a:ln>
+        </p:spPr>
+        <p:style>
+          <a:lnRef idx="1">
+            <a:schemeClr val="accent1"/>
+          </a:lnRef>
+          <a:fillRef idx="3">
+            <a:schemeClr val="accent1"/>
+          </a:fillRef>
+          <a:effectRef idx="2">
+            <a:schemeClr val="accent1"/>
+          </a:effectRef>
+          <a:fontRef idx="minor">
+            <a:schemeClr val="lt1"/>
+          </a:fontRef>
+        </p:style>
+        <p:txBody>
+          <a:bodyPr rtlCol="0" anchor="ctr"/>
+          <a:lstStyle/>
+          <a:p>
+            <a:pPr algn="ctr"/>
+          </a:p>
+        </p:txBody>
+      </p:sp>
+      <p:sp>
+        <p:nvSpPr>
+          <p:cNvPr id="27" name="Rectangle 26"/>
+          <p:cNvSpPr/>
+          <p:nvPr/>
+        </p:nvSpPr>
+        <p:spPr>
+          <a:xfrm>
+            <a:off x="7086600" y="1517904"/>
+            <a:ext cx="4526280" cy="54864"/>
+          </a:xfrm>
+          <a:prstGeom prst="rect">
+            <a:avLst/>
+          </a:prstGeom>
+          <a:solidFill>
+            <a:srgbClr val="FF6B6B"/>
+          </a:solidFill>
+          <a:ln>
+            <a:noFill/>
+          </a:ln>
+        </p:spPr>
+        <p:style>
+          <a:lnRef idx="1">
+            <a:schemeClr val="accent1"/>
+          </a:lnRef>
+          <a:fillRef idx="3">
+            <a:schemeClr val="accent1"/>
+          </a:fillRef>
+          <a:effectRef idx="2">
+            <a:schemeClr val="accent1"/>
+          </a:effectRef>
+          <a:fontRef idx="minor">
+            <a:schemeClr val="lt1"/>
+          </a:fontRef>
+        </p:style>
+        <p:txBody>
+          <a:bodyPr rtlCol="0" anchor="ctr"/>
+          <a:lstStyle/>
+          <a:p>
+            <a:pPr algn="ctr"/>
+          </a:p>
+        </p:txBody>
+      </p:sp>
+      <p:sp>
+        <p:nvSpPr>
+          <p:cNvPr id="28" name="TextBox 27"/>
+          <p:cNvSpPr txBox="1"/>
+          <p:nvPr/>
+        </p:nvSpPr>
+        <p:spPr>
+          <a:xfrm>
+            <a:off x="7223760" y="1609344"/>
+            <a:ext cx="4206240" cy="256032"/>
+          </a:xfrm>
+          <a:prstGeom prst="rect">
+            <a:avLst/>
+          </a:prstGeom>
+          <a:noFill/>
+        </p:spPr>
+        <p:txBody>
+          <a:bodyPr wrap="square">
+            <a:spAutoFit/>
+          </a:bodyPr>
+          <a:lstStyle/>
+          <a:p>
+            <a:pPr algn="l"/>
+            <a:r>
+              <a:rPr sz="1100" b="1" i="0">
+                <a:solidFill>
+                  <a:srgbClr val="FF6B6B"/>
+                </a:solidFill>
+              </a:rPr>
+              <a:t>Plan Critique (self-audit)</a:t>
+            </a:r>
+          </a:p>
+        </p:txBody>
+      </p:sp>
+      <p:sp>
+        <p:nvSpPr>
+          <p:cNvPr id="29" name="TextBox 28"/>
+          <p:cNvSpPr txBox="1"/>
+          <p:nvPr/>
+        </p:nvSpPr>
+        <p:spPr>
+          <a:xfrm>
+            <a:off x="7223760" y="1883664"/>
+            <a:ext cx="4206240" cy="438912"/>
+          </a:xfrm>
+          <a:prstGeom prst="rect">
+            <a:avLst/>
+          </a:prstGeom>
+          <a:noFill/>
+        </p:spPr>
+        <p:txBody>
+          <a:bodyPr wrap="square">
+            <a:spAutoFit/>
+          </a:bodyPr>
+          <a:lstStyle/>
+          <a:p>
+            <a:pPr algn="l"/>
+            <a:r>
+              <a:rPr sz="1000" b="0" i="0">
+                <a:solidFill>
+                  <a:srgbClr val="CCD6E0"/>
+                </a:solidFill>
+              </a:rPr>
+              <a:t>Second AI pass after every generation.
+6 categories: controls · statistics · sample size
+validation · safety · feasibility
+Rated: weak · needs_work · solid</a:t>
+            </a:r>
+          </a:p>
+        </p:txBody>
+      </p:sp>
+      <p:sp>
+        <p:nvSpPr>
+          <p:cNvPr id="30" name="Rectangle 29"/>
+          <p:cNvSpPr/>
+          <p:nvPr/>
+        </p:nvSpPr>
+        <p:spPr>
+          <a:xfrm>
+            <a:off x="7086600" y="2478024"/>
+            <a:ext cx="4526280" cy="841248"/>
+          </a:xfrm>
+          <a:prstGeom prst="rect">
+            <a:avLst/>
+          </a:prstGeom>
+          <a:solidFill>
+            <a:srgbClr val="0A1A28"/>
+          </a:solidFill>
+          <a:ln>
+            <a:noFill/>
+          </a:ln>
+        </p:spPr>
+        <p:style>
+          <a:lnRef idx="1">
+            <a:schemeClr val="accent1"/>
+          </a:lnRef>
+          <a:fillRef idx="3">
+            <a:schemeClr val="accent1"/>
+          </a:fillRef>
+          <a:effectRef idx="2">
+            <a:schemeClr val="accent1"/>
+          </a:effectRef>
+          <a:fontRef idx="minor">
+            <a:schemeClr val="lt1"/>
+          </a:fontRef>
+        </p:style>
+        <p:txBody>
+          <a:bodyPr rtlCol="0" anchor="ctr"/>
+          <a:lstStyle/>
+          <a:p>
+            <a:pPr algn="ctr"/>
+          </a:p>
+        </p:txBody>
+      </p:sp>
+      <p:sp>
+        <p:nvSpPr>
+          <p:cNvPr id="31" name="Rectangle 30"/>
+          <p:cNvSpPr/>
+          <p:nvPr/>
+        </p:nvSpPr>
+        <p:spPr>
+          <a:xfrm>
+            <a:off x="7086600" y="2478024"/>
+            <a:ext cx="4526280" cy="54864"/>
+          </a:xfrm>
+          <a:prstGeom prst="rect">
+            <a:avLst/>
+          </a:prstGeom>
+          <a:solidFill>
+            <a:srgbClr val="FFD600"/>
+          </a:solidFill>
+          <a:ln>
+            <a:noFill/>
+          </a:ln>
+        </p:spPr>
+        <p:style>
+          <a:lnRef idx="1">
+            <a:schemeClr val="accent1"/>
+          </a:lnRef>
+          <a:fillRef idx="3">
+            <a:schemeClr val="accent1"/>
+          </a:fillRef>
+          <a:effectRef idx="2">
+            <a:schemeClr val="accent1"/>
+          </a:effectRef>
+          <a:fontRef idx="minor">
+            <a:schemeClr val="lt1"/>
+          </a:fontRef>
+        </p:style>
+        <p:txBody>
+          <a:bodyPr rtlCol="0" anchor="ctr"/>
+          <a:lstStyle/>
+          <a:p>
+            <a:pPr algn="ctr"/>
+          </a:p>
+        </p:txBody>
+      </p:sp>
+      <p:sp>
+        <p:nvSpPr>
+          <p:cNvPr id="32" name="TextBox 31"/>
+          <p:cNvSpPr txBox="1"/>
+          <p:nvPr/>
+        </p:nvSpPr>
+        <p:spPr>
+          <a:xfrm>
+            <a:off x="7223760" y="2569464"/>
+            <a:ext cx="4206240" cy="256032"/>
+          </a:xfrm>
+          <a:prstGeom prst="rect">
+            <a:avLst/>
+          </a:prstGeom>
+          <a:noFill/>
+        </p:spPr>
+        <p:txBody>
+          <a:bodyPr wrap="square">
+            <a:spAutoFit/>
+          </a:bodyPr>
+          <a:lstStyle/>
+          <a:p>
+            <a:pPr algn="l"/>
+            <a:r>
+              <a:rPr sz="1100" b="1" i="0">
+                <a:solidFill>
+                  <a:srgbClr val="FFD600"/>
+                </a:solidFill>
+              </a:rPr>
+              <a:t>Multi-model redundancy</a:t>
+            </a:r>
+          </a:p>
+        </p:txBody>
+      </p:sp>
+      <p:sp>
+        <p:nvSpPr>
+          <p:cNvPr id="33" name="TextBox 32"/>
+          <p:cNvSpPr txBox="1"/>
+          <p:nvPr/>
+        </p:nvSpPr>
+        <p:spPr>
+          <a:xfrm>
+            <a:off x="7223760" y="2843784"/>
+            <a:ext cx="4206240" cy="438912"/>
+          </a:xfrm>
+          <a:prstGeom prst="rect">
+            <a:avLst/>
+          </a:prstGeom>
+          <a:noFill/>
+        </p:spPr>
+        <p:txBody>
+          <a:bodyPr wrap="square">
+            <a:spAutoFit/>
+          </a:bodyPr>
+          <a:lstStyle/>
+          <a:p>
+            <a:pPr algn="l"/>
+            <a:r>
+              <a:rPr sz="1000" b="0" i="0">
+                <a:solidFill>
+                  <a:srgbClr val="CCD6E0"/>
+                </a:solidFill>
+              </a:rPr>
+              <a:t>OpenAI GPT-4o · Google Gemini · Claude
+Heuristic fallback at every AI call
+System is fully functional with no API key</a:t>
+            </a:r>
+          </a:p>
+        </p:txBody>
+      </p:sp>
+      <p:sp>
+        <p:nvSpPr>
+          <p:cNvPr id="34" name="Rectangle 33"/>
+          <p:cNvSpPr/>
+          <p:nvPr/>
+        </p:nvSpPr>
+        <p:spPr>
+          <a:xfrm>
+            <a:off x="7086600" y="3438144"/>
+            <a:ext cx="4526280" cy="841248"/>
+          </a:xfrm>
+          <a:prstGeom prst="rect">
+            <a:avLst/>
+          </a:prstGeom>
+          <a:solidFill>
+            <a:srgbClr val="0A1A28"/>
+          </a:solidFill>
+          <a:ln>
+            <a:noFill/>
+          </a:ln>
+        </p:spPr>
+        <p:style>
+          <a:lnRef idx="1">
+            <a:schemeClr val="accent1"/>
+          </a:lnRef>
+          <a:fillRef idx="3">
+            <a:schemeClr val="accent1"/>
+          </a:fillRef>
+          <a:effectRef idx="2">
+            <a:schemeClr val="accent1"/>
+          </a:effectRef>
+          <a:fontRef idx="minor">
+            <a:schemeClr val="lt1"/>
+          </a:fontRef>
+        </p:style>
+        <p:txBody>
+          <a:bodyPr rtlCol="0" anchor="ctr"/>
+          <a:lstStyle/>
+          <a:p>
+            <a:pPr algn="ctr"/>
+          </a:p>
+        </p:txBody>
+      </p:sp>
+      <p:sp>
+        <p:nvSpPr>
+          <p:cNvPr id="35" name="Rectangle 34"/>
+          <p:cNvSpPr/>
+          <p:nvPr/>
+        </p:nvSpPr>
+        <p:spPr>
+          <a:xfrm>
+            <a:off x="7086600" y="3438144"/>
+            <a:ext cx="4526280" cy="54864"/>
+          </a:xfrm>
+          <a:prstGeom prst="rect">
+            <a:avLst/>
+          </a:prstGeom>
+          <a:solidFill>
+            <a:srgbClr val="00C2FF"/>
+          </a:solidFill>
+          <a:ln>
+            <a:noFill/>
+          </a:ln>
+        </p:spPr>
+        <p:style>
+          <a:lnRef idx="1">
+            <a:schemeClr val="accent1"/>
+          </a:lnRef>
+          <a:fillRef idx="3">
+            <a:schemeClr val="accent1"/>
+          </a:fillRef>
+          <a:effectRef idx="2">
+            <a:schemeClr val="accent1"/>
+          </a:effectRef>
+          <a:fontRef idx="minor">
+            <a:schemeClr val="lt1"/>
+          </a:fontRef>
+        </p:style>
+        <p:txBody>
+          <a:bodyPr rtlCol="0" anchor="ctr"/>
+          <a:lstStyle/>
+          <a:p>
+            <a:pPr algn="ctr"/>
+          </a:p>
+        </p:txBody>
+      </p:sp>
+      <p:sp>
+        <p:nvSpPr>
+          <p:cNvPr id="36" name="TextBox 35"/>
+          <p:cNvSpPr txBox="1"/>
+          <p:nvPr/>
+        </p:nvSpPr>
+        <p:spPr>
+          <a:xfrm>
+            <a:off x="7223760" y="3529584"/>
+            <a:ext cx="4206240" cy="256032"/>
+          </a:xfrm>
+          <a:prstGeom prst="rect">
+            <a:avLst/>
+          </a:prstGeom>
+          <a:noFill/>
+        </p:spPr>
+        <p:txBody>
+          <a:bodyPr wrap="square">
+            <a:spAutoFit/>
+          </a:bodyPr>
+          <a:lstStyle/>
+          <a:p>
+            <a:pPr algn="l"/>
+            <a:r>
+              <a:rPr sz="1100" b="1" i="0">
+                <a:solidFill>
+                  <a:srgbClr val="00C2FF"/>
+                </a:solidFill>
+              </a:rPr>
+              <a:t>Composite confidence score</a:t>
+            </a:r>
+          </a:p>
+        </p:txBody>
+      </p:sp>
+      <p:sp>
+        <p:nvSpPr>
+          <p:cNvPr id="37" name="TextBox 36"/>
+          <p:cNvSpPr txBox="1"/>
+          <p:nvPr/>
+        </p:nvSpPr>
+        <p:spPr>
+          <a:xfrm>
+            <a:off x="7223760" y="3803904"/>
+            <a:ext cx="4206240" cy="438912"/>
+          </a:xfrm>
+          <a:prstGeom prst="rect">
+            <a:avLst/>
+          </a:prstGeom>
+          <a:noFill/>
+        </p:spPr>
+        <p:txBody>
+          <a:bodyPr wrap="square">
+            <a:spAutoFit/>
+          </a:bodyPr>
+          <a:lstStyle/>
+          <a:p>
+            <a:pPr algn="l"/>
+            <a:r>
+              <a:rPr sz="1000" b="0" i="0">
+                <a:solidFill>
+                  <a:srgbClr val="CCD6E0"/>
+                </a:solidFill>
+              </a:rPr>
+              <a:t>Every plan scored: evidence quality
+supplier completeness · validation design
+feedback relevance — visible before ordering</a:t>
+            </a:r>
+          </a:p>
+        </p:txBody>
+      </p:sp>
+      <p:sp>
+        <p:nvSpPr>
+          <p:cNvPr id="38" name="Rectangle 37"/>
+          <p:cNvSpPr/>
+          <p:nvPr/>
+        </p:nvSpPr>
+        <p:spPr>
+          <a:xfrm>
+            <a:off x="7086600" y="4398264"/>
+            <a:ext cx="4526280" cy="841248"/>
+          </a:xfrm>
+          <a:prstGeom prst="rect">
+            <a:avLst/>
+          </a:prstGeom>
+          <a:solidFill>
+            <a:srgbClr val="0A1A28"/>
+          </a:solidFill>
+          <a:ln>
+            <a:noFill/>
+          </a:ln>
+        </p:spPr>
+        <p:style>
+          <a:lnRef idx="1">
+            <a:schemeClr val="accent1"/>
+          </a:lnRef>
+          <a:fillRef idx="3">
+            <a:schemeClr val="accent1"/>
+          </a:fillRef>
+          <a:effectRef idx="2">
+            <a:schemeClr val="accent1"/>
+          </a:effectRef>
+          <a:fontRef idx="minor">
+            <a:schemeClr val="lt1"/>
+          </a:fontRef>
+        </p:style>
+        <p:txBody>
+          <a:bodyPr rtlCol="0" anchor="ctr"/>
+          <a:lstStyle/>
+          <a:p>
+            <a:pPr algn="ctr"/>
+          </a:p>
+        </p:txBody>
+      </p:sp>
+      <p:sp>
+        <p:nvSpPr>
+          <p:cNvPr id="39" name="Rectangle 38"/>
+          <p:cNvSpPr/>
+          <p:nvPr/>
+        </p:nvSpPr>
+        <p:spPr>
+          <a:xfrm>
+            <a:off x="7086600" y="4398264"/>
+            <a:ext cx="4526280" cy="54864"/>
+          </a:xfrm>
+          <a:prstGeom prst="rect">
+            <a:avLst/>
+          </a:prstGeom>
+          <a:solidFill>
+            <a:srgbClr val="00E596"/>
+          </a:solidFill>
+          <a:ln>
+            <a:noFill/>
+          </a:ln>
+        </p:spPr>
+        <p:style>
+          <a:lnRef idx="1">
+            <a:schemeClr val="accent1"/>
+          </a:lnRef>
+          <a:fillRef idx="3">
+            <a:schemeClr val="accent1"/>
+          </a:fillRef>
+          <a:effectRef idx="2">
+            <a:schemeClr val="accent1"/>
+          </a:effectRef>
+          <a:fontRef idx="minor">
+            <a:schemeClr val="lt1"/>
+          </a:fontRef>
+        </p:style>
+        <p:txBody>
+          <a:bodyPr rtlCol="0" anchor="ctr"/>
+          <a:lstStyle/>
+          <a:p>
+            <a:pPr algn="ctr"/>
+          </a:p>
+        </p:txBody>
+      </p:sp>
+      <p:sp>
+        <p:nvSpPr>
+          <p:cNvPr id="40" name="TextBox 39"/>
+          <p:cNvSpPr txBox="1"/>
+          <p:nvPr/>
+        </p:nvSpPr>
+        <p:spPr>
+          <a:xfrm>
+            <a:off x="7223760" y="4489704"/>
+            <a:ext cx="4206240" cy="256032"/>
+          </a:xfrm>
+          <a:prstGeom prst="rect">
+            <a:avLst/>
+          </a:prstGeom>
+          <a:noFill/>
+        </p:spPr>
+        <p:txBody>
+          <a:bodyPr wrap="square">
+            <a:spAutoFit/>
+          </a:bodyPr>
+          <a:lstStyle/>
+          <a:p>
+            <a:pPr algn="l"/>
+            <a:r>
+              <a:rPr sz="1100" b="1" i="0">
+                <a:solidFill>
+                  <a:srgbClr val="00E596"/>
+                </a:solidFill>
+              </a:rPr>
+              <a:t>Literature grounding</a:t>
+            </a:r>
+          </a:p>
+        </p:txBody>
+      </p:sp>
+      <p:sp>
+        <p:nvSpPr>
+          <p:cNvPr id="41" name="TextBox 40"/>
+          <p:cNvSpPr txBox="1"/>
+          <p:nvPr/>
+        </p:nvSpPr>
+        <p:spPr>
+          <a:xfrm>
+            <a:off x="7223760" y="4764024"/>
+            <a:ext cx="4206240" cy="438912"/>
+          </a:xfrm>
+          <a:prstGeom prst="rect">
+            <a:avLst/>
+          </a:prstGeom>
+          <a:noFill/>
+        </p:spPr>
+        <p:txBody>
+          <a:bodyPr wrap="square">
+            <a:spAutoFit/>
+          </a:bodyPr>
+          <a:lstStyle/>
+          <a:p>
+            <a:pPr algn="l"/>
+            <a:r>
+              <a:rPr sz="1000" b="0" i="0">
+                <a:solidFill>
+                  <a:srgbClr val="CCD6E0"/>
+                </a:solidFill>
+              </a:rPr>
+              <a:t>Plans grounded in 6-source literature QC
+Nov­elty classified with confidence score
+No hallucinated catalog numbers — Tavily-verified</a:t>
+            </a:r>
+          </a:p>
+        </p:txBody>
+      </p:sp>
+      <p:sp>
+        <p:nvSpPr>
+          <p:cNvPr id="42" name="Rectangle 41"/>
+          <p:cNvSpPr/>
+          <p:nvPr/>
+        </p:nvSpPr>
+        <p:spPr>
+          <a:xfrm>
+            <a:off x="0" y="5577840"/>
+            <a:ext cx="12188952" cy="1188720"/>
+          </a:xfrm>
+          <a:prstGeom prst="rect">
+            <a:avLst/>
+          </a:prstGeom>
+          <a:solidFill>
+            <a:srgbClr val="05121E"/>
+          </a:solidFill>
+          <a:ln>
+            <a:noFill/>
+          </a:ln>
+        </p:spPr>
+        <p:style>
+          <a:lnRef idx="1">
+            <a:schemeClr val="accent1"/>
+          </a:lnRef>
+          <a:fillRef idx="3">
+            <a:schemeClr val="accent1"/>
+          </a:fillRef>
+          <a:effectRef idx="2">
+            <a:schemeClr val="accent1"/>
+          </a:effectRef>
+          <a:fontRef idx="minor">
+            <a:schemeClr val="lt1"/>
+          </a:fontRef>
+        </p:style>
+        <p:txBody>
+          <a:bodyPr rtlCol="0" anchor="ctr"/>
+          <a:lstStyle/>
+          <a:p>
+            <a:pPr algn="ctr"/>
+          </a:p>
+        </p:txBody>
+      </p:sp>
+      <p:sp>
+        <p:nvSpPr>
+          <p:cNvPr id="43" name="Rectangle 42"/>
+          <p:cNvSpPr/>
+          <p:nvPr/>
+        </p:nvSpPr>
+        <p:spPr>
+          <a:xfrm>
+            <a:off x="0" y="5577840"/>
+            <a:ext cx="12188952" cy="54864"/>
+          </a:xfrm>
+          <a:prstGeom prst="rect">
+            <a:avLst/>
+          </a:prstGeom>
+          <a:solidFill>
+            <a:srgbClr val="00C2FF"/>
+          </a:solidFill>
+          <a:ln>
+            <a:noFill/>
+          </a:ln>
+        </p:spPr>
+        <p:style>
+          <a:lnRef idx="1">
+            <a:schemeClr val="accent1"/>
+          </a:lnRef>
+          <a:fillRef idx="3">
+            <a:schemeClr val="accent1"/>
+          </a:fillRef>
+          <a:effectRef idx="2">
+            <a:schemeClr val="accent1"/>
+          </a:effectRef>
+          <a:fontRef idx="minor">
+            <a:schemeClr val="lt1"/>
+          </a:fontRef>
+        </p:style>
+        <p:txBody>
+          <a:bodyPr rtlCol="0" anchor="ctr"/>
+          <a:lstStyle/>
+          <a:p>
+            <a:pPr algn="ctr"/>
+          </a:p>
+        </p:txBody>
+      </p:sp>
+      <p:sp>
+        <p:nvSpPr>
+          <p:cNvPr id="44" name="TextBox 43"/>
+          <p:cNvSpPr txBox="1"/>
+          <p:nvPr/>
+        </p:nvSpPr>
+        <p:spPr>
+          <a:xfrm>
+            <a:off x="457200" y="5650992"/>
+            <a:ext cx="11247120" cy="292608"/>
+          </a:xfrm>
+          <a:prstGeom prst="rect">
+            <a:avLst/>
+          </a:prstGeom>
+          <a:noFill/>
+        </p:spPr>
+        <p:txBody>
+          <a:bodyPr wrap="square">
+            <a:spAutoFit/>
+          </a:bodyPr>
+          <a:lstStyle/>
+          <a:p>
+            <a:pPr algn="ctr"/>
+            <a:r>
+              <a:rPr sz="1300" b="1" i="0">
+                <a:solidFill>
+                  <a:srgbClr val="00C2FF"/>
+                </a:solidFill>
+              </a:rPr>
+              <a:t>CONTACT US FOR MORE QUESTIONS</a:t>
+            </a:r>
+          </a:p>
+        </p:txBody>
+      </p:sp>
+      <p:sp>
+        <p:nvSpPr>
+          <p:cNvPr id="45" name="TextBox 44"/>
+          <p:cNvSpPr txBox="1"/>
+          <p:nvPr/>
+        </p:nvSpPr>
+        <p:spPr>
+          <a:xfrm>
+            <a:off x="411480" y="5998464"/>
+            <a:ext cx="2834640" cy="256032"/>
+          </a:xfrm>
+          <a:prstGeom prst="rect">
+            <a:avLst/>
+          </a:prstGeom>
+          <a:noFill/>
+        </p:spPr>
+        <p:txBody>
+          <a:bodyPr wrap="square">
+            <a:spAutoFit/>
+          </a:bodyPr>
+          <a:lstStyle/>
+          <a:p>
+            <a:pPr algn="l"/>
+            <a:r>
+              <a:rPr sz="1100" b="1" i="0">
+                <a:solidFill>
+                  <a:srgbClr val="FFFFFF"/>
+                </a:solidFill>
+              </a:rPr>
+              <a:t>Samuel Hajek</a:t>
+            </a:r>
+          </a:p>
+        </p:txBody>
+      </p:sp>
+      <p:sp>
+        <p:nvSpPr>
+          <p:cNvPr id="46" name="TextBox 45"/>
+          <p:cNvSpPr txBox="1"/>
+          <p:nvPr/>
+        </p:nvSpPr>
+        <p:spPr>
+          <a:xfrm>
+            <a:off x="411480" y="6254496"/>
+            <a:ext cx="2834640" cy="237744"/>
+          </a:xfrm>
+          <a:prstGeom prst="rect">
+            <a:avLst/>
+          </a:prstGeom>
+          <a:noFill/>
+        </p:spPr>
+        <p:txBody>
+          <a:bodyPr wrap="square">
+            <a:spAutoFit/>
+          </a:bodyPr>
+          <a:lstStyle/>
+          <a:p>
+            <a:pPr algn="l"/>
+            <a:r>
+              <a:rPr sz="1000" b="0" i="1">
+                <a:solidFill>
+                  <a:srgbClr val="00C2FF"/>
+                </a:solidFill>
+              </a:rPr>
+              <a:t>samuel.hajek@gmail.com</a:t>
+            </a:r>
+          </a:p>
+        </p:txBody>
+      </p:sp>
+      <p:sp>
+        <p:nvSpPr>
+          <p:cNvPr id="47" name="TextBox 46"/>
+          <p:cNvSpPr txBox="1"/>
+          <p:nvPr/>
+        </p:nvSpPr>
+        <p:spPr>
+          <a:xfrm>
+            <a:off x="3355848" y="5998464"/>
+            <a:ext cx="2834640" cy="256032"/>
+          </a:xfrm>
+          <a:prstGeom prst="rect">
+            <a:avLst/>
+          </a:prstGeom>
+          <a:noFill/>
+        </p:spPr>
+        <p:txBody>
+          <a:bodyPr wrap="square">
+            <a:spAutoFit/>
+          </a:bodyPr>
+          <a:lstStyle/>
+          <a:p>
+            <a:pPr algn="l"/>
+            <a:r>
+              <a:rPr sz="1100" b="1" i="0">
+                <a:solidFill>
+                  <a:srgbClr val="FFFFFF"/>
+                </a:solidFill>
+              </a:rPr>
+              <a:t>Johannes Wagner</a:t>
+            </a:r>
+          </a:p>
+        </p:txBody>
+      </p:sp>
+      <p:sp>
+        <p:nvSpPr>
+          <p:cNvPr id="48" name="TextBox 47"/>
+          <p:cNvSpPr txBox="1"/>
+          <p:nvPr/>
+        </p:nvSpPr>
+        <p:spPr>
+          <a:xfrm>
+            <a:off x="3355848" y="6254496"/>
+            <a:ext cx="2834640" cy="237744"/>
+          </a:xfrm>
+          <a:prstGeom prst="rect">
+            <a:avLst/>
+          </a:prstGeom>
+          <a:noFill/>
+        </p:spPr>
+        <p:txBody>
+          <a:bodyPr wrap="square">
+            <a:spAutoFit/>
+          </a:bodyPr>
+          <a:lstStyle/>
+          <a:p>
+            <a:pPr algn="l"/>
+            <a:r>
+              <a:rPr sz="1000" b="0" i="1">
+                <a:solidFill>
+                  <a:srgbClr val="00C2FF"/>
+                </a:solidFill>
+              </a:rPr>
+              <a:t>johannes.wagner@alumni.tugraz.at</a:t>
+            </a:r>
+          </a:p>
+        </p:txBody>
+      </p:sp>
+      <p:sp>
+        <p:nvSpPr>
+          <p:cNvPr id="49" name="TextBox 48"/>
+          <p:cNvSpPr txBox="1"/>
+          <p:nvPr/>
+        </p:nvSpPr>
+        <p:spPr>
+          <a:xfrm>
+            <a:off x="6300216" y="5998464"/>
+            <a:ext cx="2834640" cy="256032"/>
+          </a:xfrm>
+          <a:prstGeom prst="rect">
+            <a:avLst/>
+          </a:prstGeom>
+          <a:noFill/>
+        </p:spPr>
+        <p:txBody>
+          <a:bodyPr wrap="square">
+            <a:spAutoFit/>
+          </a:bodyPr>
+          <a:lstStyle/>
+          <a:p>
+            <a:pPr algn="l"/>
+            <a:r>
+              <a:rPr sz="1100" b="1" i="0">
+                <a:solidFill>
+                  <a:srgbClr val="FFFFFF"/>
+                </a:solidFill>
+              </a:rPr>
+              <a:t>Felix Scope</a:t>
+            </a:r>
+          </a:p>
+        </p:txBody>
+      </p:sp>
+      <p:sp>
+        <p:nvSpPr>
+          <p:cNvPr id="50" name="TextBox 49"/>
+          <p:cNvSpPr txBox="1"/>
+          <p:nvPr/>
+        </p:nvSpPr>
+        <p:spPr>
+          <a:xfrm>
+            <a:off x="6300216" y="6254496"/>
+            <a:ext cx="2834640" cy="237744"/>
+          </a:xfrm>
+          <a:prstGeom prst="rect">
+            <a:avLst/>
+          </a:prstGeom>
+          <a:noFill/>
+        </p:spPr>
+        <p:txBody>
+          <a:bodyPr wrap="square">
+            <a:spAutoFit/>
+          </a:bodyPr>
+          <a:lstStyle/>
+          <a:p>
+            <a:pPr algn="l"/>
+            <a:r>
+              <a:rPr sz="1000" b="0" i="1">
+                <a:solidFill>
+                  <a:srgbClr val="00C2FF"/>
+                </a:solidFill>
+              </a:rPr>
+              <a:t>scope@tugraz.at</a:t>
+            </a:r>
+          </a:p>
+        </p:txBody>
+      </p:sp>
+      <p:sp>
+        <p:nvSpPr>
+          <p:cNvPr id="51" name="TextBox 50"/>
+          <p:cNvSpPr txBox="1"/>
+          <p:nvPr/>
+        </p:nvSpPr>
+        <p:spPr>
+          <a:xfrm>
+            <a:off x="9244584" y="5998464"/>
+            <a:ext cx="2834640" cy="256032"/>
+          </a:xfrm>
+          <a:prstGeom prst="rect">
+            <a:avLst/>
+          </a:prstGeom>
+          <a:noFill/>
+        </p:spPr>
+        <p:txBody>
+          <a:bodyPr wrap="square">
+            <a:spAutoFit/>
+          </a:bodyPr>
+          <a:lstStyle/>
+          <a:p>
+            <a:pPr algn="l"/>
+            <a:r>
+              <a:rPr sz="1100" b="1" i="0">
+                <a:solidFill>
+                  <a:srgbClr val="FFFFFF"/>
+                </a:solidFill>
+              </a:rPr>
+              <a:t>Georg Niess</a:t>
+            </a:r>
+          </a:p>
+        </p:txBody>
+      </p:sp>
+      <p:sp>
+        <p:nvSpPr>
+          <p:cNvPr id="52" name="TextBox 51"/>
+          <p:cNvSpPr txBox="1"/>
+          <p:nvPr/>
+        </p:nvSpPr>
+        <p:spPr>
+          <a:xfrm>
+            <a:off x="9244584" y="6254496"/>
+            <a:ext cx="2834640" cy="237744"/>
+          </a:xfrm>
+          <a:prstGeom prst="rect">
+            <a:avLst/>
+          </a:prstGeom>
+          <a:noFill/>
+        </p:spPr>
+        <p:txBody>
+          <a:bodyPr wrap="square">
+            <a:spAutoFit/>
+          </a:bodyPr>
+          <a:lstStyle/>
+          <a:p>
+            <a:pPr algn="l"/>
+            <a:r>
+              <a:rPr sz="1000" b="0" i="1">
+                <a:solidFill>
+                  <a:srgbClr val="00C2FF"/>
+                </a:solidFill>
+              </a:rPr>
+              <a:t>georg.niess@tugraz.at</a:t>
+            </a:r>
+          </a:p>
+        </p:txBody>
+      </p:sp>
+    </p:spTree>
+  </p:cSld>
+  <p:clrMapOvr>
+    <a:masterClrMapping/>
+  </p:clrMapOvr>
+</p:sld>
+</file>
+
+<file path=ppt/slides/slide6.xml><?xml version="1.0" encoding="utf-8"?>
+<p:sld xmlns:a="http://schemas.openxmlformats.org/drawingml/2006/main" xmlns:p="http://schemas.openxmlformats.org/presentationml/2006/main" xmlns:r="http://schemas.openxmlformats.org/officeDocument/2006/relationships">
+  <p:cSld>
+    <p:bg>
+      <p:bgPr>
+        <a:solidFill>
+          <a:srgbClr val="0D1B2A"/>
+        </a:solidFill>
+        <a:effectLst/>
+      </p:bgPr>
+    </p:bg>
+    <p:spTree>
+      <p:nvGrpSpPr>
+        <p:cNvPr id="1" name=""/>
+        <p:cNvGrpSpPr/>
+        <p:nvPr/>
+      </p:nvGrpSpPr>
+      <p:grpSpPr/>
+      <p:sp>
+        <p:nvSpPr>
+          <p:cNvPr id="2" name="Rectangle 1"/>
+          <p:cNvSpPr/>
+          <p:nvPr/>
+        </p:nvSpPr>
+        <p:spPr>
+          <a:xfrm>
+            <a:off x="0" y="0"/>
+            <a:ext cx="12188952" cy="91440"/>
+          </a:xfrm>
+          <a:prstGeom prst="rect">
+            <a:avLst/>
+          </a:prstGeom>
+          <a:solidFill>
+            <a:srgbClr val="00C2FF"/>
+          </a:solidFill>
+          <a:ln>
+            <a:noFill/>
+          </a:ln>
+        </p:spPr>
+        <p:style>
+          <a:lnRef idx="1">
+            <a:schemeClr val="accent1"/>
+          </a:lnRef>
+          <a:fillRef idx="3">
+            <a:schemeClr val="accent1"/>
+          </a:fillRef>
+          <a:effectRef idx="2">
+            <a:schemeClr val="accent1"/>
+          </a:effectRef>
+          <a:fontRef idx="minor">
+            <a:schemeClr val="lt1"/>
+          </a:fontRef>
+        </p:style>
+        <p:txBody>
+          <a:bodyPr rtlCol="0" anchor="ctr"/>
+          <a:lstStyle/>
+          <a:p>
+            <a:pPr algn="ctr"/>
+          </a:p>
+        </p:txBody>
+      </p:sp>
+      <p:sp>
+        <p:nvSpPr>
+          <p:cNvPr id="3" name="Rectangle 2"/>
+          <p:cNvSpPr/>
+          <p:nvPr/>
+        </p:nvSpPr>
+        <p:spPr>
+          <a:xfrm>
+            <a:off x="0" y="6766560"/>
+            <a:ext cx="12188952" cy="91440"/>
+          </a:xfrm>
+          <a:prstGeom prst="rect">
+            <a:avLst/>
+          </a:prstGeom>
+          <a:solidFill>
+            <a:srgbClr val="00C2FF"/>
+          </a:solidFill>
+          <a:ln>
+            <a:noFill/>
+          </a:ln>
+        </p:spPr>
+        <p:style>
+          <a:lnRef idx="1">
+            <a:schemeClr val="accent1"/>
+          </a:lnRef>
+          <a:fillRef idx="3">
+            <a:schemeClr val="accent1"/>
+          </a:fillRef>
+          <a:effectRef idx="2">
+            <a:schemeClr val="accent1"/>
+          </a:effectRef>
+          <a:fontRef idx="minor">
+            <a:schemeClr val="lt1"/>
+          </a:fontRef>
+        </p:style>
+        <p:txBody>
+          <a:bodyPr rtlCol="0" anchor="ctr"/>
+          <a:lstStyle/>
+          <a:p>
+            <a:pPr algn="ctr"/>
+          </a:p>
+        </p:txBody>
+      </p:sp>
+      <p:sp>
+        <p:nvSpPr>
+          <p:cNvPr id="4" name="TextBox 3"/>
+          <p:cNvSpPr txBox="1"/>
+          <p:nvPr/>
+        </p:nvSpPr>
+        <p:spPr>
+          <a:xfrm>
+            <a:off x="457200" y="502920"/>
+            <a:ext cx="11247120" cy="731520"/>
+          </a:xfrm>
+          <a:prstGeom prst="rect">
+            <a:avLst/>
+          </a:prstGeom>
+          <a:noFill/>
+        </p:spPr>
+        <p:txBody>
+          <a:bodyPr wrap="square">
+            <a:spAutoFit/>
+          </a:bodyPr>
+          <a:lstStyle/>
+          <a:p>
+            <a:pPr algn="ctr"/>
+            <a:r>
+              <a:rPr sz="4800" b="1" i="0">
+                <a:solidFill>
+                  <a:srgbClr val="FFFFFF"/>
+                </a:solidFill>
+              </a:rPr>
+              <a:t>CONTACT US</a:t>
+            </a:r>
+          </a:p>
+        </p:txBody>
+      </p:sp>
+      <p:sp>
+        <p:nvSpPr>
+          <p:cNvPr id="5" name="TextBox 4"/>
+          <p:cNvSpPr txBox="1"/>
+          <p:nvPr/>
+        </p:nvSpPr>
+        <p:spPr>
+          <a:xfrm>
+            <a:off x="457200" y="1325880"/>
+            <a:ext cx="11247120" cy="411480"/>
+          </a:xfrm>
+          <a:prstGeom prst="rect">
+            <a:avLst/>
+          </a:prstGeom>
+          <a:noFill/>
+        </p:spPr>
+        <p:txBody>
+          <a:bodyPr wrap="square">
+            <a:spAutoFit/>
+          </a:bodyPr>
+          <a:lstStyle/>
+          <a:p>
+            <a:pPr algn="ctr"/>
+            <a:r>
+              <a:rPr sz="1600" b="0" i="1">
+                <a:solidFill>
+                  <a:srgbClr val="CCD6E0"/>
+                </a:solidFill>
+              </a:rPr>
+              <a:t>Questions, collaborations, or feedback — we'd love to hear from you.</a:t>
+            </a:r>
+          </a:p>
+        </p:txBody>
+      </p:sp>
+      <p:sp>
+        <p:nvSpPr>
+          <p:cNvPr id="6" name="Rectangle 5"/>
+          <p:cNvSpPr/>
+          <p:nvPr/>
+        </p:nvSpPr>
+        <p:spPr>
+          <a:xfrm>
+            <a:off x="3657600" y="1874519"/>
+            <a:ext cx="4873752" cy="54864"/>
+          </a:xfrm>
+          <a:prstGeom prst="rect">
+            <a:avLst/>
+          </a:prstGeom>
+          <a:solidFill>
+            <a:srgbClr val="00C2FF"/>
+          </a:solidFill>
+          <a:ln>
+            <a:noFill/>
+          </a:ln>
+        </p:spPr>
+        <p:style>
+          <a:lnRef idx="1">
+            <a:schemeClr val="accent1"/>
+          </a:lnRef>
+          <a:fillRef idx="3">
+            <a:schemeClr val="accent1"/>
+          </a:fillRef>
+          <a:effectRef idx="2">
+            <a:schemeClr val="accent1"/>
+          </a:effectRef>
+          <a:fontRef idx="minor">
+            <a:schemeClr val="lt1"/>
+          </a:fontRef>
+        </p:style>
+        <p:txBody>
+          <a:bodyPr rtlCol="0" anchor="ctr"/>
+          <a:lstStyle/>
+          <a:p>
+            <a:pPr algn="ctr"/>
+          </a:p>
+        </p:txBody>
+      </p:sp>
+      <p:sp>
+        <p:nvSpPr>
+          <p:cNvPr id="7" name="Rectangle 6"/>
+          <p:cNvSpPr/>
+          <p:nvPr/>
+        </p:nvSpPr>
+        <p:spPr>
+          <a:xfrm>
+            <a:off x="502920" y="2148840"/>
+            <a:ext cx="5577840" cy="1600200"/>
+          </a:xfrm>
+          <a:prstGeom prst="rect">
+            <a:avLst/>
+          </a:prstGeom>
+          <a:solidFill>
+            <a:srgbClr val="12283E"/>
+          </a:solidFill>
+          <a:ln>
+            <a:noFill/>
+          </a:ln>
+        </p:spPr>
+        <p:style>
+          <a:lnRef idx="1">
+            <a:schemeClr val="accent1"/>
+          </a:lnRef>
+          <a:fillRef idx="3">
+            <a:schemeClr val="accent1"/>
+          </a:fillRef>
+          <a:effectRef idx="2">
+            <a:schemeClr val="accent1"/>
+          </a:effectRef>
+          <a:fontRef idx="minor">
+            <a:schemeClr val="lt1"/>
+          </a:fontRef>
+        </p:style>
+        <p:txBody>
+          <a:bodyPr rtlCol="0" anchor="ctr"/>
+          <a:lstStyle/>
+          <a:p>
+            <a:pPr algn="ctr"/>
+          </a:p>
+        </p:txBody>
+      </p:sp>
+      <p:sp>
+        <p:nvSpPr>
+          <p:cNvPr id="8" name="Rectangle 7"/>
+          <p:cNvSpPr/>
+          <p:nvPr/>
+        </p:nvSpPr>
+        <p:spPr>
+          <a:xfrm>
+            <a:off x="502920" y="2148840"/>
+            <a:ext cx="5577840" cy="73152"/>
+          </a:xfrm>
+          <a:prstGeom prst="rect">
+            <a:avLst/>
+          </a:prstGeom>
+          <a:solidFill>
+            <a:srgbClr val="00C2FF"/>
+          </a:solidFill>
+          <a:ln>
+            <a:noFill/>
+          </a:ln>
+        </p:spPr>
+        <p:style>
+          <a:lnRef idx="1">
+            <a:schemeClr val="accent1"/>
+          </a:lnRef>
+          <a:fillRef idx="3">
+            <a:schemeClr val="accent1"/>
+          </a:fillRef>
+          <a:effectRef idx="2">
+            <a:schemeClr val="accent1"/>
+          </a:effectRef>
+          <a:fontRef idx="minor">
+            <a:schemeClr val="lt1"/>
+          </a:fontRef>
+        </p:style>
+        <p:txBody>
+          <a:bodyPr rtlCol="0" anchor="ctr"/>
+          <a:lstStyle/>
+          <a:p>
+            <a:pPr algn="ctr"/>
+          </a:p>
+        </p:txBody>
+      </p:sp>
+      <p:sp>
+        <p:nvSpPr>
+          <p:cNvPr id="9" name="TextBox 8"/>
+          <p:cNvSpPr txBox="1"/>
+          <p:nvPr/>
+        </p:nvSpPr>
+        <p:spPr>
+          <a:xfrm>
+            <a:off x="704088" y="2313432"/>
+            <a:ext cx="5212080" cy="411480"/>
+          </a:xfrm>
+          <a:prstGeom prst="rect">
+            <a:avLst/>
+          </a:prstGeom>
+          <a:noFill/>
+        </p:spPr>
+        <p:txBody>
+          <a:bodyPr wrap="square">
+            <a:spAutoFit/>
+          </a:bodyPr>
+          <a:lstStyle/>
+          <a:p>
+            <a:pPr algn="l"/>
+            <a:r>
+              <a:rPr sz="2000" b="1" i="0">
+                <a:solidFill>
+                  <a:srgbClr val="FFFFFF"/>
+                </a:solidFill>
+              </a:rPr>
+              <a:t>Samuel Hajek</a:t>
+            </a:r>
+          </a:p>
+        </p:txBody>
+      </p:sp>
+      <p:sp>
+        <p:nvSpPr>
+          <p:cNvPr id="10" name="TextBox 9"/>
+          <p:cNvSpPr txBox="1"/>
+          <p:nvPr/>
+        </p:nvSpPr>
+        <p:spPr>
+          <a:xfrm>
+            <a:off x="704088" y="2743200"/>
+            <a:ext cx="5212080" cy="274320"/>
+          </a:xfrm>
+          <a:prstGeom prst="rect">
+            <a:avLst/>
+          </a:prstGeom>
+          <a:noFill/>
+        </p:spPr>
+        <p:txBody>
+          <a:bodyPr wrap="square">
+            <a:spAutoFit/>
+          </a:bodyPr>
+          <a:lstStyle/>
+          <a:p>
+            <a:pPr algn="l"/>
+            <a:r>
+              <a:rPr sz="1300" b="0" i="1">
+                <a:solidFill>
+                  <a:srgbClr val="00C2FF"/>
+                </a:solidFill>
+              </a:rPr>
+              <a:t>Scientist</a:t>
+            </a:r>
+          </a:p>
+        </p:txBody>
+      </p:sp>
+      <p:sp>
+        <p:nvSpPr>
+          <p:cNvPr id="11" name="TextBox 10"/>
+          <p:cNvSpPr txBox="1"/>
+          <p:nvPr/>
+        </p:nvSpPr>
+        <p:spPr>
+          <a:xfrm>
+            <a:off x="704088" y="3081528"/>
+            <a:ext cx="5212080" cy="292608"/>
+          </a:xfrm>
+          <a:prstGeom prst="rect">
+            <a:avLst/>
+          </a:prstGeom>
+          <a:noFill/>
+        </p:spPr>
+        <p:txBody>
+          <a:bodyPr wrap="square">
+            <a:spAutoFit/>
+          </a:bodyPr>
+          <a:lstStyle/>
+          <a:p>
+            <a:pPr algn="l"/>
+            <a:r>
+              <a:rPr sz="1300" b="0" i="0">
+                <a:solidFill>
+                  <a:srgbClr val="CCD6E0"/>
+                </a:solidFill>
+              </a:rPr>
+              <a:t>samuel.hajek@gmail.com</a:t>
+            </a:r>
+          </a:p>
+        </p:txBody>
+      </p:sp>
+      <p:sp>
+        <p:nvSpPr>
+          <p:cNvPr id="12" name="Rectangle 11"/>
+          <p:cNvSpPr/>
+          <p:nvPr/>
+        </p:nvSpPr>
+        <p:spPr>
+          <a:xfrm>
+            <a:off x="6355080" y="2148840"/>
+            <a:ext cx="5577840" cy="1600200"/>
+          </a:xfrm>
+          <a:prstGeom prst="rect">
+            <a:avLst/>
+          </a:prstGeom>
+          <a:solidFill>
+            <a:srgbClr val="12283E"/>
+          </a:solidFill>
+          <a:ln>
+            <a:noFill/>
+          </a:ln>
+        </p:spPr>
+        <p:style>
+          <a:lnRef idx="1">
+            <a:schemeClr val="accent1"/>
+          </a:lnRef>
+          <a:fillRef idx="3">
+            <a:schemeClr val="accent1"/>
+          </a:fillRef>
+          <a:effectRef idx="2">
+            <a:schemeClr val="accent1"/>
+          </a:effectRef>
+          <a:fontRef idx="minor">
+            <a:schemeClr val="lt1"/>
+          </a:fontRef>
+        </p:style>
+        <p:txBody>
+          <a:bodyPr rtlCol="0" anchor="ctr"/>
+          <a:lstStyle/>
+          <a:p>
+            <a:pPr algn="ctr"/>
+          </a:p>
+        </p:txBody>
+      </p:sp>
+      <p:sp>
+        <p:nvSpPr>
+          <p:cNvPr id="13" name="Rectangle 12"/>
+          <p:cNvSpPr/>
+          <p:nvPr/>
+        </p:nvSpPr>
+        <p:spPr>
+          <a:xfrm>
+            <a:off x="6355080" y="2148840"/>
+            <a:ext cx="5577840" cy="73152"/>
+          </a:xfrm>
+          <a:prstGeom prst="rect">
+            <a:avLst/>
+          </a:prstGeom>
+          <a:solidFill>
+            <a:srgbClr val="00C2FF"/>
+          </a:solidFill>
+          <a:ln>
+            <a:noFill/>
+          </a:ln>
+        </p:spPr>
+        <p:style>
+          <a:lnRef idx="1">
+            <a:schemeClr val="accent1"/>
+          </a:lnRef>
+          <a:fillRef idx="3">
+            <a:schemeClr val="accent1"/>
+          </a:fillRef>
+          <a:effectRef idx="2">
+            <a:schemeClr val="accent1"/>
+          </a:effectRef>
+          <a:fontRef idx="minor">
+            <a:schemeClr val="lt1"/>
+          </a:fontRef>
+        </p:style>
+        <p:txBody>
+          <a:bodyPr rtlCol="0" anchor="ctr"/>
+          <a:lstStyle/>
+          <a:p>
+            <a:pPr algn="ctr"/>
+          </a:p>
+        </p:txBody>
+      </p:sp>
+      <p:sp>
+        <p:nvSpPr>
+          <p:cNvPr id="14" name="TextBox 13"/>
+          <p:cNvSpPr txBox="1"/>
+          <p:nvPr/>
+        </p:nvSpPr>
+        <p:spPr>
+          <a:xfrm>
+            <a:off x="6556248" y="2313432"/>
+            <a:ext cx="5212080" cy="411480"/>
+          </a:xfrm>
+          <a:prstGeom prst="rect">
+            <a:avLst/>
+          </a:prstGeom>
+          <a:noFill/>
+        </p:spPr>
+        <p:txBody>
+          <a:bodyPr wrap="square">
+            <a:spAutoFit/>
+          </a:bodyPr>
+          <a:lstStyle/>
+          <a:p>
+            <a:pPr algn="l"/>
+            <a:r>
+              <a:rPr sz="2000" b="1" i="0">
+                <a:solidFill>
+                  <a:srgbClr val="FFFFFF"/>
+                </a:solidFill>
+              </a:rPr>
+              <a:t>Johannes Wagner</a:t>
+            </a:r>
+          </a:p>
+        </p:txBody>
+      </p:sp>
+      <p:sp>
+        <p:nvSpPr>
+          <p:cNvPr id="15" name="TextBox 14"/>
+          <p:cNvSpPr txBox="1"/>
+          <p:nvPr/>
+        </p:nvSpPr>
+        <p:spPr>
+          <a:xfrm>
+            <a:off x="6556248" y="2743200"/>
+            <a:ext cx="5212080" cy="274320"/>
+          </a:xfrm>
+          <a:prstGeom prst="rect">
+            <a:avLst/>
+          </a:prstGeom>
+          <a:noFill/>
+        </p:spPr>
+        <p:txBody>
+          <a:bodyPr wrap="square">
+            <a:spAutoFit/>
+          </a:bodyPr>
+          <a:lstStyle/>
+          <a:p>
+            <a:pPr algn="l"/>
+            <a:r>
+              <a:rPr sz="1300" b="0" i="1">
+                <a:solidFill>
+                  <a:srgbClr val="00C2FF"/>
+                </a:solidFill>
+              </a:rPr>
+              <a:t>Mechanical Engineer</a:t>
+            </a:r>
+          </a:p>
+        </p:txBody>
+      </p:sp>
+      <p:sp>
+        <p:nvSpPr>
+          <p:cNvPr id="16" name="TextBox 15"/>
+          <p:cNvSpPr txBox="1"/>
+          <p:nvPr/>
+        </p:nvSpPr>
+        <p:spPr>
+          <a:xfrm>
+            <a:off x="6556248" y="3081528"/>
+            <a:ext cx="5212080" cy="292608"/>
+          </a:xfrm>
+          <a:prstGeom prst="rect">
+            <a:avLst/>
+          </a:prstGeom>
+          <a:noFill/>
+        </p:spPr>
+        <p:txBody>
+          <a:bodyPr wrap="square">
+            <a:spAutoFit/>
+          </a:bodyPr>
+          <a:lstStyle/>
+          <a:p>
+            <a:pPr algn="l"/>
+            <a:r>
+              <a:rPr sz="1300" b="0" i="0">
+                <a:solidFill>
+                  <a:srgbClr val="CCD6E0"/>
+                </a:solidFill>
+              </a:rPr>
+              <a:t>johannes.wagner@alumni.tugraz.at</a:t>
+            </a:r>
+          </a:p>
+        </p:txBody>
+      </p:sp>
+      <p:sp>
+        <p:nvSpPr>
+          <p:cNvPr id="17" name="Rectangle 16"/>
+          <p:cNvSpPr/>
+          <p:nvPr/>
+        </p:nvSpPr>
+        <p:spPr>
+          <a:xfrm>
+            <a:off x="502920" y="4023360"/>
+            <a:ext cx="5577840" cy="1600200"/>
+          </a:xfrm>
+          <a:prstGeom prst="rect">
+            <a:avLst/>
+          </a:prstGeom>
+          <a:solidFill>
+            <a:srgbClr val="12283E"/>
+          </a:solidFill>
+          <a:ln>
+            <a:noFill/>
+          </a:ln>
+        </p:spPr>
+        <p:style>
+          <a:lnRef idx="1">
+            <a:schemeClr val="accent1"/>
+          </a:lnRef>
+          <a:fillRef idx="3">
+            <a:schemeClr val="accent1"/>
+          </a:fillRef>
+          <a:effectRef idx="2">
+            <a:schemeClr val="accent1"/>
+          </a:effectRef>
+          <a:fontRef idx="minor">
+            <a:schemeClr val="lt1"/>
+          </a:fontRef>
+        </p:style>
+        <p:txBody>
+          <a:bodyPr rtlCol="0" anchor="ctr"/>
+          <a:lstStyle/>
+          <a:p>
+            <a:pPr algn="ctr"/>
+          </a:p>
+        </p:txBody>
+      </p:sp>
+      <p:sp>
+        <p:nvSpPr>
+          <p:cNvPr id="18" name="Rectangle 17"/>
+          <p:cNvSpPr/>
+          <p:nvPr/>
+        </p:nvSpPr>
+        <p:spPr>
+          <a:xfrm>
+            <a:off x="502920" y="4023360"/>
+            <a:ext cx="5577840" cy="73152"/>
+          </a:xfrm>
+          <a:prstGeom prst="rect">
+            <a:avLst/>
+          </a:prstGeom>
+          <a:solidFill>
+            <a:srgbClr val="00C2FF"/>
+          </a:solidFill>
+          <a:ln>
+            <a:noFill/>
+          </a:ln>
+        </p:spPr>
+        <p:style>
+          <a:lnRef idx="1">
+            <a:schemeClr val="accent1"/>
+          </a:lnRef>
+          <a:fillRef idx="3">
+            <a:schemeClr val="accent1"/>
+          </a:fillRef>
+          <a:effectRef idx="2">
+            <a:schemeClr val="accent1"/>
+          </a:effectRef>
+          <a:fontRef idx="minor">
+            <a:schemeClr val="lt1"/>
+          </a:fontRef>
+        </p:style>
+        <p:txBody>
+          <a:bodyPr rtlCol="0" anchor="ctr"/>
+          <a:lstStyle/>
+          <a:p>
+            <a:pPr algn="ctr"/>
+          </a:p>
+        </p:txBody>
+      </p:sp>
+      <p:sp>
+        <p:nvSpPr>
+          <p:cNvPr id="19" name="TextBox 18"/>
+          <p:cNvSpPr txBox="1"/>
+          <p:nvPr/>
+        </p:nvSpPr>
+        <p:spPr>
+          <a:xfrm>
+            <a:off x="704088" y="4187952"/>
+            <a:ext cx="5212080" cy="411480"/>
+          </a:xfrm>
+          <a:prstGeom prst="rect">
+            <a:avLst/>
+          </a:prstGeom>
+          <a:noFill/>
+        </p:spPr>
+        <p:txBody>
+          <a:bodyPr wrap="square">
+            <a:spAutoFit/>
+          </a:bodyPr>
+          <a:lstStyle/>
+          <a:p>
+            <a:pPr algn="l"/>
+            <a:r>
+              <a:rPr sz="2000" b="1" i="0">
+                <a:solidFill>
+                  <a:srgbClr val="FFFFFF"/>
+                </a:solidFill>
+              </a:rPr>
+              <a:t>Felix Scope</a:t>
+            </a:r>
+          </a:p>
+        </p:txBody>
+      </p:sp>
+      <p:sp>
+        <p:nvSpPr>
+          <p:cNvPr id="20" name="TextBox 19"/>
+          <p:cNvSpPr txBox="1"/>
+          <p:nvPr/>
+        </p:nvSpPr>
+        <p:spPr>
+          <a:xfrm>
+            <a:off x="704088" y="4617720"/>
+            <a:ext cx="5212080" cy="274320"/>
+          </a:xfrm>
+          <a:prstGeom prst="rect">
+            <a:avLst/>
+          </a:prstGeom>
+          <a:noFill/>
+        </p:spPr>
+        <p:txBody>
+          <a:bodyPr wrap="square">
+            <a:spAutoFit/>
+          </a:bodyPr>
+          <a:lstStyle/>
+          <a:p>
+            <a:pPr algn="l"/>
+            <a:r>
+              <a:rPr sz="1300" b="0" i="1">
+                <a:solidFill>
+                  <a:srgbClr val="00C2FF"/>
+                </a:solidFill>
+              </a:rPr>
+              <a:t>Computer Scientist</a:t>
+            </a:r>
+          </a:p>
+        </p:txBody>
+      </p:sp>
+      <p:sp>
+        <p:nvSpPr>
+          <p:cNvPr id="21" name="TextBox 20"/>
+          <p:cNvSpPr txBox="1"/>
+          <p:nvPr/>
+        </p:nvSpPr>
+        <p:spPr>
+          <a:xfrm>
+            <a:off x="704088" y="4956048"/>
+            <a:ext cx="5212080" cy="292608"/>
+          </a:xfrm>
+          <a:prstGeom prst="rect">
+            <a:avLst/>
+          </a:prstGeom>
+          <a:noFill/>
+        </p:spPr>
+        <p:txBody>
+          <a:bodyPr wrap="square">
+            <a:spAutoFit/>
+          </a:bodyPr>
+          <a:lstStyle/>
+          <a:p>
+            <a:pPr algn="l"/>
+            <a:r>
+              <a:rPr sz="1300" b="0" i="0">
+                <a:solidFill>
+                  <a:srgbClr val="CCD6E0"/>
+                </a:solidFill>
+              </a:rPr>
+              <a:t>scope@tugraz.at</a:t>
+            </a:r>
+          </a:p>
+        </p:txBody>
+      </p:sp>
+      <p:sp>
+        <p:nvSpPr>
+          <p:cNvPr id="22" name="Rectangle 21"/>
+          <p:cNvSpPr/>
+          <p:nvPr/>
+        </p:nvSpPr>
+        <p:spPr>
+          <a:xfrm>
+            <a:off x="6355080" y="4023360"/>
+            <a:ext cx="5577840" cy="1600200"/>
+          </a:xfrm>
+          <a:prstGeom prst="rect">
+            <a:avLst/>
+          </a:prstGeom>
+          <a:solidFill>
+            <a:srgbClr val="12283E"/>
+          </a:solidFill>
+          <a:ln>
+            <a:noFill/>
+          </a:ln>
+        </p:spPr>
+        <p:style>
+          <a:lnRef idx="1">
+            <a:schemeClr val="accent1"/>
+          </a:lnRef>
+          <a:fillRef idx="3">
+            <a:schemeClr val="accent1"/>
+          </a:fillRef>
+          <a:effectRef idx="2">
+            <a:schemeClr val="accent1"/>
+          </a:effectRef>
+          <a:fontRef idx="minor">
+            <a:schemeClr val="lt1"/>
+          </a:fontRef>
+        </p:style>
+        <p:txBody>
+          <a:bodyPr rtlCol="0" anchor="ctr"/>
+          <a:lstStyle/>
+          <a:p>
+            <a:pPr algn="ctr"/>
+          </a:p>
+        </p:txBody>
+      </p:sp>
+      <p:sp>
+        <p:nvSpPr>
+          <p:cNvPr id="23" name="Rectangle 22"/>
+          <p:cNvSpPr/>
+          <p:nvPr/>
+        </p:nvSpPr>
+        <p:spPr>
+          <a:xfrm>
+            <a:off x="6355080" y="4023360"/>
+            <a:ext cx="5577840" cy="73152"/>
+          </a:xfrm>
+          <a:prstGeom prst="rect">
+            <a:avLst/>
+          </a:prstGeom>
+          <a:solidFill>
+            <a:srgbClr val="00C2FF"/>
+          </a:solidFill>
+          <a:ln>
+            <a:noFill/>
+          </a:ln>
+        </p:spPr>
+        <p:style>
+          <a:lnRef idx="1">
+            <a:schemeClr val="accent1"/>
+          </a:lnRef>
+          <a:fillRef idx="3">
+            <a:schemeClr val="accent1"/>
+          </a:fillRef>
+          <a:effectRef idx="2">
+            <a:schemeClr val="accent1"/>
+          </a:effectRef>
+          <a:fontRef idx="minor">
+            <a:schemeClr val="lt1"/>
+          </a:fontRef>
+        </p:style>
+        <p:txBody>
+          <a:bodyPr rtlCol="0" anchor="ctr"/>
+          <a:lstStyle/>
+          <a:p>
+            <a:pPr algn="ctr"/>
+          </a:p>
+        </p:txBody>
+      </p:sp>
+      <p:sp>
+        <p:nvSpPr>
+          <p:cNvPr id="24" name="TextBox 23"/>
+          <p:cNvSpPr txBox="1"/>
+          <p:nvPr/>
+        </p:nvSpPr>
+        <p:spPr>
+          <a:xfrm>
+            <a:off x="6556248" y="4187952"/>
+            <a:ext cx="5212080" cy="411480"/>
+          </a:xfrm>
+          <a:prstGeom prst="rect">
+            <a:avLst/>
+          </a:prstGeom>
+          <a:noFill/>
+        </p:spPr>
+        <p:txBody>
+          <a:bodyPr wrap="square">
+            <a:spAutoFit/>
+          </a:bodyPr>
+          <a:lstStyle/>
+          <a:p>
+            <a:pPr algn="l"/>
+            <a:r>
+              <a:rPr sz="2000" b="1" i="0">
+                <a:solidFill>
+                  <a:srgbClr val="FFFFFF"/>
+                </a:solidFill>
+              </a:rPr>
+              <a:t>Georg Niess</a:t>
+            </a:r>
+          </a:p>
+        </p:txBody>
+      </p:sp>
+      <p:sp>
+        <p:nvSpPr>
+          <p:cNvPr id="25" name="TextBox 24"/>
+          <p:cNvSpPr txBox="1"/>
+          <p:nvPr/>
+        </p:nvSpPr>
+        <p:spPr>
+          <a:xfrm>
+            <a:off x="6556248" y="4617720"/>
+            <a:ext cx="5212080" cy="274320"/>
+          </a:xfrm>
+          <a:prstGeom prst="rect">
+            <a:avLst/>
+          </a:prstGeom>
+          <a:noFill/>
+        </p:spPr>
+        <p:txBody>
+          <a:bodyPr wrap="square">
+            <a:spAutoFit/>
+          </a:bodyPr>
+          <a:lstStyle/>
+          <a:p>
+            <a:pPr algn="l"/>
+            <a:r>
+              <a:rPr sz="1300" b="0" i="1">
+                <a:solidFill>
+                  <a:srgbClr val="00C2FF"/>
+                </a:solidFill>
+              </a:rPr>
+              <a:t>Medicine MSc</a:t>
+            </a:r>
+          </a:p>
+        </p:txBody>
+      </p:sp>
+      <p:sp>
+        <p:nvSpPr>
+          <p:cNvPr id="26" name="TextBox 25"/>
+          <p:cNvSpPr txBox="1"/>
+          <p:nvPr/>
+        </p:nvSpPr>
+        <p:spPr>
+          <a:xfrm>
+            <a:off x="6556248" y="4956048"/>
+            <a:ext cx="5212080" cy="292608"/>
+          </a:xfrm>
+          <a:prstGeom prst="rect">
+            <a:avLst/>
+          </a:prstGeom>
+          <a:noFill/>
+        </p:spPr>
+        <p:txBody>
+          <a:bodyPr wrap="square">
+            <a:spAutoFit/>
+          </a:bodyPr>
+          <a:lstStyle/>
+          <a:p>
+            <a:pPr algn="l"/>
+            <a:r>
+              <a:rPr sz="1300" b="0" i="0">
+                <a:solidFill>
+                  <a:srgbClr val="CCD6E0"/>
+                </a:solidFill>
+              </a:rPr>
+              <a:t>georg.niess@tugraz.at</a:t>
+            </a:r>
+          </a:p>
+        </p:txBody>
+      </p:sp>
+      <p:sp>
+        <p:nvSpPr>
+          <p:cNvPr id="27" name="TextBox 26"/>
+          <p:cNvSpPr txBox="1"/>
+          <p:nvPr/>
+        </p:nvSpPr>
+        <p:spPr>
+          <a:xfrm>
+            <a:off x="457200" y="6035040"/>
+            <a:ext cx="11247120" cy="347472"/>
+          </a:xfrm>
+          <a:prstGeom prst="rect">
+            <a:avLst/>
+          </a:prstGeom>
+          <a:noFill/>
+        </p:spPr>
+        <p:txBody>
+          <a:bodyPr wrap="none">
+            <a:spAutoFit/>
+          </a:bodyPr>
+          <a:lstStyle/>
+          <a:p>
+            <a:pPr algn="ctr"/>
+            <a:r>
+              <a:rPr sz="1400" u="sng">
+                <a:solidFill>
+                  <a:srgbClr val="00C2FF"/>
+                </a:solidFill>
+                <a:hlinkClick r:id="rId2"/>
+              </a:rPr>
+              <a:t>🔗  github.com/fescofesco/Skill4People</a:t>
             </a:r>
           </a:p>
         </p:txBody>

</xml_diff>

<commit_message>
feat: split slide 5 into feedback-model-only + contact-only slides
</commit_message>
<xml_diff>
--- a/presentation/GF_sh_AI_scientist_Deck.pptx
+++ b/presentation/GF_sh_AI_scientist_Deck.pptx
@@ -6825,7 +6825,7 @@
                   <a:srgbClr val="FFFFFF"/>
                 </a:solidFill>
               </a:rPr>
-              <a:t>FEEDBACK MODEL &amp; AI VALIDATION</a:t>
+              <a:t>HOW THE FEEDBACK MODEL WORKS</a:t>
             </a:r>
           </a:p>
         </p:txBody>
@@ -6875,20 +6875,54 @@
       </p:sp>
       <p:sp>
         <p:nvSpPr>
-          <p:cNvPr id="6" name="Rectangle 5"/>
+          <p:cNvPr id="6" name="TextBox 5"/>
+          <p:cNvSpPr txBox="1"/>
+          <p:nvPr/>
+        </p:nvSpPr>
+        <p:spPr>
+          <a:xfrm>
+            <a:off x="457200" y="896112"/>
+            <a:ext cx="11247120" cy="347472"/>
+          </a:xfrm>
+          <a:prstGeom prst="rect">
+            <a:avLst/>
+          </a:prstGeom>
+          <a:noFill/>
+        </p:spPr>
+        <p:txBody>
+          <a:bodyPr wrap="square">
+            <a:spAutoFit/>
+          </a:bodyPr>
+          <a:lstStyle/>
+          <a:p>
+            <a:pPr algn="ctr"/>
+            <a:r>
+              <a:rPr sz="1400" b="0" i="1">
+                <a:solidFill>
+                  <a:srgbClr val="CCD6E0"/>
+                </a:solidFill>
+              </a:rPr>
+              <a:t>Every correction a scientist makes becomes a rule that improves every future plan.</a:t>
+            </a:r>
+          </a:p>
+        </p:txBody>
+      </p:sp>
+      <p:sp>
+        <p:nvSpPr>
+          <p:cNvPr id="7" name="Rectangle 6"/>
           <p:cNvSpPr/>
           <p:nvPr/>
         </p:nvSpPr>
         <p:spPr>
           <a:xfrm>
-            <a:off x="365760" y="960120"/>
-            <a:ext cx="6400800" cy="4480560"/>
+            <a:off x="365760" y="1353312"/>
+            <a:ext cx="11457432" cy="1261872"/>
           </a:xfrm>
           <a:prstGeom prst="rect">
             <a:avLst/>
           </a:prstGeom>
           <a:solidFill>
-            <a:srgbClr val="12283E"/>
+            <a:srgbClr val="0A1E30"/>
           </a:solidFill>
           <a:ln>
             <a:noFill/>
@@ -6918,14 +6952,14 @@
       </p:sp>
       <p:sp>
         <p:nvSpPr>
-          <p:cNvPr id="7" name="Rectangle 6"/>
+          <p:cNvPr id="8" name="Rectangle 7"/>
           <p:cNvSpPr/>
           <p:nvPr/>
         </p:nvSpPr>
         <p:spPr>
           <a:xfrm>
-            <a:off x="365760" y="960120"/>
-            <a:ext cx="6400800" cy="73152"/>
+            <a:off x="365760" y="1353312"/>
+            <a:ext cx="11457432" cy="73152"/>
           </a:xfrm>
           <a:prstGeom prst="rect">
             <a:avLst/>
@@ -6961,14 +6995,14 @@
       </p:sp>
       <p:sp>
         <p:nvSpPr>
-          <p:cNvPr id="8" name="TextBox 7"/>
+          <p:cNvPr id="9" name="TextBox 8"/>
           <p:cNvSpPr txBox="1"/>
           <p:nvPr/>
         </p:nvSpPr>
         <p:spPr>
           <a:xfrm>
-            <a:off x="502920" y="1078992"/>
-            <a:ext cx="6126480" cy="384048"/>
+            <a:off x="566928" y="1472184"/>
+            <a:ext cx="3474720" cy="347472"/>
           </a:xfrm>
           <a:prstGeom prst="rect">
             <a:avLst/>
@@ -6988,21 +7022,56 @@
                   <a:srgbClr val="05C48A"/>
                 </a:solidFill>
               </a:rPr>
-              <a:t>HOW THE FEEDBACK MODEL WORKS</a:t>
-            </a:r>
-          </a:p>
-        </p:txBody>
-      </p:sp>
-      <p:sp>
-        <p:nvSpPr>
-          <p:cNvPr id="9" name="Rectangle 8"/>
+              <a:t>🏢  ORGANISATION SCOPE</a:t>
+            </a:r>
+          </a:p>
+        </p:txBody>
+      </p:sp>
+      <p:sp>
+        <p:nvSpPr>
+          <p:cNvPr id="10" name="TextBox 9"/>
+          <p:cNvSpPr txBox="1"/>
+          <p:nvPr/>
+        </p:nvSpPr>
+        <p:spPr>
+          <a:xfrm>
+            <a:off x="566928" y="1883664"/>
+            <a:ext cx="10881360" cy="621792"/>
+          </a:xfrm>
+          <a:prstGeom prst="rect">
+            <a:avLst/>
+          </a:prstGeom>
+          <a:noFill/>
+        </p:spPr>
+        <p:txBody>
+          <a:bodyPr wrap="square">
+            <a:spAutoFit/>
+          </a:bodyPr>
+          <a:lstStyle/>
+          <a:p>
+            <a:pPr algn="l"/>
+            <a:r>
+              <a:rPr sz="1300" b="0" i="0">
+                <a:solidFill>
+                  <a:srgbClr val="CCD6E0"/>
+                </a:solidFill>
+              </a:rPr>
+              <a:t>Applies to every plan generated by your organisation.
+Broad best practices seeded from experience — e.g. 'Always verify matrix effects for biosensors before ordering reagents.'</a:t>
+            </a:r>
+          </a:p>
+        </p:txBody>
+      </p:sp>
+      <p:sp>
+        <p:nvSpPr>
+          <p:cNvPr id="11" name="Rectangle 10"/>
           <p:cNvSpPr/>
           <p:nvPr/>
         </p:nvSpPr>
         <p:spPr>
           <a:xfrm>
-            <a:off x="502920" y="1572768"/>
-            <a:ext cx="6126480" cy="868680"/>
+            <a:off x="365760" y="2770632"/>
+            <a:ext cx="11457432" cy="1261872"/>
           </a:xfrm>
           <a:prstGeom prst="rect">
             <a:avLst/>
@@ -7038,20 +7107,20 @@
       </p:sp>
       <p:sp>
         <p:nvSpPr>
-          <p:cNvPr id="10" name="Rectangle 9"/>
+          <p:cNvPr id="12" name="Rectangle 11"/>
           <p:cNvSpPr/>
           <p:nvPr/>
         </p:nvSpPr>
         <p:spPr>
           <a:xfrm>
-            <a:off x="502920" y="1572768"/>
-            <a:ext cx="164592" cy="868680"/>
+            <a:off x="365760" y="2770632"/>
+            <a:ext cx="11457432" cy="73152"/>
           </a:xfrm>
           <a:prstGeom prst="rect">
             <a:avLst/>
           </a:prstGeom>
           <a:solidFill>
-            <a:srgbClr val="05C48A"/>
+            <a:srgbClr val="00C2FF"/>
           </a:solidFill>
           <a:ln>
             <a:noFill/>
@@ -7081,14 +7150,14 @@
       </p:sp>
       <p:sp>
         <p:nvSpPr>
-          <p:cNvPr id="11" name="TextBox 10"/>
+          <p:cNvPr id="13" name="TextBox 12"/>
           <p:cNvSpPr txBox="1"/>
           <p:nvPr/>
         </p:nvSpPr>
         <p:spPr>
           <a:xfrm>
-            <a:off x="777240" y="1645920"/>
-            <a:ext cx="1828800" cy="274320"/>
+            <a:off x="566928" y="2889504"/>
+            <a:ext cx="3474720" cy="347472"/>
           </a:xfrm>
           <a:prstGeom prst="rect">
             <a:avLst/>
@@ -7103,26 +7172,26 @@
           <a:p>
             <a:pPr algn="l"/>
             <a:r>
-              <a:rPr sz="1200" b="1" i="0">
-                <a:solidFill>
-                  <a:srgbClr val="05C48A"/>
+              <a:rPr sz="1400" b="1" i="0">
+                <a:solidFill>
+                  <a:srgbClr val="00C2FF"/>
                 </a:solidFill>
               </a:rPr>
-              <a:t>ORGANISATION</a:t>
-            </a:r>
-          </a:p>
-        </p:txBody>
-      </p:sp>
-      <p:sp>
-        <p:nvSpPr>
-          <p:cNvPr id="12" name="TextBox 11"/>
+              <a:t>🔬  CATEGORY SCOPE</a:t>
+            </a:r>
+          </a:p>
+        </p:txBody>
+      </p:sp>
+      <p:sp>
+        <p:nvSpPr>
+          <p:cNvPr id="14" name="TextBox 13"/>
           <p:cNvSpPr txBox="1"/>
           <p:nvPr/>
         </p:nvSpPr>
         <p:spPr>
           <a:xfrm>
-            <a:off x="777240" y="1938528"/>
-            <a:ext cx="5577840" cy="411480"/>
+            <a:off x="566928" y="3300984"/>
+            <a:ext cx="10881360" cy="621792"/>
           </a:xfrm>
           <a:prstGeom prst="rect">
             <a:avLst/>
@@ -7137,27 +7206,27 @@
           <a:p>
             <a:pPr algn="l"/>
             <a:r>
-              <a:rPr sz="1100" b="0" i="0">
+              <a:rPr sz="1300" b="0" i="0">
                 <a:solidFill>
                   <a:srgbClr val="CCD6E0"/>
                 </a:solidFill>
               </a:rPr>
-              <a:t>Applies to all plans in the org
-e.g. 'Always verify matrix effects for biosensors'</a:t>
-            </a:r>
-          </a:p>
-        </p:txBody>
-      </p:sp>
-      <p:sp>
-        <p:nvSpPr>
-          <p:cNvPr id="13" name="Rectangle 12"/>
+              <a:t>Applies to a specific experiment type (Cell Biology, Diagnostics, Climate, …).
+Medium-scope patterns — e.g. 'For Cell Biology experiments: always include mycoplasma testing in the validation design.'</a:t>
+            </a:r>
+          </a:p>
+        </p:txBody>
+      </p:sp>
+      <p:sp>
+        <p:nvSpPr>
+          <p:cNvPr id="15" name="Rectangle 14"/>
           <p:cNvSpPr/>
           <p:nvPr/>
         </p:nvSpPr>
         <p:spPr>
           <a:xfrm>
-            <a:off x="502920" y="2560320"/>
-            <a:ext cx="6126480" cy="868680"/>
+            <a:off x="365760" y="4187952"/>
+            <a:ext cx="11457432" cy="1261872"/>
           </a:xfrm>
           <a:prstGeom prst="rect">
             <a:avLst/>
@@ -7193,169 +7262,14 @@
       </p:sp>
       <p:sp>
         <p:nvSpPr>
-          <p:cNvPr id="14" name="Rectangle 13"/>
+          <p:cNvPr id="16" name="Rectangle 15"/>
           <p:cNvSpPr/>
           <p:nvPr/>
         </p:nvSpPr>
         <p:spPr>
           <a:xfrm>
-            <a:off x="502920" y="2560320"/>
-            <a:ext cx="164592" cy="868680"/>
-          </a:xfrm>
-          <a:prstGeom prst="rect">
-            <a:avLst/>
-          </a:prstGeom>
-          <a:solidFill>
-            <a:srgbClr val="00C2FF"/>
-          </a:solidFill>
-          <a:ln>
-            <a:noFill/>
-          </a:ln>
-        </p:spPr>
-        <p:style>
-          <a:lnRef idx="1">
-            <a:schemeClr val="accent1"/>
-          </a:lnRef>
-          <a:fillRef idx="3">
-            <a:schemeClr val="accent1"/>
-          </a:fillRef>
-          <a:effectRef idx="2">
-            <a:schemeClr val="accent1"/>
-          </a:effectRef>
-          <a:fontRef idx="minor">
-            <a:schemeClr val="lt1"/>
-          </a:fontRef>
-        </p:style>
-        <p:txBody>
-          <a:bodyPr rtlCol="0" anchor="ctr"/>
-          <a:lstStyle/>
-          <a:p>
-            <a:pPr algn="ctr"/>
-          </a:p>
-        </p:txBody>
-      </p:sp>
-      <p:sp>
-        <p:nvSpPr>
-          <p:cNvPr id="15" name="TextBox 14"/>
-          <p:cNvSpPr txBox="1"/>
-          <p:nvPr/>
-        </p:nvSpPr>
-        <p:spPr>
-          <a:xfrm>
-            <a:off x="777240" y="2633472"/>
-            <a:ext cx="1828800" cy="274320"/>
-          </a:xfrm>
-          <a:prstGeom prst="rect">
-            <a:avLst/>
-          </a:prstGeom>
-          <a:noFill/>
-        </p:spPr>
-        <p:txBody>
-          <a:bodyPr wrap="square">
-            <a:spAutoFit/>
-          </a:bodyPr>
-          <a:lstStyle/>
-          <a:p>
-            <a:pPr algn="l"/>
-            <a:r>
-              <a:rPr sz="1200" b="1" i="0">
-                <a:solidFill>
-                  <a:srgbClr val="00C2FF"/>
-                </a:solidFill>
-              </a:rPr>
-              <a:t>CATEGORY</a:t>
-            </a:r>
-          </a:p>
-        </p:txBody>
-      </p:sp>
-      <p:sp>
-        <p:nvSpPr>
-          <p:cNvPr id="16" name="TextBox 15"/>
-          <p:cNvSpPr txBox="1"/>
-          <p:nvPr/>
-        </p:nvSpPr>
-        <p:spPr>
-          <a:xfrm>
-            <a:off x="777240" y="2926079"/>
-            <a:ext cx="5577840" cy="411480"/>
-          </a:xfrm>
-          <a:prstGeom prst="rect">
-            <a:avLst/>
-          </a:prstGeom>
-          <a:noFill/>
-        </p:spPr>
-        <p:txBody>
-          <a:bodyPr wrap="square">
-            <a:spAutoFit/>
-          </a:bodyPr>
-          <a:lstStyle/>
-          <a:p>
-            <a:pPr algn="l"/>
-            <a:r>
-              <a:rPr sz="1100" b="0" i="0">
-                <a:solidFill>
-                  <a:srgbClr val="CCD6E0"/>
-                </a:solidFill>
-              </a:rPr>
-              <a:t>Applies to one experiment type
-e.g. 'For Cell Biology: include mycoplasma testing'</a:t>
-            </a:r>
-          </a:p>
-        </p:txBody>
-      </p:sp>
-      <p:sp>
-        <p:nvSpPr>
-          <p:cNvPr id="17" name="Rectangle 16"/>
-          <p:cNvSpPr/>
-          <p:nvPr/>
-        </p:nvSpPr>
-        <p:spPr>
-          <a:xfrm>
-            <a:off x="502920" y="3547872"/>
-            <a:ext cx="6126480" cy="868680"/>
-          </a:xfrm>
-          <a:prstGeom prst="rect">
-            <a:avLst/>
-          </a:prstGeom>
-          <a:solidFill>
-            <a:srgbClr val="0A1E30"/>
-          </a:solidFill>
-          <a:ln>
-            <a:noFill/>
-          </a:ln>
-        </p:spPr>
-        <p:style>
-          <a:lnRef idx="1">
-            <a:schemeClr val="accent1"/>
-          </a:lnRef>
-          <a:fillRef idx="3">
-            <a:schemeClr val="accent1"/>
-          </a:fillRef>
-          <a:effectRef idx="2">
-            <a:schemeClr val="accent1"/>
-          </a:effectRef>
-          <a:fontRef idx="minor">
-            <a:schemeClr val="lt1"/>
-          </a:fontRef>
-        </p:style>
-        <p:txBody>
-          <a:bodyPr rtlCol="0" anchor="ctr"/>
-          <a:lstStyle/>
-          <a:p>
-            <a:pPr algn="ctr"/>
-          </a:p>
-        </p:txBody>
-      </p:sp>
-      <p:sp>
-        <p:nvSpPr>
-          <p:cNvPr id="18" name="Rectangle 17"/>
-          <p:cNvSpPr/>
-          <p:nvPr/>
-        </p:nvSpPr>
-        <p:spPr>
-          <a:xfrm>
-            <a:off x="502920" y="3547872"/>
-            <a:ext cx="164592" cy="868680"/>
+            <a:off x="365760" y="4187952"/>
+            <a:ext cx="11457432" cy="73152"/>
           </a:xfrm>
           <a:prstGeom prst="rect">
             <a:avLst/>
@@ -7391,14 +7305,14 @@
       </p:sp>
       <p:sp>
         <p:nvSpPr>
-          <p:cNvPr id="19" name="TextBox 18"/>
+          <p:cNvPr id="17" name="TextBox 16"/>
           <p:cNvSpPr txBox="1"/>
           <p:nvPr/>
         </p:nvSpPr>
         <p:spPr>
           <a:xfrm>
-            <a:off x="777240" y="3621024"/>
-            <a:ext cx="1828800" cy="274320"/>
+            <a:off x="566928" y="4306824"/>
+            <a:ext cx="3474720" cy="347472"/>
           </a:xfrm>
           <a:prstGeom prst="rect">
             <a:avLst/>
@@ -7413,26 +7327,26 @@
           <a:p>
             <a:pPr algn="l"/>
             <a:r>
-              <a:rPr sz="1200" b="1" i="0">
+              <a:rPr sz="1400" b="1" i="0">
                 <a:solidFill>
                   <a:srgbClr val="FFD600"/>
                 </a:solidFill>
               </a:rPr>
-              <a:t>EXPERIMENT</a:t>
-            </a:r>
-          </a:p>
-        </p:txBody>
-      </p:sp>
-      <p:sp>
-        <p:nvSpPr>
-          <p:cNvPr id="20" name="TextBox 19"/>
+              <a:t>🧪  EXPERIMENT SCOPE</a:t>
+            </a:r>
+          </a:p>
+        </p:txBody>
+      </p:sp>
+      <p:sp>
+        <p:nvSpPr>
+          <p:cNvPr id="18" name="TextBox 17"/>
           <p:cNvSpPr txBox="1"/>
           <p:nvPr/>
         </p:nvSpPr>
         <p:spPr>
           <a:xfrm>
-            <a:off x="777240" y="3913632"/>
-            <a:ext cx="5577840" cy="411480"/>
+            <a:off x="566928" y="4718304"/>
+            <a:ext cx="10881360" cy="621792"/>
           </a:xfrm>
           <a:prstGeom prst="rect">
             <a:avLst/>
@@ -7447,33 +7361,33 @@
           <a:p>
             <a:pPr algn="l"/>
             <a:r>
-              <a:rPr sz="1100" b="0" i="0">
+              <a:rPr sz="1300" b="0" i="0">
                 <a:solidFill>
                   <a:srgbClr val="CCD6E0"/>
                 </a:solidFill>
               </a:rPr>
-              <a:t>Applies when branching from a specific plan
-e.g. 'n=4 sufficient for this HeLa line'</a:t>
-            </a:r>
-          </a:p>
-        </p:txBody>
-      </p:sp>
-      <p:sp>
-        <p:nvSpPr>
-          <p:cNvPr id="21" name="Rectangle 20"/>
+              <a:t>Applies only when branching from a specific saved plan.
+Narrow, lab-specific corrections — e.g. 'n=4 replicates is sufficient for this HeLa cell line based on our historical variance data.'</a:t>
+            </a:r>
+          </a:p>
+        </p:txBody>
+      </p:sp>
+      <p:sp>
+        <p:nvSpPr>
+          <p:cNvPr id="19" name="Rectangle 18"/>
           <p:cNvSpPr/>
           <p:nvPr/>
         </p:nvSpPr>
         <p:spPr>
           <a:xfrm>
-            <a:off x="365760" y="4553712"/>
-            <a:ext cx="6400800" cy="438912"/>
+            <a:off x="365760" y="5641848"/>
+            <a:ext cx="11457432" cy="658368"/>
           </a:xfrm>
           <a:prstGeom prst="rect">
             <a:avLst/>
           </a:prstGeom>
           <a:solidFill>
-            <a:srgbClr val="061420"/>
+            <a:srgbClr val="05101A"/>
           </a:solidFill>
           <a:ln>
             <a:noFill/>
@@ -7503,54 +7417,20 @@
       </p:sp>
       <p:sp>
         <p:nvSpPr>
-          <p:cNvPr id="22" name="TextBox 21"/>
-          <p:cNvSpPr txBox="1"/>
-          <p:nvPr/>
-        </p:nvSpPr>
-        <p:spPr>
-          <a:xfrm>
-            <a:off x="502920" y="4599432"/>
-            <a:ext cx="6126480" cy="347472"/>
-          </a:xfrm>
-          <a:prstGeom prst="rect">
-            <a:avLst/>
-          </a:prstGeom>
-          <a:noFill/>
-        </p:spPr>
-        <p:txBody>
-          <a:bodyPr wrap="square">
-            <a:spAutoFit/>
-          </a:bodyPr>
-          <a:lstStyle/>
-          <a:p>
-            <a:pPr algn="l"/>
-            <a:r>
-              <a:rPr sz="1000" b="0" i="0">
-                <a:solidFill>
-                  <a:srgbClr val="88BBDD"/>
-                </a:solidFill>
-              </a:rPr>
-              <a:t>Gemini 768-dim embeddings · Supabase pgvector HNSW · cosine similarity · match_experiments() RPC · ~1,600 pre-seeded rules · AI auto-classifies bucket</a:t>
-            </a:r>
-          </a:p>
-        </p:txBody>
-      </p:sp>
-      <p:sp>
-        <p:nvSpPr>
-          <p:cNvPr id="23" name="Rectangle 22"/>
+          <p:cNvPr id="20" name="Rectangle 19"/>
           <p:cNvSpPr/>
           <p:nvPr/>
         </p:nvSpPr>
         <p:spPr>
           <a:xfrm>
-            <a:off x="6949440" y="960120"/>
-            <a:ext cx="4846320" cy="4480560"/>
+            <a:off x="365760" y="5641848"/>
+            <a:ext cx="11457432" cy="54864"/>
           </a:xfrm>
           <a:prstGeom prst="rect">
             <a:avLst/>
           </a:prstGeom>
           <a:solidFill>
-            <a:srgbClr val="0F2235"/>
+            <a:srgbClr val="335577"/>
           </a:solidFill>
           <a:ln>
             <a:noFill/>
@@ -7580,57 +7460,14 @@
       </p:sp>
       <p:sp>
         <p:nvSpPr>
-          <p:cNvPr id="24" name="Rectangle 23"/>
-          <p:cNvSpPr/>
-          <p:nvPr/>
-        </p:nvSpPr>
-        <p:spPr>
-          <a:xfrm>
-            <a:off x="6949440" y="960120"/>
-            <a:ext cx="4846320" cy="73152"/>
-          </a:xfrm>
-          <a:prstGeom prst="rect">
-            <a:avLst/>
-          </a:prstGeom>
-          <a:solidFill>
-            <a:srgbClr val="FF6B6B"/>
-          </a:solidFill>
-          <a:ln>
-            <a:noFill/>
-          </a:ln>
-        </p:spPr>
-        <p:style>
-          <a:lnRef idx="1">
-            <a:schemeClr val="accent1"/>
-          </a:lnRef>
-          <a:fillRef idx="3">
-            <a:schemeClr val="accent1"/>
-          </a:fillRef>
-          <a:effectRef idx="2">
-            <a:schemeClr val="accent1"/>
-          </a:effectRef>
-          <a:fontRef idx="minor">
-            <a:schemeClr val="lt1"/>
-          </a:fontRef>
-        </p:style>
-        <p:txBody>
-          <a:bodyPr rtlCol="0" anchor="ctr"/>
-          <a:lstStyle/>
-          <a:p>
-            <a:pPr algn="ctr"/>
-          </a:p>
-        </p:txBody>
-      </p:sp>
-      <p:sp>
-        <p:nvSpPr>
-          <p:cNvPr id="25" name="TextBox 24"/>
+          <p:cNvPr id="21" name="TextBox 20"/>
           <p:cNvSpPr txBox="1"/>
           <p:nvPr/>
         </p:nvSpPr>
         <p:spPr>
           <a:xfrm>
-            <a:off x="7086600" y="1078992"/>
-            <a:ext cx="4572000" cy="384048"/>
+            <a:off x="548640" y="5733288"/>
+            <a:ext cx="11064240" cy="475488"/>
           </a:xfrm>
           <a:prstGeom prst="rect">
             <a:avLst/>
@@ -7645,1029 +7482,12 @@
           <a:p>
             <a:pPr algn="l"/>
             <a:r>
-              <a:rPr sz="1400" b="1" i="0">
-                <a:solidFill>
-                  <a:srgbClr val="FF6B6B"/>
+              <a:rPr sz="1100" b="0" i="0">
+                <a:solidFill>
+                  <a:srgbClr val="88BBDD"/>
                 </a:solidFill>
               </a:rPr>
-              <a:t>HOW WE VALIDATE THE AI</a:t>
-            </a:r>
-          </a:p>
-        </p:txBody>
-      </p:sp>
-      <p:sp>
-        <p:nvSpPr>
-          <p:cNvPr id="26" name="Rectangle 25"/>
-          <p:cNvSpPr/>
-          <p:nvPr/>
-        </p:nvSpPr>
-        <p:spPr>
-          <a:xfrm>
-            <a:off x="7086600" y="1517904"/>
-            <a:ext cx="4526280" cy="841248"/>
-          </a:xfrm>
-          <a:prstGeom prst="rect">
-            <a:avLst/>
-          </a:prstGeom>
-          <a:solidFill>
-            <a:srgbClr val="0A1A28"/>
-          </a:solidFill>
-          <a:ln>
-            <a:noFill/>
-          </a:ln>
-        </p:spPr>
-        <p:style>
-          <a:lnRef idx="1">
-            <a:schemeClr val="accent1"/>
-          </a:lnRef>
-          <a:fillRef idx="3">
-            <a:schemeClr val="accent1"/>
-          </a:fillRef>
-          <a:effectRef idx="2">
-            <a:schemeClr val="accent1"/>
-          </a:effectRef>
-          <a:fontRef idx="minor">
-            <a:schemeClr val="lt1"/>
-          </a:fontRef>
-        </p:style>
-        <p:txBody>
-          <a:bodyPr rtlCol="0" anchor="ctr"/>
-          <a:lstStyle/>
-          <a:p>
-            <a:pPr algn="ctr"/>
-          </a:p>
-        </p:txBody>
-      </p:sp>
-      <p:sp>
-        <p:nvSpPr>
-          <p:cNvPr id="27" name="Rectangle 26"/>
-          <p:cNvSpPr/>
-          <p:nvPr/>
-        </p:nvSpPr>
-        <p:spPr>
-          <a:xfrm>
-            <a:off x="7086600" y="1517904"/>
-            <a:ext cx="4526280" cy="54864"/>
-          </a:xfrm>
-          <a:prstGeom prst="rect">
-            <a:avLst/>
-          </a:prstGeom>
-          <a:solidFill>
-            <a:srgbClr val="FF6B6B"/>
-          </a:solidFill>
-          <a:ln>
-            <a:noFill/>
-          </a:ln>
-        </p:spPr>
-        <p:style>
-          <a:lnRef idx="1">
-            <a:schemeClr val="accent1"/>
-          </a:lnRef>
-          <a:fillRef idx="3">
-            <a:schemeClr val="accent1"/>
-          </a:fillRef>
-          <a:effectRef idx="2">
-            <a:schemeClr val="accent1"/>
-          </a:effectRef>
-          <a:fontRef idx="minor">
-            <a:schemeClr val="lt1"/>
-          </a:fontRef>
-        </p:style>
-        <p:txBody>
-          <a:bodyPr rtlCol="0" anchor="ctr"/>
-          <a:lstStyle/>
-          <a:p>
-            <a:pPr algn="ctr"/>
-          </a:p>
-        </p:txBody>
-      </p:sp>
-      <p:sp>
-        <p:nvSpPr>
-          <p:cNvPr id="28" name="TextBox 27"/>
-          <p:cNvSpPr txBox="1"/>
-          <p:nvPr/>
-        </p:nvSpPr>
-        <p:spPr>
-          <a:xfrm>
-            <a:off x="7223760" y="1609344"/>
-            <a:ext cx="4206240" cy="256032"/>
-          </a:xfrm>
-          <a:prstGeom prst="rect">
-            <a:avLst/>
-          </a:prstGeom>
-          <a:noFill/>
-        </p:spPr>
-        <p:txBody>
-          <a:bodyPr wrap="square">
-            <a:spAutoFit/>
-          </a:bodyPr>
-          <a:lstStyle/>
-          <a:p>
-            <a:pPr algn="l"/>
-            <a:r>
-              <a:rPr sz="1100" b="1" i="0">
-                <a:solidFill>
-                  <a:srgbClr val="FF6B6B"/>
-                </a:solidFill>
-              </a:rPr>
-              <a:t>Plan Critique (self-audit)</a:t>
-            </a:r>
-          </a:p>
-        </p:txBody>
-      </p:sp>
-      <p:sp>
-        <p:nvSpPr>
-          <p:cNvPr id="29" name="TextBox 28"/>
-          <p:cNvSpPr txBox="1"/>
-          <p:nvPr/>
-        </p:nvSpPr>
-        <p:spPr>
-          <a:xfrm>
-            <a:off x="7223760" y="1883664"/>
-            <a:ext cx="4206240" cy="438912"/>
-          </a:xfrm>
-          <a:prstGeom prst="rect">
-            <a:avLst/>
-          </a:prstGeom>
-          <a:noFill/>
-        </p:spPr>
-        <p:txBody>
-          <a:bodyPr wrap="square">
-            <a:spAutoFit/>
-          </a:bodyPr>
-          <a:lstStyle/>
-          <a:p>
-            <a:pPr algn="l"/>
-            <a:r>
-              <a:rPr sz="1000" b="0" i="0">
-                <a:solidFill>
-                  <a:srgbClr val="CCD6E0"/>
-                </a:solidFill>
-              </a:rPr>
-              <a:t>Second AI pass after every generation.
-6 categories: controls · statistics · sample size
-validation · safety · feasibility
-Rated: weak · needs_work · solid</a:t>
-            </a:r>
-          </a:p>
-        </p:txBody>
-      </p:sp>
-      <p:sp>
-        <p:nvSpPr>
-          <p:cNvPr id="30" name="Rectangle 29"/>
-          <p:cNvSpPr/>
-          <p:nvPr/>
-        </p:nvSpPr>
-        <p:spPr>
-          <a:xfrm>
-            <a:off x="7086600" y="2478024"/>
-            <a:ext cx="4526280" cy="841248"/>
-          </a:xfrm>
-          <a:prstGeom prst="rect">
-            <a:avLst/>
-          </a:prstGeom>
-          <a:solidFill>
-            <a:srgbClr val="0A1A28"/>
-          </a:solidFill>
-          <a:ln>
-            <a:noFill/>
-          </a:ln>
-        </p:spPr>
-        <p:style>
-          <a:lnRef idx="1">
-            <a:schemeClr val="accent1"/>
-          </a:lnRef>
-          <a:fillRef idx="3">
-            <a:schemeClr val="accent1"/>
-          </a:fillRef>
-          <a:effectRef idx="2">
-            <a:schemeClr val="accent1"/>
-          </a:effectRef>
-          <a:fontRef idx="minor">
-            <a:schemeClr val="lt1"/>
-          </a:fontRef>
-        </p:style>
-        <p:txBody>
-          <a:bodyPr rtlCol="0" anchor="ctr"/>
-          <a:lstStyle/>
-          <a:p>
-            <a:pPr algn="ctr"/>
-          </a:p>
-        </p:txBody>
-      </p:sp>
-      <p:sp>
-        <p:nvSpPr>
-          <p:cNvPr id="31" name="Rectangle 30"/>
-          <p:cNvSpPr/>
-          <p:nvPr/>
-        </p:nvSpPr>
-        <p:spPr>
-          <a:xfrm>
-            <a:off x="7086600" y="2478024"/>
-            <a:ext cx="4526280" cy="54864"/>
-          </a:xfrm>
-          <a:prstGeom prst="rect">
-            <a:avLst/>
-          </a:prstGeom>
-          <a:solidFill>
-            <a:srgbClr val="FFD600"/>
-          </a:solidFill>
-          <a:ln>
-            <a:noFill/>
-          </a:ln>
-        </p:spPr>
-        <p:style>
-          <a:lnRef idx="1">
-            <a:schemeClr val="accent1"/>
-          </a:lnRef>
-          <a:fillRef idx="3">
-            <a:schemeClr val="accent1"/>
-          </a:fillRef>
-          <a:effectRef idx="2">
-            <a:schemeClr val="accent1"/>
-          </a:effectRef>
-          <a:fontRef idx="minor">
-            <a:schemeClr val="lt1"/>
-          </a:fontRef>
-        </p:style>
-        <p:txBody>
-          <a:bodyPr rtlCol="0" anchor="ctr"/>
-          <a:lstStyle/>
-          <a:p>
-            <a:pPr algn="ctr"/>
-          </a:p>
-        </p:txBody>
-      </p:sp>
-      <p:sp>
-        <p:nvSpPr>
-          <p:cNvPr id="32" name="TextBox 31"/>
-          <p:cNvSpPr txBox="1"/>
-          <p:nvPr/>
-        </p:nvSpPr>
-        <p:spPr>
-          <a:xfrm>
-            <a:off x="7223760" y="2569464"/>
-            <a:ext cx="4206240" cy="256032"/>
-          </a:xfrm>
-          <a:prstGeom prst="rect">
-            <a:avLst/>
-          </a:prstGeom>
-          <a:noFill/>
-        </p:spPr>
-        <p:txBody>
-          <a:bodyPr wrap="square">
-            <a:spAutoFit/>
-          </a:bodyPr>
-          <a:lstStyle/>
-          <a:p>
-            <a:pPr algn="l"/>
-            <a:r>
-              <a:rPr sz="1100" b="1" i="0">
-                <a:solidFill>
-                  <a:srgbClr val="FFD600"/>
-                </a:solidFill>
-              </a:rPr>
-              <a:t>Multi-model redundancy</a:t>
-            </a:r>
-          </a:p>
-        </p:txBody>
-      </p:sp>
-      <p:sp>
-        <p:nvSpPr>
-          <p:cNvPr id="33" name="TextBox 32"/>
-          <p:cNvSpPr txBox="1"/>
-          <p:nvPr/>
-        </p:nvSpPr>
-        <p:spPr>
-          <a:xfrm>
-            <a:off x="7223760" y="2843784"/>
-            <a:ext cx="4206240" cy="438912"/>
-          </a:xfrm>
-          <a:prstGeom prst="rect">
-            <a:avLst/>
-          </a:prstGeom>
-          <a:noFill/>
-        </p:spPr>
-        <p:txBody>
-          <a:bodyPr wrap="square">
-            <a:spAutoFit/>
-          </a:bodyPr>
-          <a:lstStyle/>
-          <a:p>
-            <a:pPr algn="l"/>
-            <a:r>
-              <a:rPr sz="1000" b="0" i="0">
-                <a:solidFill>
-                  <a:srgbClr val="CCD6E0"/>
-                </a:solidFill>
-              </a:rPr>
-              <a:t>OpenAI GPT-4o · Google Gemini · Claude
-Heuristic fallback at every AI call
-System is fully functional with no API key</a:t>
-            </a:r>
-          </a:p>
-        </p:txBody>
-      </p:sp>
-      <p:sp>
-        <p:nvSpPr>
-          <p:cNvPr id="34" name="Rectangle 33"/>
-          <p:cNvSpPr/>
-          <p:nvPr/>
-        </p:nvSpPr>
-        <p:spPr>
-          <a:xfrm>
-            <a:off x="7086600" y="3438144"/>
-            <a:ext cx="4526280" cy="841248"/>
-          </a:xfrm>
-          <a:prstGeom prst="rect">
-            <a:avLst/>
-          </a:prstGeom>
-          <a:solidFill>
-            <a:srgbClr val="0A1A28"/>
-          </a:solidFill>
-          <a:ln>
-            <a:noFill/>
-          </a:ln>
-        </p:spPr>
-        <p:style>
-          <a:lnRef idx="1">
-            <a:schemeClr val="accent1"/>
-          </a:lnRef>
-          <a:fillRef idx="3">
-            <a:schemeClr val="accent1"/>
-          </a:fillRef>
-          <a:effectRef idx="2">
-            <a:schemeClr val="accent1"/>
-          </a:effectRef>
-          <a:fontRef idx="minor">
-            <a:schemeClr val="lt1"/>
-          </a:fontRef>
-        </p:style>
-        <p:txBody>
-          <a:bodyPr rtlCol="0" anchor="ctr"/>
-          <a:lstStyle/>
-          <a:p>
-            <a:pPr algn="ctr"/>
-          </a:p>
-        </p:txBody>
-      </p:sp>
-      <p:sp>
-        <p:nvSpPr>
-          <p:cNvPr id="35" name="Rectangle 34"/>
-          <p:cNvSpPr/>
-          <p:nvPr/>
-        </p:nvSpPr>
-        <p:spPr>
-          <a:xfrm>
-            <a:off x="7086600" y="3438144"/>
-            <a:ext cx="4526280" cy="54864"/>
-          </a:xfrm>
-          <a:prstGeom prst="rect">
-            <a:avLst/>
-          </a:prstGeom>
-          <a:solidFill>
-            <a:srgbClr val="00C2FF"/>
-          </a:solidFill>
-          <a:ln>
-            <a:noFill/>
-          </a:ln>
-        </p:spPr>
-        <p:style>
-          <a:lnRef idx="1">
-            <a:schemeClr val="accent1"/>
-          </a:lnRef>
-          <a:fillRef idx="3">
-            <a:schemeClr val="accent1"/>
-          </a:fillRef>
-          <a:effectRef idx="2">
-            <a:schemeClr val="accent1"/>
-          </a:effectRef>
-          <a:fontRef idx="minor">
-            <a:schemeClr val="lt1"/>
-          </a:fontRef>
-        </p:style>
-        <p:txBody>
-          <a:bodyPr rtlCol="0" anchor="ctr"/>
-          <a:lstStyle/>
-          <a:p>
-            <a:pPr algn="ctr"/>
-          </a:p>
-        </p:txBody>
-      </p:sp>
-      <p:sp>
-        <p:nvSpPr>
-          <p:cNvPr id="36" name="TextBox 35"/>
-          <p:cNvSpPr txBox="1"/>
-          <p:nvPr/>
-        </p:nvSpPr>
-        <p:spPr>
-          <a:xfrm>
-            <a:off x="7223760" y="3529584"/>
-            <a:ext cx="4206240" cy="256032"/>
-          </a:xfrm>
-          <a:prstGeom prst="rect">
-            <a:avLst/>
-          </a:prstGeom>
-          <a:noFill/>
-        </p:spPr>
-        <p:txBody>
-          <a:bodyPr wrap="square">
-            <a:spAutoFit/>
-          </a:bodyPr>
-          <a:lstStyle/>
-          <a:p>
-            <a:pPr algn="l"/>
-            <a:r>
-              <a:rPr sz="1100" b="1" i="0">
-                <a:solidFill>
-                  <a:srgbClr val="00C2FF"/>
-                </a:solidFill>
-              </a:rPr>
-              <a:t>Composite confidence score</a:t>
-            </a:r>
-          </a:p>
-        </p:txBody>
-      </p:sp>
-      <p:sp>
-        <p:nvSpPr>
-          <p:cNvPr id="37" name="TextBox 36"/>
-          <p:cNvSpPr txBox="1"/>
-          <p:nvPr/>
-        </p:nvSpPr>
-        <p:spPr>
-          <a:xfrm>
-            <a:off x="7223760" y="3803904"/>
-            <a:ext cx="4206240" cy="438912"/>
-          </a:xfrm>
-          <a:prstGeom prst="rect">
-            <a:avLst/>
-          </a:prstGeom>
-          <a:noFill/>
-        </p:spPr>
-        <p:txBody>
-          <a:bodyPr wrap="square">
-            <a:spAutoFit/>
-          </a:bodyPr>
-          <a:lstStyle/>
-          <a:p>
-            <a:pPr algn="l"/>
-            <a:r>
-              <a:rPr sz="1000" b="0" i="0">
-                <a:solidFill>
-                  <a:srgbClr val="CCD6E0"/>
-                </a:solidFill>
-              </a:rPr>
-              <a:t>Every plan scored: evidence quality
-supplier completeness · validation design
-feedback relevance — visible before ordering</a:t>
-            </a:r>
-          </a:p>
-        </p:txBody>
-      </p:sp>
-      <p:sp>
-        <p:nvSpPr>
-          <p:cNvPr id="38" name="Rectangle 37"/>
-          <p:cNvSpPr/>
-          <p:nvPr/>
-        </p:nvSpPr>
-        <p:spPr>
-          <a:xfrm>
-            <a:off x="7086600" y="4398264"/>
-            <a:ext cx="4526280" cy="841248"/>
-          </a:xfrm>
-          <a:prstGeom prst="rect">
-            <a:avLst/>
-          </a:prstGeom>
-          <a:solidFill>
-            <a:srgbClr val="0A1A28"/>
-          </a:solidFill>
-          <a:ln>
-            <a:noFill/>
-          </a:ln>
-        </p:spPr>
-        <p:style>
-          <a:lnRef idx="1">
-            <a:schemeClr val="accent1"/>
-          </a:lnRef>
-          <a:fillRef idx="3">
-            <a:schemeClr val="accent1"/>
-          </a:fillRef>
-          <a:effectRef idx="2">
-            <a:schemeClr val="accent1"/>
-          </a:effectRef>
-          <a:fontRef idx="minor">
-            <a:schemeClr val="lt1"/>
-          </a:fontRef>
-        </p:style>
-        <p:txBody>
-          <a:bodyPr rtlCol="0" anchor="ctr"/>
-          <a:lstStyle/>
-          <a:p>
-            <a:pPr algn="ctr"/>
-          </a:p>
-        </p:txBody>
-      </p:sp>
-      <p:sp>
-        <p:nvSpPr>
-          <p:cNvPr id="39" name="Rectangle 38"/>
-          <p:cNvSpPr/>
-          <p:nvPr/>
-        </p:nvSpPr>
-        <p:spPr>
-          <a:xfrm>
-            <a:off x="7086600" y="4398264"/>
-            <a:ext cx="4526280" cy="54864"/>
-          </a:xfrm>
-          <a:prstGeom prst="rect">
-            <a:avLst/>
-          </a:prstGeom>
-          <a:solidFill>
-            <a:srgbClr val="00E596"/>
-          </a:solidFill>
-          <a:ln>
-            <a:noFill/>
-          </a:ln>
-        </p:spPr>
-        <p:style>
-          <a:lnRef idx="1">
-            <a:schemeClr val="accent1"/>
-          </a:lnRef>
-          <a:fillRef idx="3">
-            <a:schemeClr val="accent1"/>
-          </a:fillRef>
-          <a:effectRef idx="2">
-            <a:schemeClr val="accent1"/>
-          </a:effectRef>
-          <a:fontRef idx="minor">
-            <a:schemeClr val="lt1"/>
-          </a:fontRef>
-        </p:style>
-        <p:txBody>
-          <a:bodyPr rtlCol="0" anchor="ctr"/>
-          <a:lstStyle/>
-          <a:p>
-            <a:pPr algn="ctr"/>
-          </a:p>
-        </p:txBody>
-      </p:sp>
-      <p:sp>
-        <p:nvSpPr>
-          <p:cNvPr id="40" name="TextBox 39"/>
-          <p:cNvSpPr txBox="1"/>
-          <p:nvPr/>
-        </p:nvSpPr>
-        <p:spPr>
-          <a:xfrm>
-            <a:off x="7223760" y="4489704"/>
-            <a:ext cx="4206240" cy="256032"/>
-          </a:xfrm>
-          <a:prstGeom prst="rect">
-            <a:avLst/>
-          </a:prstGeom>
-          <a:noFill/>
-        </p:spPr>
-        <p:txBody>
-          <a:bodyPr wrap="square">
-            <a:spAutoFit/>
-          </a:bodyPr>
-          <a:lstStyle/>
-          <a:p>
-            <a:pPr algn="l"/>
-            <a:r>
-              <a:rPr sz="1100" b="1" i="0">
-                <a:solidFill>
-                  <a:srgbClr val="00E596"/>
-                </a:solidFill>
-              </a:rPr>
-              <a:t>Literature grounding</a:t>
-            </a:r>
-          </a:p>
-        </p:txBody>
-      </p:sp>
-      <p:sp>
-        <p:nvSpPr>
-          <p:cNvPr id="41" name="TextBox 40"/>
-          <p:cNvSpPr txBox="1"/>
-          <p:nvPr/>
-        </p:nvSpPr>
-        <p:spPr>
-          <a:xfrm>
-            <a:off x="7223760" y="4764024"/>
-            <a:ext cx="4206240" cy="438912"/>
-          </a:xfrm>
-          <a:prstGeom prst="rect">
-            <a:avLst/>
-          </a:prstGeom>
-          <a:noFill/>
-        </p:spPr>
-        <p:txBody>
-          <a:bodyPr wrap="square">
-            <a:spAutoFit/>
-          </a:bodyPr>
-          <a:lstStyle/>
-          <a:p>
-            <a:pPr algn="l"/>
-            <a:r>
-              <a:rPr sz="1000" b="0" i="0">
-                <a:solidFill>
-                  <a:srgbClr val="CCD6E0"/>
-                </a:solidFill>
-              </a:rPr>
-              <a:t>Plans grounded in 6-source literature QC
-Nov­elty classified with confidence score
-No hallucinated catalog numbers — Tavily-verified</a:t>
-            </a:r>
-          </a:p>
-        </p:txBody>
-      </p:sp>
-      <p:sp>
-        <p:nvSpPr>
-          <p:cNvPr id="42" name="Rectangle 41"/>
-          <p:cNvSpPr/>
-          <p:nvPr/>
-        </p:nvSpPr>
-        <p:spPr>
-          <a:xfrm>
-            <a:off x="0" y="5577840"/>
-            <a:ext cx="12188952" cy="1188720"/>
-          </a:xfrm>
-          <a:prstGeom prst="rect">
-            <a:avLst/>
-          </a:prstGeom>
-          <a:solidFill>
-            <a:srgbClr val="05121E"/>
-          </a:solidFill>
-          <a:ln>
-            <a:noFill/>
-          </a:ln>
-        </p:spPr>
-        <p:style>
-          <a:lnRef idx="1">
-            <a:schemeClr val="accent1"/>
-          </a:lnRef>
-          <a:fillRef idx="3">
-            <a:schemeClr val="accent1"/>
-          </a:fillRef>
-          <a:effectRef idx="2">
-            <a:schemeClr val="accent1"/>
-          </a:effectRef>
-          <a:fontRef idx="minor">
-            <a:schemeClr val="lt1"/>
-          </a:fontRef>
-        </p:style>
-        <p:txBody>
-          <a:bodyPr rtlCol="0" anchor="ctr"/>
-          <a:lstStyle/>
-          <a:p>
-            <a:pPr algn="ctr"/>
-          </a:p>
-        </p:txBody>
-      </p:sp>
-      <p:sp>
-        <p:nvSpPr>
-          <p:cNvPr id="43" name="Rectangle 42"/>
-          <p:cNvSpPr/>
-          <p:nvPr/>
-        </p:nvSpPr>
-        <p:spPr>
-          <a:xfrm>
-            <a:off x="0" y="5577840"/>
-            <a:ext cx="12188952" cy="54864"/>
-          </a:xfrm>
-          <a:prstGeom prst="rect">
-            <a:avLst/>
-          </a:prstGeom>
-          <a:solidFill>
-            <a:srgbClr val="00C2FF"/>
-          </a:solidFill>
-          <a:ln>
-            <a:noFill/>
-          </a:ln>
-        </p:spPr>
-        <p:style>
-          <a:lnRef idx="1">
-            <a:schemeClr val="accent1"/>
-          </a:lnRef>
-          <a:fillRef idx="3">
-            <a:schemeClr val="accent1"/>
-          </a:fillRef>
-          <a:effectRef idx="2">
-            <a:schemeClr val="accent1"/>
-          </a:effectRef>
-          <a:fontRef idx="minor">
-            <a:schemeClr val="lt1"/>
-          </a:fontRef>
-        </p:style>
-        <p:txBody>
-          <a:bodyPr rtlCol="0" anchor="ctr"/>
-          <a:lstStyle/>
-          <a:p>
-            <a:pPr algn="ctr"/>
-          </a:p>
-        </p:txBody>
-      </p:sp>
-      <p:sp>
-        <p:nvSpPr>
-          <p:cNvPr id="44" name="TextBox 43"/>
-          <p:cNvSpPr txBox="1"/>
-          <p:nvPr/>
-        </p:nvSpPr>
-        <p:spPr>
-          <a:xfrm>
-            <a:off x="457200" y="5650992"/>
-            <a:ext cx="11247120" cy="292608"/>
-          </a:xfrm>
-          <a:prstGeom prst="rect">
-            <a:avLst/>
-          </a:prstGeom>
-          <a:noFill/>
-        </p:spPr>
-        <p:txBody>
-          <a:bodyPr wrap="square">
-            <a:spAutoFit/>
-          </a:bodyPr>
-          <a:lstStyle/>
-          <a:p>
-            <a:pPr algn="ctr"/>
-            <a:r>
-              <a:rPr sz="1300" b="1" i="0">
-                <a:solidFill>
-                  <a:srgbClr val="00C2FF"/>
-                </a:solidFill>
-              </a:rPr>
-              <a:t>CONTACT US FOR MORE QUESTIONS</a:t>
-            </a:r>
-          </a:p>
-        </p:txBody>
-      </p:sp>
-      <p:sp>
-        <p:nvSpPr>
-          <p:cNvPr id="45" name="TextBox 44"/>
-          <p:cNvSpPr txBox="1"/>
-          <p:nvPr/>
-        </p:nvSpPr>
-        <p:spPr>
-          <a:xfrm>
-            <a:off x="411480" y="5998464"/>
-            <a:ext cx="2834640" cy="256032"/>
-          </a:xfrm>
-          <a:prstGeom prst="rect">
-            <a:avLst/>
-          </a:prstGeom>
-          <a:noFill/>
-        </p:spPr>
-        <p:txBody>
-          <a:bodyPr wrap="square">
-            <a:spAutoFit/>
-          </a:bodyPr>
-          <a:lstStyle/>
-          <a:p>
-            <a:pPr algn="l"/>
-            <a:r>
-              <a:rPr sz="1100" b="1" i="0">
-                <a:solidFill>
-                  <a:srgbClr val="FFFFFF"/>
-                </a:solidFill>
-              </a:rPr>
-              <a:t>Samuel Hajek</a:t>
-            </a:r>
-          </a:p>
-        </p:txBody>
-      </p:sp>
-      <p:sp>
-        <p:nvSpPr>
-          <p:cNvPr id="46" name="TextBox 45"/>
-          <p:cNvSpPr txBox="1"/>
-          <p:nvPr/>
-        </p:nvSpPr>
-        <p:spPr>
-          <a:xfrm>
-            <a:off x="411480" y="6254496"/>
-            <a:ext cx="2834640" cy="237744"/>
-          </a:xfrm>
-          <a:prstGeom prst="rect">
-            <a:avLst/>
-          </a:prstGeom>
-          <a:noFill/>
-        </p:spPr>
-        <p:txBody>
-          <a:bodyPr wrap="square">
-            <a:spAutoFit/>
-          </a:bodyPr>
-          <a:lstStyle/>
-          <a:p>
-            <a:pPr algn="l"/>
-            <a:r>
-              <a:rPr sz="1000" b="0" i="1">
-                <a:solidFill>
-                  <a:srgbClr val="00C2FF"/>
-                </a:solidFill>
-              </a:rPr>
-              <a:t>samuel.hajek@gmail.com</a:t>
-            </a:r>
-          </a:p>
-        </p:txBody>
-      </p:sp>
-      <p:sp>
-        <p:nvSpPr>
-          <p:cNvPr id="47" name="TextBox 46"/>
-          <p:cNvSpPr txBox="1"/>
-          <p:nvPr/>
-        </p:nvSpPr>
-        <p:spPr>
-          <a:xfrm>
-            <a:off x="3355848" y="5998464"/>
-            <a:ext cx="2834640" cy="256032"/>
-          </a:xfrm>
-          <a:prstGeom prst="rect">
-            <a:avLst/>
-          </a:prstGeom>
-          <a:noFill/>
-        </p:spPr>
-        <p:txBody>
-          <a:bodyPr wrap="square">
-            <a:spAutoFit/>
-          </a:bodyPr>
-          <a:lstStyle/>
-          <a:p>
-            <a:pPr algn="l"/>
-            <a:r>
-              <a:rPr sz="1100" b="1" i="0">
-                <a:solidFill>
-                  <a:srgbClr val="FFFFFF"/>
-                </a:solidFill>
-              </a:rPr>
-              <a:t>Johannes Wagner</a:t>
-            </a:r>
-          </a:p>
-        </p:txBody>
-      </p:sp>
-      <p:sp>
-        <p:nvSpPr>
-          <p:cNvPr id="48" name="TextBox 47"/>
-          <p:cNvSpPr txBox="1"/>
-          <p:nvPr/>
-        </p:nvSpPr>
-        <p:spPr>
-          <a:xfrm>
-            <a:off x="3355848" y="6254496"/>
-            <a:ext cx="2834640" cy="237744"/>
-          </a:xfrm>
-          <a:prstGeom prst="rect">
-            <a:avLst/>
-          </a:prstGeom>
-          <a:noFill/>
-        </p:spPr>
-        <p:txBody>
-          <a:bodyPr wrap="square">
-            <a:spAutoFit/>
-          </a:bodyPr>
-          <a:lstStyle/>
-          <a:p>
-            <a:pPr algn="l"/>
-            <a:r>
-              <a:rPr sz="1000" b="0" i="1">
-                <a:solidFill>
-                  <a:srgbClr val="00C2FF"/>
-                </a:solidFill>
-              </a:rPr>
-              <a:t>johannes.wagner@alumni.tugraz.at</a:t>
-            </a:r>
-          </a:p>
-        </p:txBody>
-      </p:sp>
-      <p:sp>
-        <p:nvSpPr>
-          <p:cNvPr id="49" name="TextBox 48"/>
-          <p:cNvSpPr txBox="1"/>
-          <p:nvPr/>
-        </p:nvSpPr>
-        <p:spPr>
-          <a:xfrm>
-            <a:off x="6300216" y="5998464"/>
-            <a:ext cx="2834640" cy="256032"/>
-          </a:xfrm>
-          <a:prstGeom prst="rect">
-            <a:avLst/>
-          </a:prstGeom>
-          <a:noFill/>
-        </p:spPr>
-        <p:txBody>
-          <a:bodyPr wrap="square">
-            <a:spAutoFit/>
-          </a:bodyPr>
-          <a:lstStyle/>
-          <a:p>
-            <a:pPr algn="l"/>
-            <a:r>
-              <a:rPr sz="1100" b="1" i="0">
-                <a:solidFill>
-                  <a:srgbClr val="FFFFFF"/>
-                </a:solidFill>
-              </a:rPr>
-              <a:t>Felix Scope</a:t>
-            </a:r>
-          </a:p>
-        </p:txBody>
-      </p:sp>
-      <p:sp>
-        <p:nvSpPr>
-          <p:cNvPr id="50" name="TextBox 49"/>
-          <p:cNvSpPr txBox="1"/>
-          <p:nvPr/>
-        </p:nvSpPr>
-        <p:spPr>
-          <a:xfrm>
-            <a:off x="6300216" y="6254496"/>
-            <a:ext cx="2834640" cy="237744"/>
-          </a:xfrm>
-          <a:prstGeom prst="rect">
-            <a:avLst/>
-          </a:prstGeom>
-          <a:noFill/>
-        </p:spPr>
-        <p:txBody>
-          <a:bodyPr wrap="square">
-            <a:spAutoFit/>
-          </a:bodyPr>
-          <a:lstStyle/>
-          <a:p>
-            <a:pPr algn="l"/>
-            <a:r>
-              <a:rPr sz="1000" b="0" i="1">
-                <a:solidFill>
-                  <a:srgbClr val="00C2FF"/>
-                </a:solidFill>
-              </a:rPr>
-              <a:t>scope@tugraz.at</a:t>
-            </a:r>
-          </a:p>
-        </p:txBody>
-      </p:sp>
-      <p:sp>
-        <p:nvSpPr>
-          <p:cNvPr id="51" name="TextBox 50"/>
-          <p:cNvSpPr txBox="1"/>
-          <p:nvPr/>
-        </p:nvSpPr>
-        <p:spPr>
-          <a:xfrm>
-            <a:off x="9244584" y="5998464"/>
-            <a:ext cx="2834640" cy="256032"/>
-          </a:xfrm>
-          <a:prstGeom prst="rect">
-            <a:avLst/>
-          </a:prstGeom>
-          <a:noFill/>
-        </p:spPr>
-        <p:txBody>
-          <a:bodyPr wrap="square">
-            <a:spAutoFit/>
-          </a:bodyPr>
-          <a:lstStyle/>
-          <a:p>
-            <a:pPr algn="l"/>
-            <a:r>
-              <a:rPr sz="1100" b="1" i="0">
-                <a:solidFill>
-                  <a:srgbClr val="FFFFFF"/>
-                </a:solidFill>
-              </a:rPr>
-              <a:t>Georg Niess</a:t>
-            </a:r>
-          </a:p>
-        </p:txBody>
-      </p:sp>
-      <p:sp>
-        <p:nvSpPr>
-          <p:cNvPr id="52" name="TextBox 51"/>
-          <p:cNvSpPr txBox="1"/>
-          <p:nvPr/>
-        </p:nvSpPr>
-        <p:spPr>
-          <a:xfrm>
-            <a:off x="9244584" y="6254496"/>
-            <a:ext cx="2834640" cy="237744"/>
-          </a:xfrm>
-          <a:prstGeom prst="rect">
-            <a:avLst/>
-          </a:prstGeom>
-          <a:noFill/>
-        </p:spPr>
-        <p:txBody>
-          <a:bodyPr wrap="square">
-            <a:spAutoFit/>
-          </a:bodyPr>
-          <a:lstStyle/>
-          <a:p>
-            <a:pPr algn="l"/>
-            <a:r>
-              <a:rPr sz="1000" b="0" i="1">
-                <a:solidFill>
-                  <a:srgbClr val="00C2FF"/>
-                </a:solidFill>
-              </a:rPr>
-              <a:t>georg.niess@tugraz.at</a:t>
+              <a:t>Under the hood:  scientist correction  →  AI classifies bucket  →  Gemini 768-dim embedding  →  Supabase pgvector (HNSW index)  →  match_experiments() cosine search  →  injected as labelled block into next plan  ·  ~1,600 rules pre-seeded</a:t>
             </a:r>
           </a:p>
         </p:txBody>

</xml_diff>